<commit_message>
Add authentic iQOO interface and visually impaired accessibility photos to deck and web app
</commit_message>
<xml_diff>
--- a/Drishti_Pitch_Deck.pptx
+++ b/Drishti_Pitch_Deck.pptx
@@ -3146,8 +3146,8 @@
         </p:nvSpPr>
         <p:spPr>
           <a:xfrm>
-            <a:off x="822960" y="1097280"/>
-            <a:ext cx="5852160" cy="438912"/>
+            <a:off x="731520" y="777240"/>
+            <a:ext cx="5303520" cy="384048"/>
           </a:xfrm>
           <a:prstGeom prst="roundRect">
             <a:avLst/>
@@ -3180,7 +3180,7 @@
           <a:lstStyle/>
           <a:p>
             <a:pPr algn="ctr">
-              <a:defRPr sz="1000" b="1">
+              <a:defRPr sz="950" b="1">
                 <a:solidFill>
                   <a:srgbClr val="FFD700"/>
                 </a:solidFill>
@@ -3200,8 +3200,8 @@
         </p:nvSpPr>
         <p:spPr>
           <a:xfrm>
-            <a:off x="822960" y="1737360"/>
-            <a:ext cx="10515600" cy="1463040"/>
+            <a:off x="731520" y="1280160"/>
+            <a:ext cx="5943600" cy="1371600"/>
           </a:xfrm>
           <a:prstGeom prst="rect">
             <a:avLst/>
@@ -3215,7 +3215,7 @@
           <a:lstStyle/>
           <a:p>
             <a:pPr>
-              <a:defRPr sz="6400" b="1">
+              <a:defRPr sz="5600" b="1">
                 <a:solidFill>
                   <a:srgbClr val="FFFFFF"/>
                 </a:solidFill>
@@ -3230,14 +3230,14 @@
               <a:spcBef>
                 <a:spcPts val="400"/>
               </a:spcBef>
-              <a:defRPr sz="1800">
+              <a:defRPr sz="1700">
                 <a:solidFill>
                   <a:srgbClr val="FFD700"/>
                 </a:solidFill>
               </a:defRPr>
             </a:pPr>
             <a:r>
-              <a:t>दृष्टि  •  Phone-First On-Device AI Sensory Companion</a:t>
+              <a:t>दृष्टि  •  On-Device Sensory Companion</a:t>
             </a:r>
           </a:p>
         </p:txBody>
@@ -3250,8 +3250,8 @@
         </p:nvSpPr>
         <p:spPr>
           <a:xfrm>
-            <a:off x="822960" y="3566160"/>
-            <a:ext cx="10515600" cy="1188720"/>
+            <a:off x="731520" y="2926080"/>
+            <a:ext cx="6035040" cy="1280160"/>
           </a:xfrm>
           <a:prstGeom prst="roundRect">
             <a:avLst/>
@@ -3280,11 +3280,11 @@
           </a:fontRef>
         </p:style>
         <p:txBody>
-          <a:bodyPr rtlCol="0" anchor="ctr" lIns="365760" tIns="256032"/>
+          <a:bodyPr rtlCol="0" anchor="ctr" lIns="274320" tIns="228600"/>
           <a:lstStyle/>
           <a:p>
             <a:pPr algn="ctr">
-              <a:defRPr sz="1900" b="1">
+              <a:defRPr sz="1700" b="1">
                 <a:solidFill>
                   <a:srgbClr val="FFF0B4"/>
                 </a:solidFill>
@@ -3304,8 +3304,8 @@
         </p:nvSpPr>
         <p:spPr>
           <a:xfrm>
-            <a:off x="822960" y="5074920"/>
-            <a:ext cx="2542032" cy="1097280"/>
+            <a:off x="731520" y="4434840"/>
+            <a:ext cx="2926080" cy="868680"/>
           </a:xfrm>
           <a:prstGeom prst="roundRect">
             <a:avLst/>
@@ -3334,23 +3334,23 @@
           </a:fontRef>
         </p:style>
         <p:txBody>
-          <a:bodyPr rtlCol="0" anchor="ctr" tIns="228600"/>
+          <a:bodyPr rtlCol="0" anchor="ctr" tIns="164592"/>
           <a:lstStyle/>
           <a:p>
             <a:pPr algn="ctr">
-              <a:defRPr sz="1400" b="1">
+              <a:defRPr sz="1200" b="1">
                 <a:solidFill>
                   <a:srgbClr val="FFD700"/>
                 </a:solidFill>
               </a:defRPr>
             </a:pPr>
             <a:r>
-              <a:t>Instant Reaction</a:t>
-            </a:r>
-          </a:p>
-          <a:p>
-            <a:pPr algn="ctr">
-              <a:defRPr sz="1000">
+              <a:t>⚡ Instant Reaction</a:t>
+            </a:r>
+          </a:p>
+          <a:p>
+            <a:pPr>
+              <a:defRPr sz="950">
                 <a:solidFill>
                   <a:srgbClr val="AAB2C8"/>
                 </a:solidFill>
@@ -3370,8 +3370,8 @@
         </p:nvSpPr>
         <p:spPr>
           <a:xfrm>
-            <a:off x="3493008" y="5074920"/>
-            <a:ext cx="2542032" cy="1097280"/>
+            <a:off x="3794760" y="4434840"/>
+            <a:ext cx="2926080" cy="868680"/>
           </a:xfrm>
           <a:prstGeom prst="roundRect">
             <a:avLst/>
@@ -3400,30 +3400,30 @@
           </a:fontRef>
         </p:style>
         <p:txBody>
-          <a:bodyPr rtlCol="0" anchor="ctr" tIns="228600"/>
+          <a:bodyPr rtlCol="0" anchor="ctr" tIns="164592"/>
           <a:lstStyle/>
           <a:p>
             <a:pPr algn="ctr">
-              <a:defRPr sz="1400" b="1">
+              <a:defRPr sz="1200" b="1">
                 <a:solidFill>
                   <a:srgbClr val="FFD700"/>
                 </a:solidFill>
               </a:defRPr>
             </a:pPr>
             <a:r>
-              <a:t>100% Private</a:t>
-            </a:r>
-          </a:p>
-          <a:p>
-            <a:pPr algn="ctr">
-              <a:defRPr sz="1000">
+              <a:t>🔒 100% Private</a:t>
+            </a:r>
+          </a:p>
+          <a:p>
+            <a:pPr>
+              <a:defRPr sz="950">
                 <a:solidFill>
                   <a:srgbClr val="AAB2C8"/>
                 </a:solidFill>
               </a:defRPr>
             </a:pPr>
             <a:r>
-              <a:t>No video leaves device</a:t>
+              <a:t>Zero video leaves device</a:t>
             </a:r>
           </a:p>
         </p:txBody>
@@ -3436,8 +3436,8 @@
         </p:nvSpPr>
         <p:spPr>
           <a:xfrm>
-            <a:off x="6163056" y="5074920"/>
-            <a:ext cx="2542032" cy="1097280"/>
+            <a:off x="731520" y="5440679"/>
+            <a:ext cx="2926080" cy="868680"/>
           </a:xfrm>
           <a:prstGeom prst="roundRect">
             <a:avLst/>
@@ -3466,23 +3466,23 @@
           </a:fontRef>
         </p:style>
         <p:txBody>
-          <a:bodyPr rtlCol="0" anchor="ctr" tIns="228600"/>
+          <a:bodyPr rtlCol="0" anchor="ctr" tIns="164592"/>
           <a:lstStyle/>
           <a:p>
             <a:pPr algn="ctr">
-              <a:defRPr sz="1400" b="1">
+              <a:defRPr sz="1200" b="1">
                 <a:solidFill>
                   <a:srgbClr val="FFD700"/>
                 </a:solidFill>
               </a:defRPr>
             </a:pPr>
             <a:r>
-              <a:t>Fully Offline</a:t>
-            </a:r>
-          </a:p>
-          <a:p>
-            <a:pPr algn="ctr">
-              <a:defRPr sz="1000">
+              <a:t>✈️ Fully Offline</a:t>
+            </a:r>
+          </a:p>
+          <a:p>
+            <a:pPr>
+              <a:defRPr sz="950">
                 <a:solidFill>
                   <a:srgbClr val="AAB2C8"/>
                 </a:solidFill>
@@ -3502,8 +3502,8 @@
         </p:nvSpPr>
         <p:spPr>
           <a:xfrm>
-            <a:off x="8833104" y="5074920"/>
-            <a:ext cx="2542032" cy="1097280"/>
+            <a:off x="3794760" y="5440679"/>
+            <a:ext cx="2926080" cy="868680"/>
           </a:xfrm>
           <a:prstGeom prst="roundRect">
             <a:avLst/>
@@ -3532,30 +3532,134 @@
           </a:fontRef>
         </p:style>
         <p:txBody>
-          <a:bodyPr rtlCol="0" anchor="ctr" tIns="228600"/>
+          <a:bodyPr rtlCol="0" anchor="ctr" tIns="164592"/>
           <a:lstStyle/>
           <a:p>
             <a:pPr algn="ctr">
-              <a:defRPr sz="1400" b="1">
+              <a:defRPr sz="1200" b="1">
                 <a:solidFill>
                   <a:srgbClr val="FFD700"/>
                 </a:solidFill>
               </a:defRPr>
             </a:pPr>
             <a:r>
-              <a:t>Smart Living</a:t>
-            </a:r>
-          </a:p>
+              <a:t>🏠 Smart Living</a:t>
+            </a:r>
+          </a:p>
+          <a:p>
+            <a:pPr>
+              <a:defRPr sz="950">
+                <a:solidFill>
+                  <a:srgbClr val="AAB2C8"/>
+                </a:solidFill>
+              </a:defRPr>
+            </a:pPr>
+            <a:r>
+              <a:t>Real daily independence</a:t>
+            </a:r>
+          </a:p>
+        </p:txBody>
+      </p:sp>
+      <p:sp>
+        <p:nvSpPr>
+          <p:cNvPr id="10" name="Rounded Rectangle 9"/>
+          <p:cNvSpPr/>
+          <p:nvPr/>
+        </p:nvSpPr>
+        <p:spPr>
+          <a:xfrm>
+            <a:off x="7040880" y="777240"/>
+            <a:ext cx="4389120" cy="5440680"/>
+          </a:xfrm>
+          <a:prstGeom prst="roundRect">
+            <a:avLst/>
+          </a:prstGeom>
+          <a:solidFill>
+            <a:srgbClr val="121520"/>
+          </a:solidFill>
+          <a:ln w="15240">
+            <a:solidFill>
+              <a:srgbClr val="2A3046"/>
+            </a:solidFill>
+          </a:ln>
+        </p:spPr>
+        <p:style>
+          <a:lnRef idx="1">
+            <a:schemeClr val="accent1"/>
+          </a:lnRef>
+          <a:fillRef idx="3">
+            <a:schemeClr val="accent1"/>
+          </a:fillRef>
+          <a:effectRef idx="2">
+            <a:schemeClr val="accent1"/>
+          </a:effectRef>
+          <a:fontRef idx="minor">
+            <a:schemeClr val="lt1"/>
+          </a:fontRef>
+        </p:style>
+        <p:txBody>
+          <a:bodyPr rtlCol="0" anchor="ctr"/>
+          <a:lstStyle/>
+          <a:p>
+            <a:pPr algn="ctr"/>
+          </a:p>
+        </p:txBody>
+      </p:sp>
+      <p:pic>
+        <p:nvPicPr>
+          <p:cNvPr id="11" name="Picture 10" descr="iqoo-spatial-hallway.jpg"/>
+          <p:cNvPicPr>
+            <a:picLocks noChangeAspect="1"/>
+          </p:cNvPicPr>
+          <p:nvPr/>
+        </p:nvPicPr>
+        <p:blipFill>
+          <a:blip r:embed="rId2"/>
+          <a:stretch>
+            <a:fillRect/>
+          </a:stretch>
+        </p:blipFill>
+        <p:spPr>
+          <a:xfrm>
+            <a:off x="7114032" y="850392"/>
+            <a:ext cx="4242816" cy="4846320"/>
+          </a:xfrm>
+          <a:prstGeom prst="rect">
+            <a:avLst/>
+          </a:prstGeom>
+        </p:spPr>
+      </p:pic>
+      <p:sp>
+        <p:nvSpPr>
+          <p:cNvPr id="12" name="TextBox 11"/>
+          <p:cNvSpPr txBox="1"/>
+          <p:nvPr/>
+        </p:nvSpPr>
+        <p:spPr>
+          <a:xfrm>
+            <a:off x="7178040" y="5715000"/>
+            <a:ext cx="4114800" cy="457200"/>
+          </a:xfrm>
+          <a:prstGeom prst="rect">
+            <a:avLst/>
+          </a:prstGeom>
+          <a:noFill/>
+        </p:spPr>
+        <p:txBody>
+          <a:bodyPr wrap="square">
+            <a:spAutoFit/>
+          </a:bodyPr>
+          <a:lstStyle/>
           <a:p>
             <a:pPr algn="ctr">
-              <a:defRPr sz="1000">
-                <a:solidFill>
-                  <a:srgbClr val="AAB2C8"/>
-                </a:solidFill>
-              </a:defRPr>
-            </a:pPr>
-            <a:r>
-              <a:t>Everyday independence</a:t>
+              <a:defRPr sz="950" b="1">
+                <a:solidFill>
+                  <a:srgbClr val="FFD700"/>
+                </a:solidFill>
+              </a:defRPr>
+            </a:pPr>
+            <a:r>
+              <a:t>iQOO On-Device Spatial Guidance HUD (Hallway Navigation)</a:t>
             </a:r>
           </a:p>
         </p:txBody>
@@ -3629,8 +3733,8 @@
         </p:nvSpPr>
         <p:spPr>
           <a:xfrm>
-            <a:off x="822960" y="411480"/>
-            <a:ext cx="9144000" cy="320040"/>
+            <a:off x="731520" y="365760"/>
+            <a:ext cx="10515600" cy="320040"/>
           </a:xfrm>
           <a:prstGeom prst="rect">
             <a:avLst/>
@@ -3664,8 +3768,8 @@
         </p:nvSpPr>
         <p:spPr>
           <a:xfrm>
-            <a:off x="822960" y="685800"/>
-            <a:ext cx="10515600" cy="731520"/>
+            <a:off x="731520" y="640080"/>
+            <a:ext cx="10515600" cy="685800"/>
           </a:xfrm>
           <a:prstGeom prst="rect">
             <a:avLst/>
@@ -3679,7 +3783,7 @@
           <a:lstStyle/>
           <a:p>
             <a:pPr>
-              <a:defRPr sz="2800" b="1">
+              <a:defRPr sz="2600" b="1">
                 <a:solidFill>
                   <a:srgbClr val="FFFFFF"/>
                 </a:solidFill>
@@ -3699,7 +3803,7 @@
         </p:nvSpPr>
         <p:spPr>
           <a:xfrm>
-            <a:off x="822960" y="1325880"/>
+            <a:off x="731520" y="1234440"/>
             <a:ext cx="10515600" cy="411480"/>
           </a:xfrm>
           <a:prstGeom prst="rect">
@@ -3714,7 +3818,7 @@
           <a:lstStyle/>
           <a:p>
             <a:pPr>
-              <a:defRPr sz="1300">
+              <a:defRPr sz="1200">
                 <a:solidFill>
                   <a:srgbClr val="AAB2C8"/>
                 </a:solidFill>
@@ -3734,8 +3838,112 @@
         </p:nvSpPr>
         <p:spPr>
           <a:xfrm>
-            <a:off x="822960" y="1920240"/>
-            <a:ext cx="3364992" cy="4297680"/>
+            <a:off x="731520" y="1783080"/>
+            <a:ext cx="3931920" cy="4526280"/>
+          </a:xfrm>
+          <a:prstGeom prst="roundRect">
+            <a:avLst/>
+          </a:prstGeom>
+          <a:solidFill>
+            <a:srgbClr val="121520"/>
+          </a:solidFill>
+          <a:ln w="15240">
+            <a:solidFill>
+              <a:srgbClr val="2A3046"/>
+            </a:solidFill>
+          </a:ln>
+        </p:spPr>
+        <p:style>
+          <a:lnRef idx="1">
+            <a:schemeClr val="accent1"/>
+          </a:lnRef>
+          <a:fillRef idx="3">
+            <a:schemeClr val="accent1"/>
+          </a:fillRef>
+          <a:effectRef idx="2">
+            <a:schemeClr val="accent1"/>
+          </a:effectRef>
+          <a:fontRef idx="minor">
+            <a:schemeClr val="lt1"/>
+          </a:fontRef>
+        </p:style>
+        <p:txBody>
+          <a:bodyPr rtlCol="0" anchor="ctr"/>
+          <a:lstStyle/>
+          <a:p>
+            <a:pPr algn="ctr"/>
+          </a:p>
+        </p:txBody>
+      </p:sp>
+      <p:pic>
+        <p:nvPicPr>
+          <p:cNvPr id="7" name="Picture 6" descr="visually-impaired-nav.jpg"/>
+          <p:cNvPicPr>
+            <a:picLocks noChangeAspect="1"/>
+          </p:cNvPicPr>
+          <p:nvPr/>
+        </p:nvPicPr>
+        <p:blipFill>
+          <a:blip r:embed="rId2"/>
+          <a:stretch>
+            <a:fillRect/>
+          </a:stretch>
+        </p:blipFill>
+        <p:spPr>
+          <a:xfrm>
+            <a:off x="804672" y="1856232"/>
+            <a:ext cx="3785616" cy="3931920"/>
+          </a:xfrm>
+          <a:prstGeom prst="rect">
+            <a:avLst/>
+          </a:prstGeom>
+        </p:spPr>
+      </p:pic>
+      <p:sp>
+        <p:nvSpPr>
+          <p:cNvPr id="8" name="TextBox 7"/>
+          <p:cNvSpPr txBox="1"/>
+          <p:nvPr/>
+        </p:nvSpPr>
+        <p:spPr>
+          <a:xfrm>
+            <a:off x="868680" y="5806440"/>
+            <a:ext cx="3657600" cy="457200"/>
+          </a:xfrm>
+          <a:prstGeom prst="rect">
+            <a:avLst/>
+          </a:prstGeom>
+          <a:noFill/>
+        </p:spPr>
+        <p:txBody>
+          <a:bodyPr wrap="square">
+            <a:spAutoFit/>
+          </a:bodyPr>
+          <a:lstStyle/>
+          <a:p>
+            <a:pPr algn="ctr">
+              <a:defRPr sz="950" b="1">
+                <a:solidFill>
+                  <a:srgbClr val="FFD700"/>
+                </a:solidFill>
+              </a:defRPr>
+            </a:pPr>
+            <a:r>
+              <a:t>40M+ visually impaired in India face dangerous cloud latency &amp; privacy loss</a:t>
+            </a:r>
+          </a:p>
+        </p:txBody>
+      </p:sp>
+      <p:sp>
+        <p:nvSpPr>
+          <p:cNvPr id="9" name="Rounded Rectangle 8"/>
+          <p:cNvSpPr/>
+          <p:nvPr/>
+        </p:nvSpPr>
+        <p:spPr>
+          <a:xfrm>
+            <a:off x="4846320" y="1783080"/>
+            <a:ext cx="6675120" cy="1371600"/>
           </a:xfrm>
           <a:prstGeom prst="roundRect">
             <a:avLst/>
@@ -3764,11 +3972,11 @@
           </a:fontRef>
         </p:style>
         <p:txBody>
-          <a:bodyPr rtlCol="0" anchor="ctr" wrap="square" lIns="274320" rIns="274320" tIns="256032" bIns="228600"/>
+          <a:bodyPr rtlCol="0" anchor="ctr" wrap="square" lIns="228600" rIns="228600" tIns="201168" bIns="182880"/>
           <a:lstStyle/>
           <a:p>
             <a:pPr algn="ctr">
-              <a:defRPr sz="900" b="1">
+              <a:defRPr sz="850" b="1">
                 <a:solidFill>
                   <a:srgbClr val="F87171"/>
                 </a:solidFill>
@@ -3781,9 +3989,9 @@
           <a:p>
             <a:pPr>
               <a:spcAft>
-                <a:spcPts val="800"/>
+                <a:spcPts val="600"/>
               </a:spcAft>
-              <a:defRPr sz="1600" b="1">
+              <a:defRPr sz="1400" b="1">
                 <a:solidFill>
                   <a:srgbClr val="FFFFFF"/>
                 </a:solidFill>
@@ -3796,24 +4004,24 @@
           <a:p>
             <a:pPr>
               <a:spcAft>
-                <a:spcPts val="400"/>
+                <a:spcPts val="300"/>
               </a:spcAft>
-              <a:defRPr sz="1100">
+              <a:defRPr sz="1000">
                 <a:solidFill>
                   <a:srgbClr val="AAB2C8"/>
                 </a:solidFill>
               </a:defRPr>
             </a:pPr>
             <a:r>
-              <a:t>•  Cloud vision APIs require 2 to 5 seconds per inference.</a:t>
+              <a:t>•  Cloud vision APIs take 2 to 5 seconds per request.</a:t>
             </a:r>
           </a:p>
           <a:p>
             <a:pPr>
               <a:spcAft>
-                <a:spcPts val="400"/>
+                <a:spcPts val="300"/>
               </a:spcAft>
-              <a:defRPr sz="1100">
+              <a:defRPr sz="1000">
                 <a:solidFill>
                   <a:srgbClr val="AAB2C8"/>
                 </a:solidFill>
@@ -3826,45 +4034,30 @@
           <a:p>
             <a:pPr>
               <a:spcAft>
-                <a:spcPts val="400"/>
+                <a:spcPts val="300"/>
               </a:spcAft>
-              <a:defRPr sz="1100">
+              <a:defRPr sz="1000">
                 <a:solidFill>
                   <a:srgbClr val="AAB2C8"/>
                 </a:solidFill>
               </a:defRPr>
             </a:pPr>
             <a:r>
-              <a:t>•  In obstacle avoidance, a 2-second delay causes physical collisions.</a:t>
-            </a:r>
-          </a:p>
-          <a:p>
-            <a:pPr>
-              <a:spcAft>
-                <a:spcPts val="400"/>
-              </a:spcAft>
-              <a:defRPr sz="1100">
-                <a:solidFill>
-                  <a:srgbClr val="AAB2C8"/>
-                </a:solidFill>
-              </a:defRPr>
-            </a:pPr>
-            <a:r>
-              <a:t>•  Assistive navigation cannot afford network lag.</a:t>
-            </a:r>
-          </a:p>
-        </p:txBody>
-      </p:sp>
-      <p:sp>
-        <p:nvSpPr>
-          <p:cNvPr id="7" name="Rounded Rectangle 6"/>
+              <a:t>•  In obstacle avoidance, that delay causes physical injury and collisions.</a:t>
+            </a:r>
+          </a:p>
+        </p:txBody>
+      </p:sp>
+      <p:sp>
+        <p:nvSpPr>
+          <p:cNvPr id="10" name="Rounded Rectangle 9"/>
           <p:cNvSpPr/>
           <p:nvPr/>
         </p:nvSpPr>
         <p:spPr>
           <a:xfrm>
-            <a:off x="4389120" y="1920240"/>
-            <a:ext cx="3364992" cy="4297680"/>
+            <a:off x="4846320" y="3337560"/>
+            <a:ext cx="6675120" cy="1371600"/>
           </a:xfrm>
           <a:prstGeom prst="roundRect">
             <a:avLst/>
@@ -3893,11 +4086,11 @@
           </a:fontRef>
         </p:style>
         <p:txBody>
-          <a:bodyPr rtlCol="0" anchor="ctr" wrap="square" lIns="274320" rIns="274320" tIns="256032" bIns="228600"/>
+          <a:bodyPr rtlCol="0" anchor="ctr" wrap="square" lIns="228600" rIns="228600" tIns="201168" bIns="182880"/>
           <a:lstStyle/>
           <a:p>
             <a:pPr algn="ctr">
-              <a:defRPr sz="900" b="1">
+              <a:defRPr sz="850" b="1">
                 <a:solidFill>
                   <a:srgbClr val="FFD700"/>
                 </a:solidFill>
@@ -3910,9 +4103,9 @@
           <a:p>
             <a:pPr>
               <a:spcAft>
-                <a:spcPts val="800"/>
+                <a:spcPts val="600"/>
               </a:spcAft>
-              <a:defRPr sz="1600" b="1">
+              <a:defRPr sz="1400" b="1">
                 <a:solidFill>
                   <a:srgbClr val="FFFFFF"/>
                 </a:solidFill>
@@ -3925,75 +4118,60 @@
           <a:p>
             <a:pPr>
               <a:spcAft>
-                <a:spcPts val="400"/>
+                <a:spcPts val="300"/>
               </a:spcAft>
-              <a:defRPr sz="1100">
+              <a:defRPr sz="1000">
                 <a:solidFill>
                   <a:srgbClr val="AAB2C8"/>
                 </a:solidFill>
               </a:defRPr>
             </a:pPr>
             <a:r>
-              <a:t>•  Users are forced to stream live camera feeds to commercial servers.</a:t>
+              <a:t>•  Users must upload live camera feeds of private bedrooms, bathrooms, and IDs.</a:t>
             </a:r>
           </a:p>
           <a:p>
             <a:pPr>
               <a:spcAft>
-                <a:spcPts val="400"/>
+                <a:spcPts val="300"/>
               </a:spcAft>
-              <a:defRPr sz="1100">
+              <a:defRPr sz="1000">
                 <a:solidFill>
                   <a:srgbClr val="AAB2C8"/>
                 </a:solidFill>
               </a:defRPr>
             </a:pPr>
             <a:r>
-              <a:t>•  Exposes private bedrooms, personal ID cards (Aadhaar), and prescriptions.</a:t>
+              <a:t>•  Transmits personal documents (Aadhaar, prescriptions) to 3rd-party servers.</a:t>
             </a:r>
           </a:p>
           <a:p>
             <a:pPr>
               <a:spcAft>
-                <a:spcPts val="400"/>
+                <a:spcPts val="300"/>
               </a:spcAft>
-              <a:defRPr sz="1100">
+              <a:defRPr sz="1000">
                 <a:solidFill>
                   <a:srgbClr val="AAB2C8"/>
                 </a:solidFill>
               </a:defRPr>
             </a:pPr>
             <a:r>
-              <a:t>•  Third-party logging creates massive biometric and spatial risk.</a:t>
-            </a:r>
-          </a:p>
-          <a:p>
-            <a:pPr>
-              <a:spcAft>
-                <a:spcPts val="400"/>
-              </a:spcAft>
-              <a:defRPr sz="1100">
-                <a:solidFill>
-                  <a:srgbClr val="AAB2C8"/>
-                </a:solidFill>
-              </a:defRPr>
-            </a:pPr>
-            <a:r>
-              <a:t>•  Users sacrifice their privacy just to 'see'.</a:t>
-            </a:r>
-          </a:p>
-        </p:txBody>
-      </p:sp>
-      <p:sp>
-        <p:nvSpPr>
-          <p:cNvPr id="8" name="Rounded Rectangle 7"/>
+              <a:t>•  Sacrifices personal privacy just to achieve basic mobility.</a:t>
+            </a:r>
+          </a:p>
+        </p:txBody>
+      </p:sp>
+      <p:sp>
+        <p:nvSpPr>
+          <p:cNvPr id="11" name="Rounded Rectangle 10"/>
           <p:cNvSpPr/>
           <p:nvPr/>
         </p:nvSpPr>
         <p:spPr>
           <a:xfrm>
-            <a:off x="7955279" y="1920240"/>
-            <a:ext cx="3364992" cy="4297680"/>
+            <a:off x="4846320" y="4892040"/>
+            <a:ext cx="6675120" cy="1371600"/>
           </a:xfrm>
           <a:prstGeom prst="roundRect">
             <a:avLst/>
@@ -4022,11 +4200,11 @@
           </a:fontRef>
         </p:style>
         <p:txBody>
-          <a:bodyPr rtlCol="0" anchor="ctr" wrap="square" lIns="274320" rIns="274320" tIns="256032" bIns="228600"/>
+          <a:bodyPr rtlCol="0" anchor="ctr" wrap="square" lIns="228600" rIns="228600" tIns="201168" bIns="182880"/>
           <a:lstStyle/>
           <a:p>
             <a:pPr algn="ctr">
-              <a:defRPr sz="900" b="1">
+              <a:defRPr sz="850" b="1">
                 <a:solidFill>
                   <a:srgbClr val="00E5FF"/>
                 </a:solidFill>
@@ -4039,9 +4217,9 @@
           <a:p>
             <a:pPr>
               <a:spcAft>
-                <a:spcPts val="800"/>
+                <a:spcPts val="600"/>
               </a:spcAft>
-              <a:defRPr sz="1600" b="1">
+              <a:defRPr sz="1400" b="1">
                 <a:solidFill>
                   <a:srgbClr val="FFFFFF"/>
                 </a:solidFill>
@@ -4054,61 +4232,46 @@
           <a:p>
             <a:pPr>
               <a:spcAft>
-                <a:spcPts val="400"/>
+                <a:spcPts val="300"/>
               </a:spcAft>
-              <a:defRPr sz="1100">
+              <a:defRPr sz="1000">
                 <a:solidFill>
                   <a:srgbClr val="AAB2C8"/>
                 </a:solidFill>
               </a:defRPr>
             </a:pPr>
             <a:r>
-              <a:t>•  Real Indian transit corridors frequently lack reliable internet.</a:t>
+              <a:t>•  Transit corridors (metro stations, elevators, rural zones) lack stable internet.</a:t>
             </a:r>
           </a:p>
           <a:p>
             <a:pPr>
               <a:spcAft>
-                <a:spcPts val="400"/>
+                <a:spcPts val="300"/>
               </a:spcAft>
-              <a:defRPr sz="1100">
+              <a:defRPr sz="1000">
                 <a:solidFill>
                   <a:srgbClr val="AAB2C8"/>
                 </a:solidFill>
               </a:defRPr>
             </a:pPr>
             <a:r>
-              <a:t>•  Metro basements, elevators, rural transit, and stairwells fail.</a:t>
+              <a:t>•  When the connection drops, cloud-tethered apps instantly disable.</a:t>
             </a:r>
           </a:p>
           <a:p>
             <a:pPr>
               <a:spcAft>
-                <a:spcPts val="400"/>
+                <a:spcPts val="300"/>
               </a:spcAft>
-              <a:defRPr sz="1100">
+              <a:defRPr sz="1000">
                 <a:solidFill>
                   <a:srgbClr val="AAB2C8"/>
                 </a:solidFill>
               </a:defRPr>
             </a:pPr>
             <a:r>
-              <a:t>•  The moment connection drops, cloud-tethered apps instantly disable.</a:t>
-            </a:r>
-          </a:p>
-          <a:p>
-            <a:pPr>
-              <a:spcAft>
-                <a:spcPts val="400"/>
-              </a:spcAft>
-              <a:defRPr sz="1100">
-                <a:solidFill>
-                  <a:srgbClr val="AAB2C8"/>
-                </a:solidFill>
-              </a:defRPr>
-            </a:pPr>
-            <a:r>
-              <a:t>•  Leaves visually impaired users stranded and blinded.</a:t>
+              <a:t>•  Leaves visually impaired users stranded and functionally blinded.</a:t>
             </a:r>
           </a:p>
         </p:txBody>
@@ -4182,8 +4345,8 @@
         </p:nvSpPr>
         <p:spPr>
           <a:xfrm>
-            <a:off x="822960" y="411480"/>
-            <a:ext cx="9144000" cy="320040"/>
+            <a:off x="731520" y="365760"/>
+            <a:ext cx="10515600" cy="320040"/>
           </a:xfrm>
           <a:prstGeom prst="rect">
             <a:avLst/>
@@ -4217,8 +4380,8 @@
         </p:nvSpPr>
         <p:spPr>
           <a:xfrm>
-            <a:off x="822960" y="685800"/>
-            <a:ext cx="10515600" cy="731520"/>
+            <a:off x="731520" y="640080"/>
+            <a:ext cx="10515600" cy="685800"/>
           </a:xfrm>
           <a:prstGeom prst="rect">
             <a:avLst/>
@@ -4232,7 +4395,7 @@
           <a:lstStyle/>
           <a:p>
             <a:pPr>
-              <a:defRPr sz="2800" b="1">
+              <a:defRPr sz="2600" b="1">
                 <a:solidFill>
                   <a:srgbClr val="FFFFFF"/>
                 </a:solidFill>
@@ -4252,7 +4415,7 @@
         </p:nvSpPr>
         <p:spPr>
           <a:xfrm>
-            <a:off x="822960" y="1325880"/>
+            <a:off x="731520" y="1234440"/>
             <a:ext cx="10515600" cy="411480"/>
           </a:xfrm>
           <a:prstGeom prst="rect">
@@ -4267,7 +4430,7 @@
           <a:lstStyle/>
           <a:p>
             <a:pPr>
-              <a:defRPr sz="1300">
+              <a:defRPr sz="1200">
                 <a:solidFill>
                   <a:srgbClr val="AAB2C8"/>
                 </a:solidFill>
@@ -4287,8 +4450,8 @@
         </p:nvSpPr>
         <p:spPr>
           <a:xfrm>
-            <a:off x="822960" y="1920240"/>
-            <a:ext cx="5166360" cy="2148840"/>
+            <a:off x="731520" y="1783080"/>
+            <a:ext cx="3246120" cy="2148840"/>
           </a:xfrm>
           <a:prstGeom prst="roundRect">
             <a:avLst/>
@@ -4317,11 +4480,11 @@
           </a:fontRef>
         </p:style>
         <p:txBody>
-          <a:bodyPr rtlCol="0" anchor="ctr" wrap="square" lIns="274320" rIns="274320" tIns="256032" bIns="228600"/>
+          <a:bodyPr rtlCol="0" anchor="ctr" wrap="square" lIns="228600" rIns="228600" tIns="201168" bIns="182880"/>
           <a:lstStyle/>
           <a:p>
             <a:pPr algn="ctr">
-              <a:defRPr sz="900" b="1">
+              <a:defRPr sz="850" b="1">
                 <a:solidFill>
                   <a:srgbClr val="FFD700"/>
                 </a:solidFill>
@@ -4334,9 +4497,9 @@
           <a:p>
             <a:pPr>
               <a:spcAft>
-                <a:spcPts val="800"/>
+                <a:spcPts val="600"/>
               </a:spcAft>
-              <a:defRPr sz="1600" b="1">
+              <a:defRPr sz="1350" b="1">
                 <a:solidFill>
                   <a:srgbClr val="FFFFFF"/>
                 </a:solidFill>
@@ -4349,46 +4512,46 @@
           <a:p>
             <a:pPr>
               <a:spcAft>
-                <a:spcPts val="400"/>
+                <a:spcPts val="300"/>
               </a:spcAft>
-              <a:defRPr sz="1100">
+              <a:defRPr sz="950">
                 <a:solidFill>
                   <a:srgbClr val="AAB2C8"/>
                 </a:solidFill>
               </a:defRPr>
             </a:pPr>
             <a:r>
-              <a:t>•  Real-time obstacle narration via on-device vision model.</a:t>
+              <a:t>•  Real-time obstacle narration via local quantized VLM.</a:t>
             </a:r>
           </a:p>
           <a:p>
             <a:pPr>
               <a:spcAft>
-                <a:spcPts val="400"/>
+                <a:spcPts val="300"/>
               </a:spcAft>
-              <a:defRPr sz="1100">
+              <a:defRPr sz="950">
                 <a:solidFill>
                   <a:srgbClr val="AAB2C8"/>
                 </a:solidFill>
               </a:defRPr>
             </a:pPr>
             <a:r>
-              <a:t>•  Maps obstacles to 12 clock-face sectors (e.g. 'Obstacle at 2 o'clock, 3 ft').</a:t>
+              <a:t>•  12 clock-face sectors ('Obstacle at 2 o'clock, 3 ft').</a:t>
             </a:r>
           </a:p>
           <a:p>
             <a:pPr>
               <a:spcAft>
-                <a:spcPts val="400"/>
+                <a:spcPts val="300"/>
               </a:spcAft>
-              <a:defRPr sz="1100">
+              <a:defRPr sz="950">
                 <a:solidFill>
                   <a:srgbClr val="AAB2C8"/>
                 </a:solidFill>
               </a:defRPr>
             </a:pPr>
             <a:r>
-              <a:t>•  Directional linear haptic motor pulses guide user around hazards.</a:t>
+              <a:t>•  Directional haptic motor pulses guide around hazards.</a:t>
             </a:r>
           </a:p>
         </p:txBody>
@@ -4401,8 +4564,8 @@
         </p:nvSpPr>
         <p:spPr>
           <a:xfrm>
-            <a:off x="6172200" y="1920240"/>
-            <a:ext cx="5166360" cy="2148840"/>
+            <a:off x="4114800" y="1783080"/>
+            <a:ext cx="3246120" cy="2148840"/>
           </a:xfrm>
           <a:prstGeom prst="roundRect">
             <a:avLst/>
@@ -4431,11 +4594,11 @@
           </a:fontRef>
         </p:style>
         <p:txBody>
-          <a:bodyPr rtlCol="0" anchor="ctr" wrap="square" lIns="274320" rIns="274320" tIns="256032" bIns="228600"/>
+          <a:bodyPr rtlCol="0" anchor="ctr" wrap="square" lIns="228600" rIns="228600" tIns="201168" bIns="182880"/>
           <a:lstStyle/>
           <a:p>
             <a:pPr algn="ctr">
-              <a:defRPr sz="900" b="1">
+              <a:defRPr sz="850" b="1">
                 <a:solidFill>
                   <a:srgbClr val="34C759"/>
                 </a:solidFill>
@@ -4448,61 +4611,61 @@
           <a:p>
             <a:pPr>
               <a:spcAft>
-                <a:spcPts val="800"/>
+                <a:spcPts val="600"/>
               </a:spcAft>
-              <a:defRPr sz="1600" b="1">
+              <a:defRPr sz="1350" b="1">
                 <a:solidFill>
                   <a:srgbClr val="FFFFFF"/>
                 </a:solidFill>
               </a:defRPr>
             </a:pPr>
             <a:r>
-              <a:t>💊  Smart-Scan for Medicine &amp; Packaging</a:t>
+              <a:t>💊  Smart-Scan for Medicine</a:t>
             </a:r>
           </a:p>
           <a:p>
             <a:pPr>
               <a:spcAft>
-                <a:spcPts val="400"/>
+                <a:spcPts val="300"/>
               </a:spcAft>
-              <a:defRPr sz="1100">
+              <a:defRPr sz="950">
                 <a:solidFill>
                   <a:srgbClr val="AAB2C8"/>
                 </a:solidFill>
               </a:defRPr>
             </a:pPr>
             <a:r>
-              <a:t>•  On-device OCR + local LLM filters noisy, cluttered packaging.</a:t>
+              <a:t>•  On-device OCR + local LLM filters noisy packaging.</a:t>
             </a:r>
           </a:p>
           <a:p>
             <a:pPr>
               <a:spcAft>
-                <a:spcPts val="400"/>
+                <a:spcPts val="300"/>
               </a:spcAft>
-              <a:defRPr sz="1100">
+              <a:defRPr sz="950">
                 <a:solidFill>
                   <a:srgbClr val="AAB2C8"/>
                 </a:solidFill>
               </a:defRPr>
             </a:pPr>
             <a:r>
-              <a:t>•  Isolates just 3 critical pieces of info: Drug Name, Dosage, and Expiry Date.</a:t>
+              <a:t>•  Isolates Drug Name, Dosage, and Expiry Date.</a:t>
             </a:r>
           </a:p>
           <a:p>
             <a:pPr>
               <a:spcAft>
-                <a:spcPts val="400"/>
+                <a:spcPts val="300"/>
               </a:spcAft>
-              <a:defRPr sz="1100">
+              <a:defRPr sz="950">
                 <a:solidFill>
                   <a:srgbClr val="AAB2C8"/>
                 </a:solidFill>
               </a:defRPr>
             </a:pPr>
             <a:r>
-              <a:t>•  Vocalizes clear vernacular guidance ('Take after food').</a:t>
+              <a:t>•  Vocalizes vernacular directions ('Take after food').</a:t>
             </a:r>
           </a:p>
         </p:txBody>
@@ -4515,8 +4678,8 @@
         </p:nvSpPr>
         <p:spPr>
           <a:xfrm>
-            <a:off x="822960" y="4251960"/>
-            <a:ext cx="5166360" cy="2148840"/>
+            <a:off x="731520" y="4114800"/>
+            <a:ext cx="3246120" cy="2148840"/>
           </a:xfrm>
           <a:prstGeom prst="roundRect">
             <a:avLst/>
@@ -4545,11 +4708,11 @@
           </a:fontRef>
         </p:style>
         <p:txBody>
-          <a:bodyPr rtlCol="0" anchor="ctr" wrap="square" lIns="274320" rIns="274320" tIns="256032" bIns="228600"/>
+          <a:bodyPr rtlCol="0" anchor="ctr" wrap="square" lIns="228600" rIns="228600" tIns="201168" bIns="182880"/>
           <a:lstStyle/>
           <a:p>
             <a:pPr algn="ctr">
-              <a:defRPr sz="900" b="1">
+              <a:defRPr sz="850" b="1">
                 <a:solidFill>
                   <a:srgbClr val="00E5FF"/>
                 </a:solidFill>
@@ -4562,61 +4725,61 @@
           <a:p>
             <a:pPr>
               <a:spcAft>
-                <a:spcPts val="800"/>
+                <a:spcPts val="600"/>
               </a:spcAft>
-              <a:defRPr sz="1600" b="1">
+              <a:defRPr sz="1350" b="1">
                 <a:solidFill>
                   <a:srgbClr val="FFFFFF"/>
                 </a:solidFill>
               </a:defRPr>
             </a:pPr>
             <a:r>
-              <a:t>👤  'Who's Near Me' Face Recognition</a:t>
+              <a:t>👤  'Who's Near Me' Face Scan</a:t>
             </a:r>
           </a:p>
           <a:p>
             <a:pPr>
               <a:spcAft>
-                <a:spcPts val="400"/>
+                <a:spcPts val="300"/>
               </a:spcAft>
-              <a:defRPr sz="1100">
+              <a:defRPr sz="950">
                 <a:solidFill>
                   <a:srgbClr val="AAB2C8"/>
                 </a:solidFill>
               </a:defRPr>
             </a:pPr>
             <a:r>
-              <a:t>•  On-device facial recognition of registered trusted contacts.</a:t>
+              <a:t>•  On-device contact recognition for trusted individuals.</a:t>
             </a:r>
           </a:p>
           <a:p>
             <a:pPr>
               <a:spcAft>
-                <a:spcPts val="400"/>
+                <a:spcPts val="300"/>
               </a:spcAft>
-              <a:defRPr sz="1100">
+              <a:defRPr sz="950">
                 <a:solidFill>
                   <a:srgbClr val="AAB2C8"/>
                 </a:solidFill>
               </a:defRPr>
             </a:pPr>
             <a:r>
-              <a:t>•  Biometric vector embeddings stored strictly on-device with zero cloud upload.</a:t>
+              <a:t>•  128-d local embeddings stored only on-device.</a:t>
             </a:r>
           </a:p>
           <a:p>
             <a:pPr>
               <a:spcAft>
-                <a:spcPts val="400"/>
+                <a:spcPts val="300"/>
               </a:spcAft>
-              <a:defRPr sz="1100">
+              <a:defRPr sz="950">
                 <a:solidFill>
                   <a:srgbClr val="AAB2C8"/>
                 </a:solidFill>
               </a:defRPr>
             </a:pPr>
             <a:r>
-              <a:t>•  Discreet double-heartbeat vibration &amp; whispered prompt when friend approaches.</a:t>
+              <a:t>•  Whispers proximity alert with heartbeat haptic pulse.</a:t>
             </a:r>
           </a:p>
         </p:txBody>
@@ -4629,8 +4792,8 @@
         </p:nvSpPr>
         <p:spPr>
           <a:xfrm>
-            <a:off x="6172200" y="4251960"/>
-            <a:ext cx="5166360" cy="2148840"/>
+            <a:off x="4114800" y="4114800"/>
+            <a:ext cx="3246120" cy="2148840"/>
           </a:xfrm>
           <a:prstGeom prst="roundRect">
             <a:avLst/>
@@ -4640,7 +4803,7 @@
           </a:solidFill>
           <a:ln w="15240">
             <a:solidFill>
-              <a:srgbClr val="FF6F00"/>
+              <a:srgbClr val="FFEB78"/>
             </a:solidFill>
           </a:ln>
         </p:spPr>
@@ -4659,13 +4822,13 @@
           </a:fontRef>
         </p:style>
         <p:txBody>
-          <a:bodyPr rtlCol="0" anchor="ctr" wrap="square" lIns="274320" rIns="274320" tIns="256032" bIns="228600"/>
+          <a:bodyPr rtlCol="0" anchor="ctr" wrap="square" lIns="228600" rIns="228600" tIns="201168" bIns="182880"/>
           <a:lstStyle/>
           <a:p>
             <a:pPr algn="ctr">
-              <a:defRPr sz="900" b="1">
-                <a:solidFill>
-                  <a:srgbClr val="FF6F00"/>
+              <a:defRPr sz="850" b="1">
+                <a:solidFill>
+                  <a:srgbClr val="FFEB78"/>
                 </a:solidFill>
               </a:defRPr>
             </a:pPr>
@@ -4676,61 +4839,165 @@
           <a:p>
             <a:pPr>
               <a:spcAft>
-                <a:spcPts val="800"/>
+                <a:spcPts val="600"/>
               </a:spcAft>
-              <a:defRPr sz="1600" b="1">
+              <a:defRPr sz="1350" b="1">
                 <a:solidFill>
                   <a:srgbClr val="FFFFFF"/>
                 </a:solidFill>
               </a:defRPr>
             </a:pPr>
             <a:r>
-              <a:t>🎧  Pure Tactile &amp; Voice UX</a:t>
+              <a:t>📳  Pure Tactile &amp; Voice UX</a:t>
             </a:r>
           </a:p>
           <a:p>
             <a:pPr>
               <a:spcAft>
-                <a:spcPts val="400"/>
+                <a:spcPts val="300"/>
               </a:spcAft>
-              <a:defRPr sz="1100">
+              <a:defRPr sz="950">
                 <a:solidFill>
                   <a:srgbClr val="AAB2C8"/>
                 </a:solidFill>
               </a:defRPr>
             </a:pPr>
             <a:r>
-              <a:t>•  Eyes-free by design — absolutely no screen dependency anywhere.</a:t>
+              <a:t>•  Eyes-free high-contrast OLED interface.</a:t>
             </a:r>
           </a:p>
           <a:p>
             <a:pPr>
               <a:spcAft>
-                <a:spcPts val="400"/>
+                <a:spcPts val="300"/>
               </a:spcAft>
-              <a:defRPr sz="1100">
+              <a:defRPr sz="950">
                 <a:solidFill>
                   <a:srgbClr val="AAB2C8"/>
                 </a:solidFill>
               </a:defRPr>
             </a:pPr>
             <a:r>
-              <a:t>•  Multi-modal audio cues + rich linear haptic vibration feedback.</a:t>
+              <a:t>•  Spatial audio + localized Indian speech engines.</a:t>
             </a:r>
           </a:p>
           <a:p>
             <a:pPr>
               <a:spcAft>
-                <a:spcPts val="400"/>
+                <a:spcPts val="300"/>
               </a:spcAft>
-              <a:defRPr sz="1100">
+              <a:defRPr sz="950">
                 <a:solidFill>
                   <a:srgbClr val="AAB2C8"/>
                 </a:solidFill>
               </a:defRPr>
             </a:pPr>
             <a:r>
-              <a:t>•  Natural back-tap and screen gestures built for blind accessibility.</a:t>
+              <a:t>•  Proximity vibrations guide hands directly to targets.</a:t>
+            </a:r>
+          </a:p>
+        </p:txBody>
+      </p:sp>
+      <p:sp>
+        <p:nvSpPr>
+          <p:cNvPr id="10" name="Rounded Rectangle 9"/>
+          <p:cNvSpPr/>
+          <p:nvPr/>
+        </p:nvSpPr>
+        <p:spPr>
+          <a:xfrm>
+            <a:off x="7543800" y="1783080"/>
+            <a:ext cx="3886200" cy="4480560"/>
+          </a:xfrm>
+          <a:prstGeom prst="roundRect">
+            <a:avLst/>
+          </a:prstGeom>
+          <a:solidFill>
+            <a:srgbClr val="121520"/>
+          </a:solidFill>
+          <a:ln w="15240">
+            <a:solidFill>
+              <a:srgbClr val="2A3046"/>
+            </a:solidFill>
+          </a:ln>
+        </p:spPr>
+        <p:style>
+          <a:lnRef idx="1">
+            <a:schemeClr val="accent1"/>
+          </a:lnRef>
+          <a:fillRef idx="3">
+            <a:schemeClr val="accent1"/>
+          </a:fillRef>
+          <a:effectRef idx="2">
+            <a:schemeClr val="accent1"/>
+          </a:effectRef>
+          <a:fontRef idx="minor">
+            <a:schemeClr val="lt1"/>
+          </a:fontRef>
+        </p:style>
+        <p:txBody>
+          <a:bodyPr rtlCol="0" anchor="ctr"/>
+          <a:lstStyle/>
+          <a:p>
+            <a:pPr algn="ctr"/>
+          </a:p>
+        </p:txBody>
+      </p:sp>
+      <p:pic>
+        <p:nvPicPr>
+          <p:cNvPr id="11" name="Picture 10" descr="iqoo-interface-medicine.jpg"/>
+          <p:cNvPicPr>
+            <a:picLocks noChangeAspect="1"/>
+          </p:cNvPicPr>
+          <p:nvPr/>
+        </p:nvPicPr>
+        <p:blipFill>
+          <a:blip r:embed="rId2"/>
+          <a:stretch>
+            <a:fillRect/>
+          </a:stretch>
+        </p:blipFill>
+        <p:spPr>
+          <a:xfrm>
+            <a:off x="7616952" y="1856232"/>
+            <a:ext cx="3739896" cy="3886200"/>
+          </a:xfrm>
+          <a:prstGeom prst="rect">
+            <a:avLst/>
+          </a:prstGeom>
+        </p:spPr>
+      </p:pic>
+      <p:sp>
+        <p:nvSpPr>
+          <p:cNvPr id="12" name="TextBox 11"/>
+          <p:cNvSpPr txBox="1"/>
+          <p:nvPr/>
+        </p:nvSpPr>
+        <p:spPr>
+          <a:xfrm>
+            <a:off x="7680960" y="5760720"/>
+            <a:ext cx="3611880" cy="457200"/>
+          </a:xfrm>
+          <a:prstGeom prst="rect">
+            <a:avLst/>
+          </a:prstGeom>
+          <a:noFill/>
+        </p:spPr>
+        <p:txBody>
+          <a:bodyPr wrap="square">
+            <a:spAutoFit/>
+          </a:bodyPr>
+          <a:lstStyle/>
+          <a:p>
+            <a:pPr algn="ctr">
+              <a:defRPr sz="950" b="1">
+                <a:solidFill>
+                  <a:srgbClr val="FFD700"/>
+                </a:solidFill>
+              </a:defRPr>
+            </a:pPr>
+            <a:r>
+              <a:t>Drishti on iQOO: On-Device Medicine Scanner &amp; Spatial Radar</a:t>
             </a:r>
           </a:p>
         </p:txBody>
@@ -4804,8 +5071,8 @@
         </p:nvSpPr>
         <p:spPr>
           <a:xfrm>
-            <a:off x="822960" y="411480"/>
-            <a:ext cx="9144000" cy="320040"/>
+            <a:off x="731520" y="365760"/>
+            <a:ext cx="10515600" cy="320040"/>
           </a:xfrm>
           <a:prstGeom prst="rect">
             <a:avLst/>
@@ -4839,8 +5106,8 @@
         </p:nvSpPr>
         <p:spPr>
           <a:xfrm>
-            <a:off x="822960" y="685800"/>
-            <a:ext cx="10515600" cy="731520"/>
+            <a:off x="731520" y="640080"/>
+            <a:ext cx="10515600" cy="685800"/>
           </a:xfrm>
           <a:prstGeom prst="rect">
             <a:avLst/>
@@ -4854,7 +5121,7 @@
           <a:lstStyle/>
           <a:p>
             <a:pPr>
-              <a:defRPr sz="2800" b="1">
+              <a:defRPr sz="2600" b="1">
                 <a:solidFill>
                   <a:srgbClr val="FFFFFF"/>
                 </a:solidFill>
@@ -4874,7 +5141,7 @@
         </p:nvSpPr>
         <p:spPr>
           <a:xfrm>
-            <a:off x="822960" y="1325880"/>
+            <a:off x="731520" y="1234440"/>
             <a:ext cx="10515600" cy="411480"/>
           </a:xfrm>
           <a:prstGeom prst="rect">
@@ -4889,14 +5156,14 @@
           <a:lstStyle/>
           <a:p>
             <a:pPr>
-              <a:defRPr sz="1300">
+              <a:defRPr sz="1200">
                 <a:solidFill>
                   <a:srgbClr val="AAB2C8"/>
                 </a:solidFill>
               </a:defRPr>
             </a:pPr>
             <a:r>
-              <a:t>Built on engineering integrity, real-world hardware diversity, and verified offline execution:</a:t>
+              <a:t>Engineering decisions purpose-built for real Indian living conditions and hardware accessibility:</a:t>
             </a:r>
           </a:p>
         </p:txBody>
@@ -4909,7 +5176,7 @@
         </p:nvSpPr>
         <p:spPr>
           <a:xfrm>
-            <a:off x="822960" y="1920240"/>
+            <a:off x="731520" y="1783080"/>
             <a:ext cx="5166360" cy="2148840"/>
           </a:xfrm>
           <a:prstGeom prst="roundRect">
@@ -4939,93 +5206,78 @@
           </a:fontRef>
         </p:style>
         <p:txBody>
-          <a:bodyPr rtlCol="0" anchor="ctr" wrap="square" lIns="274320" rIns="274320" tIns="256032" bIns="228600"/>
+          <a:bodyPr rtlCol="0" anchor="ctr" wrap="square" lIns="228600" rIns="228600" tIns="201168" bIns="182880"/>
           <a:lstStyle/>
           <a:p>
             <a:pPr algn="ctr">
-              <a:defRPr sz="900" b="1">
+              <a:defRPr sz="850" b="1">
                 <a:solidFill>
                   <a:srgbClr val="FFD700"/>
                 </a:solidFill>
               </a:defRPr>
             </a:pPr>
             <a:r>
-              <a:t>AFFORDABLE HARDWARE DIVERSITY</a:t>
+              <a:t>STRATEGY 1</a:t>
             </a:r>
           </a:p>
           <a:p>
             <a:pPr>
               <a:spcAft>
-                <a:spcPts val="800"/>
+                <a:spcPts val="600"/>
               </a:spcAft>
-              <a:defRPr sz="1600" b="1">
+              <a:defRPr sz="1500" b="1">
                 <a:solidFill>
                   <a:srgbClr val="FFFFFF"/>
                 </a:solidFill>
               </a:defRPr>
             </a:pPr>
             <a:r>
-              <a:t>📱  Tiered Model Strategy</a:t>
+              <a:t>⚡  Tiered Model Strategy</a:t>
             </a:r>
           </a:p>
           <a:p>
             <a:pPr>
               <a:spcAft>
-                <a:spcPts val="400"/>
+                <a:spcPts val="300"/>
               </a:spcAft>
-              <a:defRPr sz="1100">
+              <a:defRPr sz="1050">
                 <a:solidFill>
                   <a:srgbClr val="AAB2C8"/>
                 </a:solidFill>
               </a:defRPr>
             </a:pPr>
             <a:r>
-              <a:t>•  Standard Tier: Full-quality vision model running on flagship NPUs.</a:t>
+              <a:t>•  Standard Model: Runs on flagship NPU (iQOO devices) for rich contextual description.</a:t>
             </a:r>
           </a:p>
           <a:p>
             <a:pPr>
               <a:spcAft>
-                <a:spcPts val="400"/>
+                <a:spcPts val="300"/>
               </a:spcAft>
-              <a:defRPr sz="1100">
+              <a:defRPr sz="1050">
                 <a:solidFill>
                   <a:srgbClr val="AAB2C8"/>
                 </a:solidFill>
               </a:defRPr>
             </a:pPr>
             <a:r>
-              <a:t>•  Lite Tier: Fast, lightweight quantized model optimized for budget chips.</a:t>
+              <a:t>•  Lite Model: Optimized for budget &amp; mid-range chips (Dimensity 6300/7300, Snapdragon 6).</a:t>
             </a:r>
           </a:p>
           <a:p>
             <a:pPr>
               <a:spcAft>
-                <a:spcPts val="400"/>
+                <a:spcPts val="300"/>
               </a:spcAft>
-              <a:defRPr sz="1100">
+              <a:defRPr sz="1050">
                 <a:solidFill>
                   <a:srgbClr val="AAB2C8"/>
                 </a:solidFill>
               </a:defRPr>
             </a:pPr>
             <a:r>
-              <a:t>•  Works on affordable sub-₹15,000 devices (Dimensity 6300) — not just flagships.</a:t>
-            </a:r>
-          </a:p>
-          <a:p>
-            <a:pPr>
-              <a:spcAft>
-                <a:spcPts val="400"/>
-              </a:spcAft>
-              <a:defRPr sz="1100">
-                <a:solidFill>
-                  <a:srgbClr val="AAB2C8"/>
-                </a:solidFill>
-              </a:defRPr>
-            </a:pPr>
-            <a:r>
-              <a:t>•  Democratizes assistive technology for all socioeconomic groups.</a:t>
+              <a:t>•  Ensures accessibility across all economic demographics, not just flagship buyers.</a:t>
             </a:r>
           </a:p>
         </p:txBody>
@@ -5038,7 +5290,7 @@
         </p:nvSpPr>
         <p:spPr>
           <a:xfrm>
-            <a:off x="6172200" y="1920240"/>
+            <a:off x="6217920" y="1783080"/>
             <a:ext cx="5166360" cy="2148840"/>
           </a:xfrm>
           <a:prstGeom prst="roundRect">
@@ -5068,93 +5320,78 @@
           </a:fontRef>
         </p:style>
         <p:txBody>
-          <a:bodyPr rtlCol="0" anchor="ctr" wrap="square" lIns="274320" rIns="274320" tIns="256032" bIns="228600"/>
+          <a:bodyPr rtlCol="0" anchor="ctr" wrap="square" lIns="228600" rIns="228600" tIns="201168" bIns="182880"/>
           <a:lstStyle/>
           <a:p>
             <a:pPr algn="ctr">
-              <a:defRPr sz="900" b="1">
+              <a:defRPr sz="850" b="1">
                 <a:solidFill>
                   <a:srgbClr val="00E5FF"/>
                 </a:solidFill>
               </a:defRPr>
             </a:pPr>
             <a:r>
-              <a:t>PROVEN ON STAGE, NOT CLAIMED</a:t>
+              <a:t>STRATEGY 2</a:t>
             </a:r>
           </a:p>
           <a:p>
             <a:pPr>
               <a:spcAft>
-                <a:spcPts val="800"/>
+                <a:spcPts val="600"/>
               </a:spcAft>
-              <a:defRPr sz="1600" b="1">
+              <a:defRPr sz="1500" b="1">
                 <a:solidFill>
                   <a:srgbClr val="FFFFFF"/>
                 </a:solidFill>
               </a:defRPr>
             </a:pPr>
             <a:r>
-              <a:t>⏱️  Live Unsimulated Latency Benchmark</a:t>
+              <a:t>⏱️  Live Real-World Latency Benchmark</a:t>
             </a:r>
           </a:p>
           <a:p>
             <a:pPr>
               <a:spcAft>
-                <a:spcPts val="400"/>
+                <a:spcPts val="300"/>
               </a:spcAft>
-              <a:defRPr sz="1100">
+              <a:defRPr sz="1050">
                 <a:solidFill>
                   <a:srgbClr val="AAB2C8"/>
                 </a:solidFill>
               </a:defRPr>
             </a:pPr>
             <a:r>
-              <a:t>•  Genuine live HTTP cloud round-trip vs. on-device NPU stopwatch.</a:t>
+              <a:t>•  Not simulated or mocked: fires a real HTTP network call against local stopwatch.</a:t>
             </a:r>
           </a:p>
           <a:p>
             <a:pPr>
               <a:spcAft>
-                <a:spcPts val="400"/>
+                <a:spcPts val="300"/>
               </a:spcAft>
-              <a:defRPr sz="1100">
+              <a:defRPr sz="1050">
                 <a:solidFill>
                   <a:srgbClr val="AAB2C8"/>
                 </a:solidFill>
               </a:defRPr>
             </a:pPr>
             <a:r>
-              <a:t>•  Proven live on stage with real network calls — not hardcoded or assumed.</a:t>
+              <a:t>•  Demonstrates local processing is an order of magnitude faster than cloud round-trips.</a:t>
             </a:r>
           </a:p>
           <a:p>
             <a:pPr>
               <a:spcAft>
-                <a:spcPts val="400"/>
+                <a:spcPts val="300"/>
               </a:spcAft>
-              <a:defRPr sz="1100">
+              <a:defRPr sz="1050">
                 <a:solidFill>
                   <a:srgbClr val="AAB2C8"/>
                 </a:solidFill>
               </a:defRPr>
             </a:pPr>
             <a:r>
-              <a:t>•  Measured live per device; demonstrates order-of-magnitude speedup over cloud.</a:t>
-            </a:r>
-          </a:p>
-          <a:p>
-            <a:pPr>
-              <a:spcAft>
-                <a:spcPts val="400"/>
-              </a:spcAft>
-              <a:defRPr sz="1100">
-                <a:solidFill>
-                  <a:srgbClr val="AAB2C8"/>
-                </a:solidFill>
-              </a:defRPr>
-            </a:pPr>
-            <a:r>
-              <a:t>•  Telemetry HUD visibly contrasts local speed vs. cloud network lag.</a:t>
+              <a:t>•  Includes cached replay fallback if convention Wi-Fi is completely down.</a:t>
             </a:r>
           </a:p>
         </p:txBody>
@@ -5167,7 +5404,7 @@
         </p:nvSpPr>
         <p:spPr>
           <a:xfrm>
-            <a:off x="822960" y="4251960"/>
+            <a:off x="731520" y="4114800"/>
             <a:ext cx="5166360" cy="2148840"/>
           </a:xfrm>
           <a:prstGeom prst="roundRect">
@@ -5197,93 +5434,78 @@
           </a:fontRef>
         </p:style>
         <p:txBody>
-          <a:bodyPr rtlCol="0" anchor="ctr" wrap="square" lIns="274320" rIns="274320" tIns="256032" bIns="228600"/>
+          <a:bodyPr rtlCol="0" anchor="ctr" wrap="square" lIns="228600" rIns="228600" tIns="201168" bIns="182880"/>
           <a:lstStyle/>
           <a:p>
             <a:pPr algn="ctr">
-              <a:defRPr sz="900" b="1">
+              <a:defRPr sz="850" b="1">
                 <a:solidFill>
                   <a:srgbClr val="34C759"/>
                 </a:solidFill>
               </a:defRPr>
             </a:pPr>
             <a:r>
-              <a:t>AIR-GAPPED AUTONOMY</a:t>
+              <a:t>STRATEGY 3</a:t>
             </a:r>
           </a:p>
           <a:p>
             <a:pPr>
               <a:spcAft>
-                <a:spcPts val="800"/>
+                <a:spcPts val="600"/>
               </a:spcAft>
-              <a:defRPr sz="1600" b="1">
+              <a:defRPr sz="1500" b="1">
                 <a:solidFill>
                   <a:srgbClr val="FFFFFF"/>
                 </a:solidFill>
               </a:defRPr>
             </a:pPr>
             <a:r>
-              <a:t>✈️  100% Offline-Verifiable</a:t>
+              <a:t>✈️  100% Offline-Verifiable (Airplane Mode)</a:t>
             </a:r>
           </a:p>
           <a:p>
             <a:pPr>
               <a:spcAft>
-                <a:spcPts val="400"/>
+                <a:spcPts val="300"/>
               </a:spcAft>
-              <a:defRPr sz="1100">
+              <a:defRPr sz="1050">
                 <a:solidFill>
                   <a:srgbClr val="AAB2C8"/>
                 </a:solidFill>
               </a:defRPr>
             </a:pPr>
             <a:r>
-              <a:t>•  Works reliably in Airplane Mode with Wi-Fi and cellular disabled live.</a:t>
+              <a:t>•  Airplane mode toggle proves zero network calls during live evaluation.</a:t>
             </a:r>
           </a:p>
           <a:p>
             <a:pPr>
               <a:spcAft>
-                <a:spcPts val="400"/>
+                <a:spcPts val="300"/>
               </a:spcAft>
-              <a:defRPr sz="1100">
+              <a:defRPr sz="1050">
                 <a:solidFill>
                   <a:srgbClr val="AAB2C8"/>
                 </a:solidFill>
               </a:defRPr>
             </a:pPr>
             <a:r>
-              <a:t>•  Complete sensory pipeline runs air-gapped with zero network calls.</a:t>
+              <a:t>•  Operates flawlessly in basements, elevators, underground metros, and remote regions.</a:t>
             </a:r>
           </a:p>
           <a:p>
             <a:pPr>
               <a:spcAft>
-                <a:spcPts val="400"/>
+                <a:spcPts val="300"/>
               </a:spcAft>
-              <a:defRPr sz="1100">
+              <a:defRPr sz="1050">
                 <a:solidFill>
                   <a:srgbClr val="AAB2C8"/>
                 </a:solidFill>
               </a:defRPr>
             </a:pPr>
             <a:r>
-              <a:t>•  Proves zero cloud reliance live on stage in front of judges.</a:t>
-            </a:r>
-          </a:p>
-          <a:p>
-            <a:pPr>
-              <a:spcAft>
-                <a:spcPts val="400"/>
-              </a:spcAft>
-              <a:defRPr sz="1100">
-                <a:solidFill>
-                  <a:srgbClr val="AAB2C8"/>
-                </a:solidFill>
-              </a:defRPr>
-            </a:pPr>
-            <a:r>
-              <a:t>•  Eliminates transit dead-zones in metro stations and elevators.</a:t>
+              <a:t>•  Zero cloud dependency: guaranteed reliability when it matters most.</a:t>
             </a:r>
           </a:p>
         </p:txBody>
@@ -5296,7 +5518,7 @@
         </p:nvSpPr>
         <p:spPr>
           <a:xfrm>
-            <a:off x="6172200" y="4251960"/>
+            <a:off x="6217920" y="4114800"/>
             <a:ext cx="5166360" cy="2148840"/>
           </a:xfrm>
           <a:prstGeom prst="roundRect">
@@ -5307,7 +5529,7 @@
           </a:solidFill>
           <a:ln w="15240">
             <a:solidFill>
-              <a:srgbClr val="FF6F00"/>
+              <a:srgbClr val="FFEB78"/>
             </a:solidFill>
           </a:ln>
         </p:spPr>
@@ -5326,93 +5548,78 @@
           </a:fontRef>
         </p:style>
         <p:txBody>
-          <a:bodyPr rtlCol="0" anchor="ctr" wrap="square" lIns="274320" rIns="274320" tIns="256032" bIns="228600"/>
+          <a:bodyPr rtlCol="0" anchor="ctr" wrap="square" lIns="228600" rIns="228600" tIns="201168" bIns="182880"/>
           <a:lstStyle/>
           <a:p>
             <a:pPr algn="ctr">
-              <a:defRPr sz="900" b="1">
-                <a:solidFill>
-                  <a:srgbClr val="FF6F00"/>
-                </a:solidFill>
-              </a:defRPr>
-            </a:pPr>
-            <a:r>
-              <a:t>ZERO CLOUD LEAKAGE</a:t>
+              <a:defRPr sz="850" b="1">
+                <a:solidFill>
+                  <a:srgbClr val="FFEB78"/>
+                </a:solidFill>
+              </a:defRPr>
+            </a:pPr>
+            <a:r>
+              <a:t>STRATEGY 4</a:t>
             </a:r>
           </a:p>
           <a:p>
             <a:pPr>
               <a:spcAft>
-                <a:spcPts val="800"/>
+                <a:spcPts val="600"/>
               </a:spcAft>
-              <a:defRPr sz="1600" b="1">
+              <a:defRPr sz="1500" b="1">
                 <a:solidFill>
                   <a:srgbClr val="FFFFFF"/>
                 </a:solidFill>
               </a:defRPr>
             </a:pPr>
             <a:r>
-              <a:t>🔐  Local-Only Biometric Storage</a:t>
+              <a:t>🔐  Local Encrypted Face Recognition</a:t>
             </a:r>
           </a:p>
           <a:p>
             <a:pPr>
               <a:spcAft>
-                <a:spcPts val="400"/>
+                <a:spcPts val="300"/>
               </a:spcAft>
-              <a:defRPr sz="1100">
+              <a:defRPr sz="1050">
                 <a:solidFill>
                   <a:srgbClr val="AAB2C8"/>
                 </a:solidFill>
               </a:defRPr>
             </a:pPr>
             <a:r>
-              <a:t>•  128-dimensional facial embeddings stored strictly on-device.</a:t>
+              <a:t>•  128-dimensional vector embeddings stored strictly on-device.</a:t>
             </a:r>
           </a:p>
           <a:p>
             <a:pPr>
               <a:spcAft>
-                <a:spcPts val="400"/>
+                <a:spcPts val="300"/>
               </a:spcAft>
-              <a:defRPr sz="1100">
+              <a:defRPr sz="1050">
                 <a:solidFill>
                   <a:srgbClr val="AAB2C8"/>
                 </a:solidFill>
               </a:defRPr>
             </a:pPr>
             <a:r>
-              <a:t>•  Never uploaded to servers, never synced, never trained on external models.</a:t>
+              <a:t>•  Encrypted at rest with WebCrypto AES-GCM 256-bit encryption.</a:t>
             </a:r>
           </a:p>
           <a:p>
             <a:pPr>
               <a:spcAft>
-                <a:spcPts val="400"/>
+                <a:spcPts val="300"/>
               </a:spcAft>
-              <a:defRPr sz="1100">
+              <a:defRPr sz="1050">
                 <a:solidFill>
                   <a:srgbClr val="AAB2C8"/>
                 </a:solidFill>
               </a:defRPr>
             </a:pPr>
             <a:r>
-              <a:t>•  Encrypted at rest using WebCrypto AES-GCM 256-bit encryption.</a:t>
-            </a:r>
-          </a:p>
-          <a:p>
-            <a:pPr>
-              <a:spcAft>
-                <a:spcPts val="400"/>
-              </a:spcAft>
-              <a:defRPr sz="1100">
-                <a:solidFill>
-                  <a:srgbClr val="AAB2C8"/>
-                </a:solidFill>
-              </a:defRPr>
-            </a:pPr>
-            <a:r>
-              <a:t>•  Guarantees total privacy and zero surveillance risk for user and family.</a:t>
+              <a:t>•  Zero biometric data ever transmitted or uploaded to external servers.</a:t>
             </a:r>
           </a:p>
         </p:txBody>
@@ -5486,8 +5693,8 @@
         </p:nvSpPr>
         <p:spPr>
           <a:xfrm>
-            <a:off x="822960" y="411480"/>
-            <a:ext cx="9144000" cy="320040"/>
+            <a:off x="731520" y="365760"/>
+            <a:ext cx="10515600" cy="320040"/>
           </a:xfrm>
           <a:prstGeom prst="rect">
             <a:avLst/>
@@ -5521,8 +5728,8 @@
         </p:nvSpPr>
         <p:spPr>
           <a:xfrm>
-            <a:off x="822960" y="685800"/>
-            <a:ext cx="10515600" cy="731520"/>
+            <a:off x="731520" y="640080"/>
+            <a:ext cx="10515600" cy="685800"/>
           </a:xfrm>
           <a:prstGeom prst="rect">
             <a:avLst/>
@@ -5536,14 +5743,14 @@
           <a:lstStyle/>
           <a:p>
             <a:pPr>
-              <a:defRPr sz="2800" b="1">
+              <a:defRPr sz="2600" b="1">
                 <a:solidFill>
                   <a:srgbClr val="FFFFFF"/>
                 </a:solidFill>
               </a:defRPr>
             </a:pPr>
             <a:r>
-              <a:t>Technical Architecture</a:t>
+              <a:t>Technical Architecture: Fully On-Device Pipeline</a:t>
             </a:r>
           </a:p>
         </p:txBody>
@@ -5556,7 +5763,7 @@
         </p:nvSpPr>
         <p:spPr>
           <a:xfrm>
-            <a:off x="822960" y="1325880"/>
+            <a:off x="731520" y="1234440"/>
             <a:ext cx="10515600" cy="411480"/>
           </a:xfrm>
           <a:prstGeom prst="rect">
@@ -5571,14 +5778,14 @@
           <a:lstStyle/>
           <a:p>
             <a:pPr>
-              <a:defRPr sz="1300">
+              <a:defRPr sz="1200">
                 <a:solidFill>
                   <a:srgbClr val="AAB2C8"/>
                 </a:solidFill>
               </a:defRPr>
             </a:pPr>
             <a:r>
-              <a:t>A clean pipeline designed for local silicon execution with zero network dependency:</a:t>
+              <a:t>Pure on-device edge pipeline converting raw camera &amp; motion frames into spatial speech and haptics:</a:t>
             </a:r>
           </a:p>
         </p:txBody>
@@ -5591,8 +5798,8 @@
         </p:nvSpPr>
         <p:spPr>
           <a:xfrm>
-            <a:off x="822960" y="1920240"/>
-            <a:ext cx="3364992" cy="4297680"/>
+            <a:off x="731520" y="1783080"/>
+            <a:ext cx="3429000" cy="2651760"/>
           </a:xfrm>
           <a:prstGeom prst="roundRect">
             <a:avLst/>
@@ -5621,93 +5828,78 @@
           </a:fontRef>
         </p:style>
         <p:txBody>
-          <a:bodyPr rtlCol="0" anchor="ctr" wrap="square" lIns="274320" rIns="274320" tIns="256032" bIns="228600"/>
+          <a:bodyPr rtlCol="0" anchor="ctr" wrap="square" lIns="228600" rIns="228600" tIns="201168" bIns="182880"/>
           <a:lstStyle/>
           <a:p>
             <a:pPr algn="ctr">
-              <a:defRPr sz="900" b="1">
+              <a:defRPr sz="850" b="1">
                 <a:solidFill>
                   <a:srgbClr val="FFD700"/>
                 </a:solidFill>
               </a:defRPr>
             </a:pPr>
             <a:r>
-              <a:t>PERCEPTION LAYER</a:t>
+              <a:t>1. SENSORY INPUT</a:t>
             </a:r>
           </a:p>
           <a:p>
             <a:pPr>
               <a:spcAft>
-                <a:spcPts val="800"/>
+                <a:spcPts val="600"/>
               </a:spcAft>
-              <a:defRPr sz="1600" b="1">
+              <a:defRPr sz="1500" b="1">
                 <a:solidFill>
                   <a:srgbClr val="FFFFFF"/>
                 </a:solidFill>
               </a:defRPr>
             </a:pPr>
             <a:r>
-              <a:t>📷  1. Local Ingestion &amp; Models</a:t>
+              <a:t>Camera &amp; IMU Sensors</a:t>
             </a:r>
           </a:p>
           <a:p>
             <a:pPr>
               <a:spcAft>
-                <a:spcPts val="400"/>
+                <a:spcPts val="300"/>
               </a:spcAft>
-              <a:defRPr sz="1100">
+              <a:defRPr sz="1050">
                 <a:solidFill>
                   <a:srgbClr val="AAB2C8"/>
                 </a:solidFill>
               </a:defRPr>
             </a:pPr>
             <a:r>
-              <a:t>•  Camera Stream: Low-latency frame capture with adaptive downsampling.</a:t>
+              <a:t>•  Low-latency 640x480 frame capture</a:t>
             </a:r>
           </a:p>
           <a:p>
             <a:pPr>
               <a:spcAft>
-                <a:spcPts val="400"/>
+                <a:spcPts val="300"/>
               </a:spcAft>
-              <a:defRPr sz="1100">
+              <a:defRPr sz="1050">
                 <a:solidFill>
                   <a:srgbClr val="AAB2C8"/>
                 </a:solidFill>
               </a:defRPr>
             </a:pPr>
             <a:r>
-              <a:t>•  On-Device Quantized Vision Model: Fast obstacle &amp; spatial segmentation.</a:t>
+              <a:t>•  Accelerometer tilt &amp; back-tap detection</a:t>
             </a:r>
           </a:p>
           <a:p>
             <a:pPr>
               <a:spcAft>
-                <a:spcPts val="400"/>
+                <a:spcPts val="300"/>
               </a:spcAft>
-              <a:defRPr sz="1100">
+              <a:defRPr sz="1050">
                 <a:solidFill>
                   <a:srgbClr val="AAB2C8"/>
                 </a:solidFill>
               </a:defRPr>
             </a:pPr>
             <a:r>
-              <a:t>•  On-Device OCR: High-contrast text extraction from blister packs.</a:t>
-            </a:r>
-          </a:p>
-          <a:p>
-            <a:pPr>
-              <a:spcAft>
-                <a:spcPts val="400"/>
-              </a:spcAft>
-              <a:defRPr sz="1100">
-                <a:solidFill>
-                  <a:srgbClr val="AAB2C8"/>
-                </a:solidFill>
-              </a:defRPr>
-            </a:pPr>
-            <a:r>
-              <a:t>•  Local Lightweight LLM: Strips packaging clutter into drug name, dosage &amp; expiry.</a:t>
+              <a:t>•  Zero frame buffering or disk writing</a:t>
             </a:r>
           </a:p>
         </p:txBody>
@@ -5720,8 +5912,8 @@
         </p:nvSpPr>
         <p:spPr>
           <a:xfrm>
-            <a:off x="4389120" y="1920240"/>
-            <a:ext cx="3364992" cy="4297680"/>
+            <a:off x="4389120" y="1783080"/>
+            <a:ext cx="3429000" cy="2651760"/>
           </a:xfrm>
           <a:prstGeom prst="roundRect">
             <a:avLst/>
@@ -5750,93 +5942,78 @@
           </a:fontRef>
         </p:style>
         <p:txBody>
-          <a:bodyPr rtlCol="0" anchor="ctr" wrap="square" lIns="274320" rIns="274320" tIns="256032" bIns="228600"/>
+          <a:bodyPr rtlCol="0" anchor="ctr" wrap="square" lIns="228600" rIns="228600" tIns="201168" bIns="182880"/>
           <a:lstStyle/>
           <a:p>
             <a:pPr algn="ctr">
-              <a:defRPr sz="900" b="1">
+              <a:defRPr sz="850" b="1">
                 <a:solidFill>
                   <a:srgbClr val="00E5FF"/>
                 </a:solidFill>
               </a:defRPr>
             </a:pPr>
             <a:r>
-              <a:t>ADAPTIVE COMPUTE ENGINE</a:t>
+              <a:t>2. ON-DEVICE INFERENCE</a:t>
             </a:r>
           </a:p>
           <a:p>
             <a:pPr>
               <a:spcAft>
-                <a:spcPts val="800"/>
+                <a:spcPts val="600"/>
               </a:spcAft>
-              <a:defRPr sz="1600" b="1">
+              <a:defRPr sz="1500" b="1">
                 <a:solidFill>
                   <a:srgbClr val="FFFFFF"/>
                 </a:solidFill>
               </a:defRPr>
             </a:pPr>
             <a:r>
-              <a:t>⚡  2. Hardware Adaptation</a:t>
+              <a:t>Quantized VLM + OCR + LLM</a:t>
             </a:r>
           </a:p>
           <a:p>
             <a:pPr>
               <a:spcAft>
-                <a:spcPts val="400"/>
+                <a:spcPts val="300"/>
               </a:spcAft>
-              <a:defRPr sz="1100">
+              <a:defRPr sz="1050">
                 <a:solidFill>
                   <a:srgbClr val="AAB2C8"/>
                 </a:solidFill>
               </a:defRPr>
             </a:pPr>
             <a:r>
-              <a:t>•  Dynamic Tier Manager: Auto-detects device compute and frame budget.</a:t>
+              <a:t>•  Quantized VLM for spatial scene analysis</a:t>
             </a:r>
           </a:p>
           <a:p>
             <a:pPr>
               <a:spcAft>
-                <a:spcPts val="400"/>
+                <a:spcPts val="300"/>
               </a:spcAft>
-              <a:defRPr sz="1100">
+              <a:defRPr sz="1050">
                 <a:solidFill>
                   <a:srgbClr val="AAB2C8"/>
                 </a:solidFill>
               </a:defRPr>
             </a:pPr>
             <a:r>
-              <a:t>•  Standard Mode: Rich spatial comprehension for flagship silicon.</a:t>
+              <a:t>•  On-device OCR for medicine labels</a:t>
             </a:r>
           </a:p>
           <a:p>
             <a:pPr>
               <a:spcAft>
-                <a:spcPts val="400"/>
+                <a:spcPts val="300"/>
               </a:spcAft>
-              <a:defRPr sz="1100">
+              <a:defRPr sz="1050">
                 <a:solidFill>
                   <a:srgbClr val="AAB2C8"/>
                 </a:solidFill>
               </a:defRPr>
             </a:pPr>
             <a:r>
-              <a:t>•  Lite Mode: Rapid directional evasion hints for budget chipsets.</a:t>
-            </a:r>
-          </a:p>
-          <a:p>
-            <a:pPr>
-              <a:spcAft>
-                <a:spcPts val="400"/>
-              </a:spcAft>
-              <a:defRPr sz="1100">
-                <a:solidFill>
-                  <a:srgbClr val="AAB2C8"/>
-                </a:solidFill>
-              </a:defRPr>
-            </a:pPr>
-            <a:r>
-              <a:t>•  Zero Network Call Constraint: Core loop strictly isolated from internet.</a:t>
+              <a:t>•  Local LLM for text summarization</a:t>
             </a:r>
           </a:p>
         </p:txBody>
@@ -5849,8 +6026,8 @@
         </p:nvSpPr>
         <p:spPr>
           <a:xfrm>
-            <a:off x="7955279" y="1920240"/>
-            <a:ext cx="3364992" cy="4297680"/>
+            <a:off x="8046720" y="1783080"/>
+            <a:ext cx="3429000" cy="2651760"/>
           </a:xfrm>
           <a:prstGeom prst="roundRect">
             <a:avLst/>
@@ -5879,93 +6056,171 @@
           </a:fontRef>
         </p:style>
         <p:txBody>
-          <a:bodyPr rtlCol="0" anchor="ctr" wrap="square" lIns="274320" rIns="274320" tIns="256032" bIns="228600"/>
+          <a:bodyPr rtlCol="0" anchor="ctr" wrap="square" lIns="228600" rIns="228600" tIns="201168" bIns="182880"/>
           <a:lstStyle/>
           <a:p>
             <a:pPr algn="ctr">
-              <a:defRPr sz="900" b="1">
+              <a:defRPr sz="850" b="1">
                 <a:solidFill>
                   <a:srgbClr val="34C759"/>
                 </a:solidFill>
               </a:defRPr>
             </a:pPr>
             <a:r>
-              <a:t>TACTILE &amp; AUDIO FEEDBACK</a:t>
+              <a:t>3. MULTI-MODAL OUTPUT</a:t>
             </a:r>
           </a:p>
           <a:p>
             <a:pPr>
               <a:spcAft>
-                <a:spcPts val="800"/>
+                <a:spcPts val="600"/>
               </a:spcAft>
-              <a:defRPr sz="1600" b="1">
+              <a:defRPr sz="1500" b="1">
                 <a:solidFill>
                   <a:srgbClr val="FFFFFF"/>
                 </a:solidFill>
               </a:defRPr>
             </a:pPr>
             <a:r>
-              <a:t>🔊  3. Multi-Sensory UX</a:t>
+              <a:t>Neural TTS + Linear Haptics</a:t>
             </a:r>
           </a:p>
           <a:p>
             <a:pPr>
               <a:spcAft>
+                <a:spcPts val="300"/>
+              </a:spcAft>
+              <a:defRPr sz="1050">
+                <a:solidFill>
+                  <a:srgbClr val="AAB2C8"/>
+                </a:solidFill>
+              </a:defRPr>
+            </a:pPr>
+            <a:r>
+              <a:t>•  Clock-face spatial audio guidance</a:t>
+            </a:r>
+          </a:p>
+          <a:p>
+            <a:pPr>
+              <a:spcAft>
+                <a:spcPts val="300"/>
+              </a:spcAft>
+              <a:defRPr sz="1050">
+                <a:solidFill>
+                  <a:srgbClr val="AAB2C8"/>
+                </a:solidFill>
+              </a:defRPr>
+            </a:pPr>
+            <a:r>
+              <a:t>•  Pan-Indian speech (Telugu, Hindi, etc.)</a:t>
+            </a:r>
+          </a:p>
+          <a:p>
+            <a:pPr>
+              <a:spcAft>
+                <a:spcPts val="300"/>
+              </a:spcAft>
+              <a:defRPr sz="1050">
+                <a:solidFill>
+                  <a:srgbClr val="AAB2C8"/>
+                </a:solidFill>
+              </a:defRPr>
+            </a:pPr>
+            <a:r>
+              <a:t>•  Proximity vibration pulse sequences</a:t>
+            </a:r>
+          </a:p>
+        </p:txBody>
+      </p:sp>
+      <p:sp>
+        <p:nvSpPr>
+          <p:cNvPr id="9" name="Rounded Rectangle 8"/>
+          <p:cNvSpPr/>
+          <p:nvPr/>
+        </p:nvSpPr>
+        <p:spPr>
+          <a:xfrm>
+            <a:off x="731520" y="4663440"/>
+            <a:ext cx="10744200" cy="1600200"/>
+          </a:xfrm>
+          <a:prstGeom prst="roundRect">
+            <a:avLst/>
+          </a:prstGeom>
+          <a:solidFill>
+            <a:srgbClr val="121520"/>
+          </a:solidFill>
+          <a:ln>
+            <a:solidFill>
+              <a:srgbClr val="FFD700"/>
+            </a:solidFill>
+          </a:ln>
+        </p:spPr>
+        <p:style>
+          <a:lnRef idx="1">
+            <a:schemeClr val="accent1"/>
+          </a:lnRef>
+          <a:fillRef idx="3">
+            <a:schemeClr val="accent1"/>
+          </a:fillRef>
+          <a:effectRef idx="2">
+            <a:schemeClr val="accent1"/>
+          </a:effectRef>
+          <a:fontRef idx="minor">
+            <a:schemeClr val="lt1"/>
+          </a:fontRef>
+        </p:style>
+        <p:txBody>
+          <a:bodyPr rtlCol="0" anchor="ctr" lIns="365760" tIns="228600"/>
+          <a:lstStyle/>
+          <a:p>
+            <a:pPr algn="ctr">
+              <a:defRPr sz="1100" b="1">
+                <a:solidFill>
+                  <a:srgbClr val="FFD700"/>
+                </a:solidFill>
+              </a:defRPr>
+            </a:pPr>
+            <a:r>
+              <a:t>TIERED MODEL SELECTION  &amp;  ZERO-NETWORK GUARANTEE</a:t>
+            </a:r>
+          </a:p>
+          <a:p>
+            <a:pPr>
+              <a:spcBef>
                 <a:spcPts val="400"/>
-              </a:spcAft>
+              </a:spcBef>
               <a:defRPr sz="1100">
                 <a:solidFill>
+                  <a:srgbClr val="FFFFFF"/>
+                </a:solidFill>
+              </a:defRPr>
+            </a:pPr>
+            <a:r>
+              <a:t>• Standard Tier (NPU): Leverages mobile NPU hardware (iQOO flagship chips) for multi-object spatial reasoning.</a:t>
+            </a:r>
+          </a:p>
+          <a:p>
+            <a:pPr>
+              <a:defRPr sz="1100">
+                <a:solidFill>
                   <a:srgbClr val="AAB2C8"/>
                 </a:solidFill>
               </a:defRPr>
             </a:pPr>
             <a:r>
-              <a:t>•  Offline Text-to-Speech: Natural voice synthesis across 7 Indian languages.</a:t>
-            </a:r>
-          </a:p>
-          <a:p>
-            <a:pPr>
-              <a:spcAft>
-                <a:spcPts val="400"/>
-              </a:spcAft>
+              <a:t>• Lite Tier (Edge CPU/GPU): Streamlined quantized weights running on affordable mid-range Indian smartphones.</a:t>
+            </a:r>
+          </a:p>
+          <a:p>
+            <a:pPr>
               <a:defRPr sz="1100">
                 <a:solidFill>
-                  <a:srgbClr val="AAB2C8"/>
-                </a:solidFill>
-              </a:defRPr>
-            </a:pPr>
-            <a:r>
-              <a:t>•  Directional Linear Haptics: Escalating vibration pulses for near hazards.</a:t>
-            </a:r>
-          </a:p>
-          <a:p>
-            <a:pPr>
-              <a:spcAft>
-                <a:spcPts val="400"/>
-              </a:spcAft>
-              <a:defRPr sz="1100">
-                <a:solidFill>
-                  <a:srgbClr val="AAB2C8"/>
-                </a:solidFill>
-              </a:defRPr>
-            </a:pPr>
-            <a:r>
-              <a:t>•  Eyes-Free Gestures: Screen double-tap &amp; back-tap controls.</a:t>
-            </a:r>
-          </a:p>
-          <a:p>
-            <a:pPr>
-              <a:spcAft>
-                <a:spcPts val="400"/>
-              </a:spcAft>
-              <a:defRPr sz="1100">
-                <a:solidFill>
-                  <a:srgbClr val="AAB2C8"/>
-                </a:solidFill>
-              </a:defRPr>
-            </a:pPr>
-            <a:r>
-              <a:t>•  Discreet Whispers: Proximity alerts for registered trusted contacts.</a:t>
+                  <a:srgbClr val="34C759"/>
+                </a:solidFill>
+              </a:defRPr>
+            </a:pPr>
+            <a:r>
+              <a:t>• 100% Air-Gapped Autonomy: Zero network sockets, zero telemetry tracking, zero server infrastructure costs.</a:t>
             </a:r>
           </a:p>
         </p:txBody>
@@ -6039,8 +6294,8 @@
         </p:nvSpPr>
         <p:spPr>
           <a:xfrm>
-            <a:off x="822960" y="411480"/>
-            <a:ext cx="9144000" cy="320040"/>
+            <a:off x="731520" y="365760"/>
+            <a:ext cx="10515600" cy="320040"/>
           </a:xfrm>
           <a:prstGeom prst="rect">
             <a:avLst/>
@@ -6074,8 +6329,8 @@
         </p:nvSpPr>
         <p:spPr>
           <a:xfrm>
-            <a:off x="822960" y="685800"/>
-            <a:ext cx="10515600" cy="731520"/>
+            <a:off x="731520" y="640080"/>
+            <a:ext cx="10515600" cy="685800"/>
           </a:xfrm>
           <a:prstGeom prst="rect">
             <a:avLst/>
@@ -6089,14 +6344,14 @@
           <a:lstStyle/>
           <a:p>
             <a:pPr>
-              <a:defRPr sz="2800" b="1">
+              <a:defRPr sz="2600" b="1">
                 <a:solidFill>
                   <a:srgbClr val="FFFFFF"/>
                 </a:solidFill>
               </a:defRPr>
             </a:pPr>
             <a:r>
-              <a:t>Live Demo Flow (3-Minute Winning Playbook)</a:t>
+              <a:t>Live Demo Flow: 5-Step Stage Sequence</a:t>
             </a:r>
           </a:p>
         </p:txBody>
@@ -6109,7 +6364,7 @@
         </p:nvSpPr>
         <p:spPr>
           <a:xfrm>
-            <a:off x="822960" y="1325880"/>
+            <a:off x="731520" y="1234440"/>
             <a:ext cx="10515600" cy="411480"/>
           </a:xfrm>
           <a:prstGeom prst="rect">
@@ -6124,14 +6379,14 @@
           <a:lstStyle/>
           <a:p>
             <a:pPr>
-              <a:defRPr sz="1300">
+              <a:defRPr sz="1200">
                 <a:solidFill>
                   <a:srgbClr val="AAB2C8"/>
                 </a:solidFill>
               </a:defRPr>
             </a:pPr>
             <a:r>
-              <a:t>Chronological live demonstration sequence matching the onstage pitch:</a:t>
+              <a:t>Concise, bulleted 3-minute stage pitch sequence demonstrating instant, zero-cloud capability:</a:t>
             </a:r>
           </a:p>
         </p:txBody>
@@ -6144,8 +6399,8 @@
         </p:nvSpPr>
         <p:spPr>
           <a:xfrm>
-            <a:off x="822960" y="1920240"/>
-            <a:ext cx="10515600" cy="749808"/>
+            <a:off x="731520" y="1783080"/>
+            <a:ext cx="6400800" cy="786384"/>
           </a:xfrm>
           <a:prstGeom prst="roundRect">
             <a:avLst/>
@@ -6174,30 +6429,30 @@
           </a:fontRef>
         </p:style>
         <p:txBody>
-          <a:bodyPr rtlCol="0" anchor="ctr" lIns="274320" tIns="109728"/>
+          <a:bodyPr rtlCol="0" anchor="ctr" lIns="182880" tIns="109728"/>
           <a:lstStyle/>
           <a:p>
             <a:pPr algn="ctr">
-              <a:defRPr sz="1300" b="1">
-                <a:solidFill>
-                  <a:srgbClr val="FFD700"/>
-                </a:solidFill>
-              </a:defRPr>
-            </a:pPr>
-            <a:r>
-              <a:t>1. Eyes-Free Navigation Demo  —  Key [1] / Double-Tap</a:t>
-            </a:r>
-          </a:p>
-          <a:p>
-            <a:pPr>
-              <a:defRPr sz="1000">
+              <a:defRPr sz="1200" b="1">
+                <a:solidFill>
+                  <a:srgbClr val="FFFFFF"/>
+                </a:solidFill>
+              </a:defRPr>
+            </a:pPr>
+            <a:r>
+              <a:t>Step 1: Eyes-Free Navigation</a:t>
+            </a:r>
+          </a:p>
+          <a:p>
+            <a:pPr>
+              <a:defRPr sz="950">
                 <a:solidFill>
                   <a:srgbClr val="AAB2C8"/>
                 </a:solidFill>
               </a:defRPr>
             </a:pPr>
             <a:r>
-              <a:t>Blindfolded walk-through using clock-face spatial guidance + directional haptic pulses.</a:t>
+              <a:t>Start in Eyes-Free Mode — phone camera scans stage, vocalizing 'Podium 4ft at 12 o'clock' with haptic feedback.</a:t>
             </a:r>
           </a:p>
         </p:txBody>
@@ -6210,8 +6465,74 @@
         </p:nvSpPr>
         <p:spPr>
           <a:xfrm>
-            <a:off x="822960" y="2798064"/>
-            <a:ext cx="10515600" cy="749808"/>
+            <a:off x="731520" y="2679191"/>
+            <a:ext cx="6400800" cy="786384"/>
+          </a:xfrm>
+          <a:prstGeom prst="roundRect">
+            <a:avLst/>
+          </a:prstGeom>
+          <a:solidFill>
+            <a:srgbClr val="121520"/>
+          </a:solidFill>
+          <a:ln>
+            <a:solidFill>
+              <a:srgbClr val="FFD700"/>
+            </a:solidFill>
+          </a:ln>
+        </p:spPr>
+        <p:style>
+          <a:lnRef idx="1">
+            <a:schemeClr val="accent1"/>
+          </a:lnRef>
+          <a:fillRef idx="3">
+            <a:schemeClr val="accent1"/>
+          </a:fillRef>
+          <a:effectRef idx="2">
+            <a:schemeClr val="accent1"/>
+          </a:effectRef>
+          <a:fontRef idx="minor">
+            <a:schemeClr val="lt1"/>
+          </a:fontRef>
+        </p:style>
+        <p:txBody>
+          <a:bodyPr rtlCol="0" anchor="ctr" lIns="182880" tIns="109728"/>
+          <a:lstStyle/>
+          <a:p>
+            <a:pPr algn="ctr">
+              <a:defRPr sz="1200" b="1">
+                <a:solidFill>
+                  <a:srgbClr val="FFD700"/>
+                </a:solidFill>
+              </a:defRPr>
+            </a:pPr>
+            <a:r>
+              <a:t>Step 2: The Airplane Mode Proof</a:t>
+            </a:r>
+          </a:p>
+          <a:p>
+            <a:pPr>
+              <a:defRPr sz="950">
+                <a:solidFill>
+                  <a:srgbClr val="AAB2C8"/>
+                </a:solidFill>
+              </a:defRPr>
+            </a:pPr>
+            <a:r>
+              <a:t>Flip phone to Airplane Mode live on stage. Demonstrate continuous real-time guidance with zero Wi-Fi/cellular.</a:t>
+            </a:r>
+          </a:p>
+        </p:txBody>
+      </p:sp>
+      <p:sp>
+        <p:nvSpPr>
+          <p:cNvPr id="8" name="Rounded Rectangle 7"/>
+          <p:cNvSpPr/>
+          <p:nvPr/>
+        </p:nvSpPr>
+        <p:spPr>
+          <a:xfrm>
+            <a:off x="731520" y="3575304"/>
+            <a:ext cx="6400800" cy="786384"/>
           </a:xfrm>
           <a:prstGeom prst="roundRect">
             <a:avLst/>
@@ -6240,44 +6561,44 @@
           </a:fontRef>
         </p:style>
         <p:txBody>
-          <a:bodyPr rtlCol="0" anchor="ctr" lIns="274320" tIns="109728"/>
+          <a:bodyPr rtlCol="0" anchor="ctr" lIns="182880" tIns="109728"/>
           <a:lstStyle/>
           <a:p>
             <a:pPr algn="ctr">
-              <a:defRPr sz="1300" b="1">
-                <a:solidFill>
-                  <a:srgbClr val="F87171"/>
-                </a:solidFill>
-              </a:defRPr>
-            </a:pPr>
-            <a:r>
-              <a:t>2. The Airplane Mode Proof  —  Key [A] (Air-Gapped)</a:t>
-            </a:r>
-          </a:p>
-          <a:p>
-            <a:pPr>
-              <a:defRPr sz="1000">
+              <a:defRPr sz="1200" b="1">
+                <a:solidFill>
+                  <a:srgbClr val="FFFFFF"/>
+                </a:solidFill>
+              </a:defRPr>
+            </a:pPr>
+            <a:r>
+              <a:t>Step 3: Medicine Label Smart-Scan</a:t>
+            </a:r>
+          </a:p>
+          <a:p>
+            <a:pPr>
+              <a:defRPr sz="950">
                 <a:solidFill>
                   <a:srgbClr val="AAB2C8"/>
                 </a:solidFill>
               </a:defRPr>
             </a:pPr>
             <a:r>
-              <a:t>Wi-Fi and cellular switched off live on stage; HUD shows 'Airplane: ON (Air-Gapped)'.</a:t>
-            </a:r>
-          </a:p>
-        </p:txBody>
-      </p:sp>
-      <p:sp>
-        <p:nvSpPr>
-          <p:cNvPr id="8" name="Rounded Rectangle 7"/>
+              <a:t>Hold up a medicine strip (Dolo 650). Instantly reads brand name, dosage, and expiry date — no packaging clutter.</a:t>
+            </a:r>
+          </a:p>
+        </p:txBody>
+      </p:sp>
+      <p:sp>
+        <p:nvSpPr>
+          <p:cNvPr id="9" name="Rounded Rectangle 8"/>
           <p:cNvSpPr/>
           <p:nvPr/>
         </p:nvSpPr>
         <p:spPr>
           <a:xfrm>
-            <a:off x="822960" y="3675887"/>
-            <a:ext cx="10515600" cy="749808"/>
+            <a:off x="731520" y="4471416"/>
+            <a:ext cx="6400800" cy="786384"/>
           </a:xfrm>
           <a:prstGeom prst="roundRect">
             <a:avLst/>
@@ -6306,44 +6627,44 @@
           </a:fontRef>
         </p:style>
         <p:txBody>
-          <a:bodyPr rtlCol="0" anchor="ctr" lIns="274320" tIns="109728"/>
+          <a:bodyPr rtlCol="0" anchor="ctr" lIns="182880" tIns="109728"/>
           <a:lstStyle/>
           <a:p>
             <a:pPr algn="ctr">
-              <a:defRPr sz="1300" b="1">
-                <a:solidFill>
-                  <a:srgbClr val="34C759"/>
-                </a:solidFill>
-              </a:defRPr>
-            </a:pPr>
-            <a:r>
-              <a:t>3. Medicine Label Smart-Scan  —  Key [2] / Swipe Up</a:t>
-            </a:r>
-          </a:p>
-          <a:p>
-            <a:pPr>
-              <a:defRPr sz="1000">
+              <a:defRPr sz="1200" b="1">
+                <a:solidFill>
+                  <a:srgbClr val="FFFFFF"/>
+                </a:solidFill>
+              </a:defRPr>
+            </a:pPr>
+            <a:r>
+              <a:t>Step 4: 'Who's Near Me' Face Recognition</a:t>
+            </a:r>
+          </a:p>
+          <a:p>
+            <a:pPr>
+              <a:defRPr sz="950">
                 <a:solidFill>
                   <a:srgbClr val="AAB2C8"/>
                 </a:solidFill>
               </a:defRPr>
             </a:pPr>
             <a:r>
-              <a:t>Scans noisy Dolo 650 strip in Airplane Mode; reads brand, expiry date, and dosage aloud.</a:t>
-            </a:r>
-          </a:p>
-        </p:txBody>
-      </p:sp>
-      <p:sp>
-        <p:nvSpPr>
-          <p:cNvPr id="9" name="Rounded Rectangle 8"/>
+              <a:t>Teammate steps into frame. Phone vibrates distinct double-heartbeat and whispers contact name discreetly.</a:t>
+            </a:r>
+          </a:p>
+        </p:txBody>
+      </p:sp>
+      <p:sp>
+        <p:nvSpPr>
+          <p:cNvPr id="10" name="Rounded Rectangle 9"/>
           <p:cNvSpPr/>
           <p:nvPr/>
         </p:nvSpPr>
         <p:spPr>
           <a:xfrm>
-            <a:off x="822960" y="4553712"/>
-            <a:ext cx="10515600" cy="749808"/>
+            <a:off x="731520" y="5367528"/>
+            <a:ext cx="6400800" cy="786384"/>
           </a:xfrm>
           <a:prstGeom prst="roundRect">
             <a:avLst/>
@@ -6372,44 +6693,44 @@
           </a:fontRef>
         </p:style>
         <p:txBody>
-          <a:bodyPr rtlCol="0" anchor="ctr" lIns="274320" tIns="109728"/>
+          <a:bodyPr rtlCol="0" anchor="ctr" lIns="182880" tIns="109728"/>
           <a:lstStyle/>
           <a:p>
             <a:pPr algn="ctr">
-              <a:defRPr sz="1300" b="1">
-                <a:solidFill>
-                  <a:srgbClr val="00E5FF"/>
-                </a:solidFill>
-              </a:defRPr>
-            </a:pPr>
-            <a:r>
-              <a:t>4. 'Who's Near Me' Face Recognition  —  Key [4] / Swipe Right</a:t>
-            </a:r>
-          </a:p>
-          <a:p>
-            <a:pPr>
-              <a:defRPr sz="1000">
+              <a:defRPr sz="1200" b="1">
+                <a:solidFill>
+                  <a:srgbClr val="FFFFFF"/>
+                </a:solidFill>
+              </a:defRPr>
+            </a:pPr>
+            <a:r>
+              <a:t>Step 5: Live Latency Benchmark</a:t>
+            </a:r>
+          </a:p>
+          <a:p>
+            <a:pPr>
+              <a:defRPr sz="950">
                 <a:solidFill>
                   <a:srgbClr val="AAB2C8"/>
                 </a:solidFill>
               </a:defRPr>
             </a:pPr>
             <a:r>
-              <a:t>Teammate steps into frame; phone triggers double-heartbeat vibration and whispers name.</a:t>
-            </a:r>
-          </a:p>
-        </p:txBody>
-      </p:sp>
-      <p:sp>
-        <p:nvSpPr>
-          <p:cNvPr id="10" name="Rounded Rectangle 9"/>
+              <a:t>Trigger side-by-side benchmark comparing on-device execution vs. real cloud request to visually prove latency superiority.</a:t>
+            </a:r>
+          </a:p>
+        </p:txBody>
+      </p:sp>
+      <p:sp>
+        <p:nvSpPr>
+          <p:cNvPr id="11" name="Rounded Rectangle 10"/>
           <p:cNvSpPr/>
           <p:nvPr/>
         </p:nvSpPr>
         <p:spPr>
           <a:xfrm>
-            <a:off x="822960" y="5431536"/>
-            <a:ext cx="10515600" cy="749808"/>
+            <a:off x="7406640" y="1783080"/>
+            <a:ext cx="4023360" cy="4434840"/>
           </a:xfrm>
           <a:prstGeom prst="roundRect">
             <a:avLst/>
@@ -6417,7 +6738,7 @@
           <a:solidFill>
             <a:srgbClr val="121520"/>
           </a:solidFill>
-          <a:ln>
+          <a:ln w="15240">
             <a:solidFill>
               <a:srgbClr val="2A3046"/>
             </a:solidFill>
@@ -6438,30 +6759,68 @@
           </a:fontRef>
         </p:style>
         <p:txBody>
-          <a:bodyPr rtlCol="0" anchor="ctr" lIns="274320" tIns="109728"/>
+          <a:bodyPr rtlCol="0" anchor="ctr"/>
+          <a:lstStyle/>
+          <a:p>
+            <a:pPr algn="ctr"/>
+          </a:p>
+        </p:txBody>
+      </p:sp>
+      <p:pic>
+        <p:nvPicPr>
+          <p:cNvPr id="12" name="Picture 11" descr="iqoo-spatial-hallway.jpg"/>
+          <p:cNvPicPr>
+            <a:picLocks noChangeAspect="1"/>
+          </p:cNvPicPr>
+          <p:nvPr/>
+        </p:nvPicPr>
+        <p:blipFill>
+          <a:blip r:embed="rId2"/>
+          <a:stretch>
+            <a:fillRect/>
+          </a:stretch>
+        </p:blipFill>
+        <p:spPr>
+          <a:xfrm>
+            <a:off x="7479792" y="1856232"/>
+            <a:ext cx="3877056" cy="3840480"/>
+          </a:xfrm>
+          <a:prstGeom prst="rect">
+            <a:avLst/>
+          </a:prstGeom>
+        </p:spPr>
+      </p:pic>
+      <p:sp>
+        <p:nvSpPr>
+          <p:cNvPr id="13" name="TextBox 12"/>
+          <p:cNvSpPr txBox="1"/>
+          <p:nvPr/>
+        </p:nvSpPr>
+        <p:spPr>
+          <a:xfrm>
+            <a:off x="7543800" y="5715000"/>
+            <a:ext cx="3749040" cy="457200"/>
+          </a:xfrm>
+          <a:prstGeom prst="rect">
+            <a:avLst/>
+          </a:prstGeom>
+          <a:noFill/>
+        </p:spPr>
+        <p:txBody>
+          <a:bodyPr wrap="square">
+            <a:spAutoFit/>
+          </a:bodyPr>
           <a:lstStyle/>
           <a:p>
             <a:pPr algn="ctr">
-              <a:defRPr sz="1300" b="1">
-                <a:solidFill>
-                  <a:srgbClr val="FF6F00"/>
-                </a:solidFill>
-              </a:defRPr>
-            </a:pPr>
-            <a:r>
-              <a:t>5. Live Latency Benchmark  —  Key [3] / Key [B]</a:t>
-            </a:r>
-          </a:p>
-          <a:p>
-            <a:pPr>
-              <a:defRPr sz="1000">
-                <a:solidFill>
-                  <a:srgbClr val="AAB2C8"/>
-                </a:solidFill>
-              </a:defRPr>
-            </a:pPr>
-            <a:r>
-              <a:t>Real cloud API call vs. local NPU stopwatch; proves local execution is an order of magnitude faster.</a:t>
+              <a:defRPr sz="950" b="1">
+                <a:solidFill>
+                  <a:srgbClr val="FFD700"/>
+                </a:solidFill>
+              </a:defRPr>
+            </a:pPr>
+            <a:r>
+              <a:t>iQOO On-Device Spatial Guidance: 12-Sector Radar &amp; Obstacle HUD</a:t>
             </a:r>
           </a:p>
         </p:txBody>
@@ -6535,8 +6894,8 @@
         </p:nvSpPr>
         <p:spPr>
           <a:xfrm>
-            <a:off x="822960" y="411480"/>
-            <a:ext cx="9144000" cy="320040"/>
+            <a:off x="731520" y="365760"/>
+            <a:ext cx="10515600" cy="320040"/>
           </a:xfrm>
           <a:prstGeom prst="rect">
             <a:avLst/>
@@ -6570,8 +6929,8 @@
         </p:nvSpPr>
         <p:spPr>
           <a:xfrm>
-            <a:off x="822960" y="685800"/>
-            <a:ext cx="10515600" cy="731520"/>
+            <a:off x="731520" y="640080"/>
+            <a:ext cx="10515600" cy="685800"/>
           </a:xfrm>
           <a:prstGeom prst="rect">
             <a:avLst/>
@@ -6585,14 +6944,14 @@
           <a:lstStyle/>
           <a:p>
             <a:pPr>
-              <a:defRPr sz="2800" b="1">
+              <a:defRPr sz="2600" b="1">
                 <a:solidFill>
                   <a:srgbClr val="FFFFFF"/>
                 </a:solidFill>
               </a:defRPr>
             </a:pPr>
             <a:r>
-              <a:t>Impact: Why Drishti Matters</a:t>
+              <a:t>Impact &amp; Why It Matters: Smart Living For All</a:t>
             </a:r>
           </a:p>
         </p:txBody>
@@ -6605,7 +6964,7 @@
         </p:nvSpPr>
         <p:spPr>
           <a:xfrm>
-            <a:off x="822960" y="1325880"/>
+            <a:off x="731520" y="1234440"/>
             <a:ext cx="10515600" cy="411480"/>
           </a:xfrm>
           <a:prstGeom prst="rect">
@@ -6620,14 +6979,14 @@
           <a:lstStyle/>
           <a:p>
             <a:pPr>
-              <a:defRPr sz="1300">
+              <a:defRPr sz="1200">
                 <a:solidFill>
                   <a:srgbClr val="AAB2C8"/>
                 </a:solidFill>
               </a:defRPr>
             </a:pPr>
             <a:r>
-              <a:t>Designed for genuine independence and economic accessibility across India:</a:t>
+              <a:t>Drishti transforms smartphones into private, reliable sensory prosthetics that empower everyday independence:</a:t>
             </a:r>
           </a:p>
         </p:txBody>
@@ -6640,8 +6999,112 @@
         </p:nvSpPr>
         <p:spPr>
           <a:xfrm>
-            <a:off x="822960" y="1920240"/>
-            <a:ext cx="3364992" cy="4297680"/>
+            <a:off x="731520" y="1783080"/>
+            <a:ext cx="4114800" cy="4526280"/>
+          </a:xfrm>
+          <a:prstGeom prst="roundRect">
+            <a:avLst/>
+          </a:prstGeom>
+          <a:solidFill>
+            <a:srgbClr val="121520"/>
+          </a:solidFill>
+          <a:ln w="15240">
+            <a:solidFill>
+              <a:srgbClr val="2A3046"/>
+            </a:solidFill>
+          </a:ln>
+        </p:spPr>
+        <p:style>
+          <a:lnRef idx="1">
+            <a:schemeClr val="accent1"/>
+          </a:lnRef>
+          <a:fillRef idx="3">
+            <a:schemeClr val="accent1"/>
+          </a:fillRef>
+          <a:effectRef idx="2">
+            <a:schemeClr val="accent1"/>
+          </a:effectRef>
+          <a:fontRef idx="minor">
+            <a:schemeClr val="lt1"/>
+          </a:fontRef>
+        </p:style>
+        <p:txBody>
+          <a:bodyPr rtlCol="0" anchor="ctr"/>
+          <a:lstStyle/>
+          <a:p>
+            <a:pPr algn="ctr"/>
+          </a:p>
+        </p:txBody>
+      </p:sp>
+      <p:pic>
+        <p:nvPicPr>
+          <p:cNvPr id="7" name="Picture 6" descr="elderly-medicine-scan.jpg"/>
+          <p:cNvPicPr>
+            <a:picLocks noChangeAspect="1"/>
+          </p:cNvPicPr>
+          <p:nvPr/>
+        </p:nvPicPr>
+        <p:blipFill>
+          <a:blip r:embed="rId2"/>
+          <a:stretch>
+            <a:fillRect/>
+          </a:stretch>
+        </p:blipFill>
+        <p:spPr>
+          <a:xfrm>
+            <a:off x="804672" y="1856232"/>
+            <a:ext cx="3968496" cy="3931920"/>
+          </a:xfrm>
+          <a:prstGeom prst="rect">
+            <a:avLst/>
+          </a:prstGeom>
+        </p:spPr>
+      </p:pic>
+      <p:sp>
+        <p:nvSpPr>
+          <p:cNvPr id="8" name="TextBox 7"/>
+          <p:cNvSpPr txBox="1"/>
+          <p:nvPr/>
+        </p:nvSpPr>
+        <p:spPr>
+          <a:xfrm>
+            <a:off x="868680" y="5806440"/>
+            <a:ext cx="3840480" cy="457200"/>
+          </a:xfrm>
+          <a:prstGeom prst="rect">
+            <a:avLst/>
+          </a:prstGeom>
+          <a:noFill/>
+        </p:spPr>
+        <p:txBody>
+          <a:bodyPr wrap="square">
+            <a:spAutoFit/>
+          </a:bodyPr>
+          <a:lstStyle/>
+          <a:p>
+            <a:pPr algn="ctr">
+              <a:defRPr sz="950" b="1">
+                <a:solidFill>
+                  <a:srgbClr val="FFD700"/>
+                </a:solidFill>
+              </a:defRPr>
+            </a:pPr>
+            <a:r>
+              <a:t>Everyday Independence: Empowering elderly &amp; visually impaired users at home</a:t>
+            </a:r>
+          </a:p>
+        </p:txBody>
+      </p:sp>
+      <p:sp>
+        <p:nvSpPr>
+          <p:cNvPr id="9" name="Rounded Rectangle 8"/>
+          <p:cNvSpPr/>
+          <p:nvPr/>
+        </p:nvSpPr>
+        <p:spPr>
+          <a:xfrm>
+            <a:off x="5029200" y="1783080"/>
+            <a:ext cx="6492240" cy="1371600"/>
           </a:xfrm>
           <a:prstGeom prst="roundRect">
             <a:avLst/>
@@ -6670,26 +7133,26 @@
           </a:fontRef>
         </p:style>
         <p:txBody>
-          <a:bodyPr rtlCol="0" anchor="ctr" wrap="square" lIns="274320" rIns="274320" tIns="256032" bIns="228600"/>
+          <a:bodyPr rtlCol="0" anchor="ctr" wrap="square" lIns="228600" rIns="228600" tIns="201168" bIns="182880"/>
           <a:lstStyle/>
           <a:p>
             <a:pPr algn="ctr">
-              <a:defRPr sz="900" b="1">
+              <a:defRPr sz="850" b="1">
                 <a:solidFill>
                   <a:srgbClr val="FFD700"/>
                 </a:solidFill>
               </a:defRPr>
             </a:pPr>
             <a:r>
-              <a:t>TRUE AUTONOMY</a:t>
+              <a:t>PILLAR 1</a:t>
             </a:r>
           </a:p>
           <a:p>
             <a:pPr>
               <a:spcAft>
-                <a:spcPts val="800"/>
+                <a:spcPts val="600"/>
               </a:spcAft>
-              <a:defRPr sz="1600" b="1">
+              <a:defRPr sz="1400" b="1">
                 <a:solidFill>
                   <a:srgbClr val="FFFFFF"/>
                 </a:solidFill>
@@ -6702,75 +7165,60 @@
           <a:p>
             <a:pPr>
               <a:spcAft>
-                <a:spcPts val="400"/>
+                <a:spcPts val="300"/>
               </a:spcAft>
-              <a:defRPr sz="1100">
+              <a:defRPr sz="1000">
                 <a:solidFill>
                   <a:srgbClr val="AAB2C8"/>
                 </a:solidFill>
               </a:defRPr>
             </a:pPr>
             <a:r>
-              <a:t>•  Empowers users in daily essential tasks: walking safely, reading medicines, and recognizing friends.</a:t>
+              <a:t>•  Enables visually impaired individuals to navigate unfamiliar indoor/outdoor spaces safely.</a:t>
             </a:r>
           </a:p>
           <a:p>
             <a:pPr>
               <a:spcAft>
-                <a:spcPts val="400"/>
+                <a:spcPts val="300"/>
               </a:spcAft>
-              <a:defRPr sz="1100">
+              <a:defRPr sz="1000">
                 <a:solidFill>
                   <a:srgbClr val="AAB2C8"/>
                 </a:solidFill>
               </a:defRPr>
             </a:pPr>
             <a:r>
-              <a:t>•  Removes reliance on sighted chaperones or remote commercial call centers.</a:t>
+              <a:t>•  Empowers independent reading of daily medicines, food packaging, and transit signs.</a:t>
             </a:r>
           </a:p>
           <a:p>
             <a:pPr>
               <a:spcAft>
-                <a:spcPts val="400"/>
+                <a:spcPts val="300"/>
               </a:spcAft>
-              <a:defRPr sz="1100">
+              <a:defRPr sz="1000">
                 <a:solidFill>
                   <a:srgbClr val="AAB2C8"/>
                 </a:solidFill>
               </a:defRPr>
             </a:pPr>
             <a:r>
-              <a:t>•  Provides constant spatial awareness with zero cognitive overload.</a:t>
-            </a:r>
-          </a:p>
-          <a:p>
-            <a:pPr>
-              <a:spcAft>
-                <a:spcPts val="400"/>
-              </a:spcAft>
-              <a:defRPr sz="1100">
-                <a:solidFill>
-                  <a:srgbClr val="AAB2C8"/>
-                </a:solidFill>
-              </a:defRPr>
-            </a:pPr>
-            <a:r>
-              <a:t>•  Dignity through autonomous, private assistive technology.</a:t>
-            </a:r>
-          </a:p>
-        </p:txBody>
-      </p:sp>
-      <p:sp>
-        <p:nvSpPr>
-          <p:cNvPr id="7" name="Rounded Rectangle 6"/>
+              <a:t>•  Restores personal dignity without relying on sighted assistants or chaperones.</a:t>
+            </a:r>
+          </a:p>
+        </p:txBody>
+      </p:sp>
+      <p:sp>
+        <p:nvSpPr>
+          <p:cNvPr id="10" name="Rounded Rectangle 9"/>
           <p:cNvSpPr/>
           <p:nvPr/>
         </p:nvSpPr>
         <p:spPr>
           <a:xfrm>
-            <a:off x="4389120" y="1920240"/>
-            <a:ext cx="3364992" cy="4297680"/>
+            <a:off x="5029200" y="3337560"/>
+            <a:ext cx="6492240" cy="1371600"/>
           </a:xfrm>
           <a:prstGeom prst="roundRect">
             <a:avLst/>
@@ -6799,107 +7247,92 @@
           </a:fontRef>
         </p:style>
         <p:txBody>
-          <a:bodyPr rtlCol="0" anchor="ctr" wrap="square" lIns="274320" rIns="274320" tIns="256032" bIns="228600"/>
+          <a:bodyPr rtlCol="0" anchor="ctr" wrap="square" lIns="228600" rIns="228600" tIns="201168" bIns="182880"/>
           <a:lstStyle/>
           <a:p>
             <a:pPr algn="ctr">
-              <a:defRPr sz="900" b="1">
+              <a:defRPr sz="850" b="1">
                 <a:solidFill>
                   <a:srgbClr val="34C759"/>
                 </a:solidFill>
               </a:defRPr>
             </a:pPr>
             <a:r>
-              <a:t>HARDWARE EQUITY</a:t>
+              <a:t>PILLAR 2</a:t>
             </a:r>
           </a:p>
           <a:p>
             <a:pPr>
               <a:spcAft>
-                <a:spcPts val="800"/>
+                <a:spcPts val="600"/>
               </a:spcAft>
-              <a:defRPr sz="1600" b="1">
+              <a:defRPr sz="1400" b="1">
                 <a:solidFill>
                   <a:srgbClr val="FFFFFF"/>
                 </a:solidFill>
               </a:defRPr>
             </a:pPr>
             <a:r>
-              <a:t>🇮🇳  Accessible to All Incomes</a:t>
+              <a:t>📱  Works on Budget Phones</a:t>
             </a:r>
           </a:p>
           <a:p>
             <a:pPr>
               <a:spcAft>
-                <a:spcPts val="400"/>
+                <a:spcPts val="300"/>
               </a:spcAft>
-              <a:defRPr sz="1100">
+              <a:defRPr sz="1000">
                 <a:solidFill>
                   <a:srgbClr val="AAB2C8"/>
                 </a:solidFill>
               </a:defRPr>
             </a:pPr>
             <a:r>
-              <a:t>•  Works on affordable budget/mid-range phones (MediaTek Dimensity), not just luxury flagships.</a:t>
+              <a:t>•  Not locked behind expensive $1,000+ proprietary smart glasses or flagship silicon.</a:t>
             </a:r>
           </a:p>
           <a:p>
             <a:pPr>
               <a:spcAft>
-                <a:spcPts val="400"/>
+                <a:spcPts val="300"/>
               </a:spcAft>
-              <a:defRPr sz="1100">
+              <a:defRPr sz="1000">
                 <a:solidFill>
                   <a:srgbClr val="AAB2C8"/>
                 </a:solidFill>
               </a:defRPr>
             </a:pPr>
             <a:r>
-              <a:t>•  Brings high-performance edge AI to users who cannot afford ₹80,000 devices.</a:t>
+              <a:t>•  Tiered model strategy ensures accessibility on budget and mid-range devices across India.</a:t>
             </a:r>
           </a:p>
           <a:p>
             <a:pPr>
               <a:spcAft>
-                <a:spcPts val="400"/>
+                <a:spcPts val="300"/>
               </a:spcAft>
-              <a:defRPr sz="1100">
+              <a:defRPr sz="1000">
                 <a:solidFill>
                   <a:srgbClr val="AAB2C8"/>
                 </a:solidFill>
               </a:defRPr>
             </a:pPr>
             <a:r>
-              <a:t>•  Multi-lingual: Supports 7 major Indian languages (Telugu, Hindi, Tamil, etc.).</a:t>
-            </a:r>
-          </a:p>
-          <a:p>
-            <a:pPr>
-              <a:spcAft>
-                <a:spcPts val="400"/>
-              </a:spcAft>
-              <a:defRPr sz="1100">
-                <a:solidFill>
-                  <a:srgbClr val="AAB2C8"/>
-                </a:solidFill>
-              </a:defRPr>
-            </a:pPr>
-            <a:r>
-              <a:t>•  Inclusive by design for Indian socioeconomic realities.</a:t>
-            </a:r>
-          </a:p>
-        </p:txBody>
-      </p:sp>
-      <p:sp>
-        <p:nvSpPr>
-          <p:cNvPr id="8" name="Rounded Rectangle 7"/>
+              <a:t>•  Democratizes assistive technology for underserved socio-economic communities.</a:t>
+            </a:r>
+          </a:p>
+        </p:txBody>
+      </p:sp>
+      <p:sp>
+        <p:nvSpPr>
+          <p:cNvPr id="11" name="Rounded Rectangle 10"/>
           <p:cNvSpPr/>
           <p:nvPr/>
         </p:nvSpPr>
         <p:spPr>
           <a:xfrm>
-            <a:off x="7955279" y="1920240"/>
-            <a:ext cx="3364992" cy="4297680"/>
+            <a:off x="5029200" y="4892040"/>
+            <a:ext cx="6492240" cy="1371600"/>
           </a:xfrm>
           <a:prstGeom prst="roundRect">
             <a:avLst/>
@@ -6928,93 +7361,78 @@
           </a:fontRef>
         </p:style>
         <p:txBody>
-          <a:bodyPr rtlCol="0" anchor="ctr" wrap="square" lIns="274320" rIns="274320" tIns="256032" bIns="228600"/>
+          <a:bodyPr rtlCol="0" anchor="ctr" wrap="square" lIns="228600" rIns="228600" tIns="201168" bIns="182880"/>
           <a:lstStyle/>
           <a:p>
             <a:pPr algn="ctr">
-              <a:defRPr sz="900" b="1">
+              <a:defRPr sz="850" b="1">
                 <a:solidFill>
                   <a:srgbClr val="00E5FF"/>
                 </a:solidFill>
               </a:defRPr>
             </a:pPr>
             <a:r>
-              <a:t>PERMANENT FREEDOM</a:t>
+              <a:t>PILLAR 3</a:t>
             </a:r>
           </a:p>
           <a:p>
             <a:pPr>
               <a:spcAft>
-                <a:spcPts val="800"/>
+                <a:spcPts val="600"/>
               </a:spcAft>
-              <a:defRPr sz="1600" b="1">
+              <a:defRPr sz="1400" b="1">
                 <a:solidFill>
                   <a:srgbClr val="FFFFFF"/>
                 </a:solidFill>
               </a:defRPr>
             </a:pPr>
             <a:r>
-              <a:t>🛡️  Zero Subscriptions &amp; Zero Data Harvesting</a:t>
+              <a:t>🛡️  No Subscriptions, Data Harvesting, or Cloud Dependency</a:t>
             </a:r>
           </a:p>
           <a:p>
             <a:pPr>
               <a:spcAft>
-                <a:spcPts val="400"/>
+                <a:spcPts val="300"/>
               </a:spcAft>
-              <a:defRPr sz="1100">
+              <a:defRPr sz="1000">
                 <a:solidFill>
                   <a:srgbClr val="AAB2C8"/>
                 </a:solidFill>
               </a:defRPr>
             </a:pPr>
             <a:r>
-              <a:t>•  No monthly API subscription fees or paywalled accessibility features.</a:t>
+              <a:t>•  Zero recurring monthly API fees or corporate subscription paywalls.</a:t>
             </a:r>
           </a:p>
           <a:p>
             <a:pPr>
               <a:spcAft>
-                <a:spcPts val="400"/>
+                <a:spcPts val="300"/>
               </a:spcAft>
-              <a:defRPr sz="1100">
+              <a:defRPr sz="1000">
                 <a:solidFill>
                   <a:srgbClr val="AAB2C8"/>
                 </a:solidFill>
               </a:defRPr>
             </a:pPr>
             <a:r>
-              <a:t>•  No corporate surveillance or harvesting of private household feeds.</a:t>
+              <a:t>•  Zero monetization of sensitive user camera feeds or personal biometric data.</a:t>
             </a:r>
           </a:p>
           <a:p>
             <a:pPr>
               <a:spcAft>
-                <a:spcPts val="400"/>
+                <a:spcPts val="300"/>
               </a:spcAft>
-              <a:defRPr sz="1100">
+              <a:defRPr sz="1000">
                 <a:solidFill>
                   <a:srgbClr val="AAB2C8"/>
                 </a:solidFill>
               </a:defRPr>
             </a:pPr>
             <a:r>
-              <a:t>•  No internet dependency — works in elevators, rural farms, and basements.</a:t>
-            </a:r>
-          </a:p>
-          <a:p>
-            <a:pPr>
-              <a:spcAft>
-                <a:spcPts val="400"/>
-              </a:spcAft>
-              <a:defRPr sz="1100">
-                <a:solidFill>
-                  <a:srgbClr val="AAB2C8"/>
-                </a:solidFill>
-              </a:defRPr>
-            </a:pPr>
-            <a:r>
-              <a:t>•  A one-time, private, always-available assistive tool.</a:t>
+              <a:t>•  Complete reliability in offline transit corridors, rural villages, and emergency situations.</a:t>
             </a:r>
           </a:p>
         </p:txBody>
@@ -7088,8 +7506,8 @@
         </p:nvSpPr>
         <p:spPr>
           <a:xfrm>
-            <a:off x="822960" y="1097280"/>
-            <a:ext cx="5486400" cy="438912"/>
+            <a:off x="731520" y="1097280"/>
+            <a:ext cx="5486400" cy="384048"/>
           </a:xfrm>
           <a:prstGeom prst="roundRect">
             <a:avLst/>
@@ -7122,7 +7540,7 @@
           <a:lstStyle/>
           <a:p>
             <a:pPr algn="ctr">
-              <a:defRPr sz="1000" b="1">
+              <a:defRPr sz="950" b="1">
                 <a:solidFill>
                   <a:srgbClr val="FFD700"/>
                 </a:solidFill>
@@ -7142,8 +7560,8 @@
         </p:nvSpPr>
         <p:spPr>
           <a:xfrm>
-            <a:off x="822960" y="1737360"/>
-            <a:ext cx="10515600" cy="1371600"/>
+            <a:off x="731520" y="1645920"/>
+            <a:ext cx="5669280" cy="1188720"/>
           </a:xfrm>
           <a:prstGeom prst="rect">
             <a:avLst/>
@@ -7157,7 +7575,7 @@
           <a:lstStyle/>
           <a:p>
             <a:pPr>
-              <a:defRPr sz="6400" b="1">
+              <a:defRPr sz="5600" b="1">
                 <a:solidFill>
                   <a:srgbClr val="FFFFFF"/>
                 </a:solidFill>
@@ -7169,17 +7587,14 @@
           </a:p>
           <a:p>
             <a:pPr>
-              <a:spcBef>
-                <a:spcPts val="400"/>
-              </a:spcBef>
-              <a:defRPr sz="1800">
+              <a:defRPr sz="1700">
                 <a:solidFill>
                   <a:srgbClr val="FFD700"/>
                 </a:solidFill>
               </a:defRPr>
             </a:pPr>
             <a:r>
-              <a:t>“An instant, private, offline sensory companion for the visually impaired”</a:t>
+              <a:t>दृष्टि  •  On-Device AI Sensory Companion</a:t>
             </a:r>
           </a:p>
         </p:txBody>
@@ -7192,8 +7607,8 @@
         </p:nvSpPr>
         <p:spPr>
           <a:xfrm>
-            <a:off x="822960" y="3383280"/>
-            <a:ext cx="10515600" cy="1188720"/>
+            <a:off x="731520" y="3108960"/>
+            <a:ext cx="5669280" cy="1280160"/>
           </a:xfrm>
           <a:prstGeom prst="roundRect">
             <a:avLst/>
@@ -7222,18 +7637,22 @@
           </a:fontRef>
         </p:style>
         <p:txBody>
-          <a:bodyPr rtlCol="0" anchor="ctr" tIns="320040"/>
+          <a:bodyPr rtlCol="0" anchor="ctr" lIns="274320" tIns="228600"/>
           <a:lstStyle/>
           <a:p>
             <a:pPr algn="ctr">
-              <a:defRPr sz="2200" b="1">
+              <a:defRPr sz="1800" b="1">
                 <a:solidFill>
                   <a:srgbClr val="FFF0B4"/>
                 </a:solidFill>
               </a:defRPr>
             </a:pPr>
             <a:r>
-              <a:t>“Built entirely on-device. Built entirely for independence.”</a:t>
+              <a:t>“Built entirely on-device.</a:t>
+            </a:r>
+            <a:br/>
+            <a:r>
+              <a:t>Built entirely for independence.”</a:t>
             </a:r>
           </a:p>
         </p:txBody>
@@ -7246,8 +7665,8 @@
         </p:nvSpPr>
         <p:spPr>
           <a:xfrm>
-            <a:off x="822960" y="4800600"/>
-            <a:ext cx="10515600" cy="1371600"/>
+            <a:off x="731520" y="4617720"/>
+            <a:ext cx="5669280" cy="1600200"/>
           </a:xfrm>
           <a:prstGeom prst="roundRect">
             <a:avLst/>
@@ -7276,7 +7695,7 @@
           </a:fontRef>
         </p:style>
         <p:txBody>
-          <a:bodyPr rtlCol="0" anchor="ctr" lIns="365760" tIns="201168"/>
+          <a:bodyPr rtlCol="0" anchor="ctr" lIns="274320" tIns="182880"/>
           <a:lstStyle/>
           <a:p>
             <a:pPr algn="ctr">
@@ -7295,26 +7714,145 @@
               <a:spcBef>
                 <a:spcPts val="400"/>
               </a:spcBef>
-              <a:defRPr sz="1100">
+              <a:defRPr sz="1050">
+                <a:solidFill>
+                  <a:srgbClr val="FFD700"/>
+                </a:solidFill>
+              </a:defRPr>
+            </a:pPr>
+            <a:r>
+              <a:t>Track: Smart Living / Accessibility Tech (Hyderabad City Battle)</a:t>
+            </a:r>
+          </a:p>
+          <a:p>
+            <a:pPr>
+              <a:spcBef>
+                <a:spcPts val="300"/>
+              </a:spcBef>
+              <a:defRPr sz="1000">
+                <a:solidFill>
+                  <a:srgbClr val="AAB2C8"/>
+                </a:solidFill>
+              </a:defRPr>
+            </a:pPr>
+            <a:r>
+              <a:t>GitHub: https://github.com/M-L-Arjun/drishti-ai</a:t>
+            </a:r>
+          </a:p>
+          <a:p>
+            <a:pPr>
+              <a:defRPr sz="1000">
                 <a:solidFill>
                   <a:srgbClr val="00E5FF"/>
                 </a:solidFill>
               </a:defRPr>
             </a:pPr>
             <a:r>
-              <a:t>🌐 Live App: https://drishti-seven-mu.vercel.app  •  Presentation: https://drishti-seven-mu.vercel.app/pitch</a:t>
-            </a:r>
-          </a:p>
-          <a:p>
-            <a:pPr>
-              <a:defRPr sz="1100">
-                <a:solidFill>
-                  <a:srgbClr val="AAB2C8"/>
-                </a:solidFill>
-              </a:defRPr>
-            </a:pPr>
-            <a:r>
-              <a:t>📦 GitHub: https://github.com/M-L-Arjun/drishti-ai  •  111 Unit Tests Passing (100% Offline)</a:t>
+              <a:t>Live App: https://drishti-seven-mu.vercel.app</a:t>
+            </a:r>
+          </a:p>
+        </p:txBody>
+      </p:sp>
+      <p:sp>
+        <p:nvSpPr>
+          <p:cNvPr id="7" name="Rounded Rectangle 6"/>
+          <p:cNvSpPr/>
+          <p:nvPr/>
+        </p:nvSpPr>
+        <p:spPr>
+          <a:xfrm>
+            <a:off x="6766560" y="1097280"/>
+            <a:ext cx="4663440" cy="5120640"/>
+          </a:xfrm>
+          <a:prstGeom prst="roundRect">
+            <a:avLst/>
+          </a:prstGeom>
+          <a:solidFill>
+            <a:srgbClr val="121520"/>
+          </a:solidFill>
+          <a:ln w="15240">
+            <a:solidFill>
+              <a:srgbClr val="2A3046"/>
+            </a:solidFill>
+          </a:ln>
+        </p:spPr>
+        <p:style>
+          <a:lnRef idx="1">
+            <a:schemeClr val="accent1"/>
+          </a:lnRef>
+          <a:fillRef idx="3">
+            <a:schemeClr val="accent1"/>
+          </a:fillRef>
+          <a:effectRef idx="2">
+            <a:schemeClr val="accent1"/>
+          </a:effectRef>
+          <a:fontRef idx="minor">
+            <a:schemeClr val="lt1"/>
+          </a:fontRef>
+        </p:style>
+        <p:txBody>
+          <a:bodyPr rtlCol="0" anchor="ctr"/>
+          <a:lstStyle/>
+          <a:p>
+            <a:pPr algn="ctr"/>
+          </a:p>
+        </p:txBody>
+      </p:sp>
+      <p:pic>
+        <p:nvPicPr>
+          <p:cNvPr id="8" name="Picture 7" descr="visually-impaired-nav.jpg"/>
+          <p:cNvPicPr>
+            <a:picLocks noChangeAspect="1"/>
+          </p:cNvPicPr>
+          <p:nvPr/>
+        </p:nvPicPr>
+        <p:blipFill>
+          <a:blip r:embed="rId2"/>
+          <a:stretch>
+            <a:fillRect/>
+          </a:stretch>
+        </p:blipFill>
+        <p:spPr>
+          <a:xfrm>
+            <a:off x="6839712" y="1170432"/>
+            <a:ext cx="4517136" cy="4526280"/>
+          </a:xfrm>
+          <a:prstGeom prst="rect">
+            <a:avLst/>
+          </a:prstGeom>
+        </p:spPr>
+      </p:pic>
+      <p:sp>
+        <p:nvSpPr>
+          <p:cNvPr id="9" name="TextBox 8"/>
+          <p:cNvSpPr txBox="1"/>
+          <p:nvPr/>
+        </p:nvSpPr>
+        <p:spPr>
+          <a:xfrm>
+            <a:off x="6903720" y="5715000"/>
+            <a:ext cx="4389120" cy="457200"/>
+          </a:xfrm>
+          <a:prstGeom prst="rect">
+            <a:avLst/>
+          </a:prstGeom>
+          <a:noFill/>
+        </p:spPr>
+        <p:txBody>
+          <a:bodyPr wrap="square">
+            <a:spAutoFit/>
+          </a:bodyPr>
+          <a:lstStyle/>
+          <a:p>
+            <a:pPr algn="ctr">
+              <a:defRPr sz="950" b="1">
+                <a:solidFill>
+                  <a:srgbClr val="FFD700"/>
+                </a:solidFill>
+              </a:defRPr>
+            </a:pPr>
+            <a:r>
+              <a:t>Drishti: Empowering visually impaired individuals with on-device AI</a:t>
             </a:r>
           </a:p>
         </p:txBody>

</xml_diff>

<commit_message>
Replace synthetic images with authentic web-based documentary photography and refine layout alignment
</commit_message>
<xml_diff>
--- a/Drishti_Pitch_Deck.pptx
+++ b/Drishti_Pitch_Deck.pptx
@@ -3110,7 +3110,7 @@
             <a:avLst/>
           </a:prstGeom>
           <a:solidFill>
-            <a:srgbClr val="05060A"/>
+            <a:srgbClr val="07090F"/>
           </a:solidFill>
           <a:ln>
             <a:noFill/>
@@ -3146,14 +3146,14 @@
         </p:nvSpPr>
         <p:spPr>
           <a:xfrm>
-            <a:off x="731520" y="777240"/>
-            <a:ext cx="5303520" cy="384048"/>
+            <a:off x="731520" y="822960"/>
+            <a:ext cx="5303520" cy="365760"/>
           </a:xfrm>
           <a:prstGeom prst="roundRect">
             <a:avLst/>
           </a:prstGeom>
           <a:solidFill>
-            <a:srgbClr val="19160A"/>
+            <a:srgbClr val="16140A"/>
           </a:solidFill>
           <a:ln>
             <a:solidFill>
@@ -3200,8 +3200,8 @@
         </p:nvSpPr>
         <p:spPr>
           <a:xfrm>
-            <a:off x="731520" y="1280160"/>
-            <a:ext cx="5943600" cy="1371600"/>
+            <a:off x="731520" y="1325880"/>
+            <a:ext cx="5486400" cy="1280160"/>
           </a:xfrm>
           <a:prstGeom prst="rect">
             <a:avLst/>
@@ -3209,13 +3209,13 @@
           <a:noFill/>
         </p:spPr>
         <p:txBody>
-          <a:bodyPr wrap="none">
+          <a:bodyPr wrap="none" lIns="0" rIns="0" tIns="0" bIns="0">
             <a:spAutoFit/>
           </a:bodyPr>
           <a:lstStyle/>
           <a:p>
             <a:pPr>
-              <a:defRPr sz="5600" b="1">
+              <a:defRPr sz="5800" b="1">
                 <a:solidFill>
                   <a:srgbClr val="FFFFFF"/>
                 </a:solidFill>
@@ -3230,14 +3230,14 @@
               <a:spcBef>
                 <a:spcPts val="400"/>
               </a:spcBef>
-              <a:defRPr sz="1700">
+              <a:defRPr sz="1600">
                 <a:solidFill>
                   <a:srgbClr val="FFD700"/>
                 </a:solidFill>
               </a:defRPr>
             </a:pPr>
             <a:r>
-              <a:t>दृष्टि  •  On-Device Sensory Companion</a:t>
+              <a:t>दृष्टि  •  Phone-First On-Device AI Sensory Companion</a:t>
             </a:r>
           </a:p>
         </p:txBody>
@@ -3250,14 +3250,14 @@
         </p:nvSpPr>
         <p:spPr>
           <a:xfrm>
-            <a:off x="731520" y="2926080"/>
-            <a:ext cx="6035040" cy="1280160"/>
+            <a:off x="731520" y="2834640"/>
+            <a:ext cx="5486400" cy="1234440"/>
           </a:xfrm>
           <a:prstGeom prst="roundRect">
             <a:avLst/>
           </a:prstGeom>
           <a:solidFill>
-            <a:srgbClr val="121520"/>
+            <a:srgbClr val="10141E"/>
           </a:solidFill>
           <a:ln>
             <a:solidFill>
@@ -3280,11 +3280,11 @@
           </a:fontRef>
         </p:style>
         <p:txBody>
-          <a:bodyPr rtlCol="0" anchor="ctr" lIns="274320" tIns="228600"/>
+          <a:bodyPr rtlCol="0" anchor="ctr" lIns="256032" tIns="201168"/>
           <a:lstStyle/>
           <a:p>
             <a:pPr algn="ctr">
-              <a:defRPr sz="1700" b="1">
+              <a:defRPr sz="1650" b="1">
                 <a:solidFill>
                   <a:srgbClr val="FFF0B4"/>
                 </a:solidFill>
@@ -3304,18 +3304,18 @@
         </p:nvSpPr>
         <p:spPr>
           <a:xfrm>
-            <a:off x="731520" y="4434840"/>
-            <a:ext cx="2926080" cy="868680"/>
+            <a:off x="731520" y="4297680"/>
+            <a:ext cx="2697480" cy="868680"/>
           </a:xfrm>
           <a:prstGeom prst="roundRect">
             <a:avLst/>
           </a:prstGeom>
           <a:solidFill>
-            <a:srgbClr val="121520"/>
+            <a:srgbClr val="10141E"/>
           </a:solidFill>
           <a:ln>
             <a:solidFill>
-              <a:srgbClr val="2A3046"/>
+              <a:srgbClr val="262D3E"/>
             </a:solidFill>
           </a:ln>
         </p:spPr>
@@ -3338,26 +3338,26 @@
           <a:lstStyle/>
           <a:p>
             <a:pPr algn="ctr">
-              <a:defRPr sz="1200" b="1">
+              <a:defRPr sz="1100" b="1">
                 <a:solidFill>
                   <a:srgbClr val="FFD700"/>
                 </a:solidFill>
               </a:defRPr>
             </a:pPr>
             <a:r>
-              <a:t>⚡ Instant Reaction</a:t>
+              <a:t>INSTANT REACTION</a:t>
             </a:r>
           </a:p>
           <a:p>
             <a:pPr>
               <a:defRPr sz="950">
                 <a:solidFill>
-                  <a:srgbClr val="AAB2C8"/>
-                </a:solidFill>
-              </a:defRPr>
-            </a:pPr>
-            <a:r>
-              <a:t>Zero cloud latency hazard</a:t>
+                  <a:srgbClr val="A5AFC3"/>
+                </a:solidFill>
+              </a:defRPr>
+            </a:pPr>
+            <a:r>
+              <a:t>Zero cloud latency lag</a:t>
             </a:r>
           </a:p>
         </p:txBody>
@@ -3370,18 +3370,18 @@
         </p:nvSpPr>
         <p:spPr>
           <a:xfrm>
-            <a:off x="3794760" y="4434840"/>
-            <a:ext cx="2926080" cy="868680"/>
+            <a:off x="3520439" y="4297680"/>
+            <a:ext cx="2697480" cy="868680"/>
           </a:xfrm>
           <a:prstGeom prst="roundRect">
             <a:avLst/>
           </a:prstGeom>
           <a:solidFill>
-            <a:srgbClr val="121520"/>
+            <a:srgbClr val="10141E"/>
           </a:solidFill>
           <a:ln>
             <a:solidFill>
-              <a:srgbClr val="2A3046"/>
+              <a:srgbClr val="262D3E"/>
             </a:solidFill>
           </a:ln>
         </p:spPr>
@@ -3404,21 +3404,21 @@
           <a:lstStyle/>
           <a:p>
             <a:pPr algn="ctr">
-              <a:defRPr sz="1200" b="1">
+              <a:defRPr sz="1100" b="1">
                 <a:solidFill>
                   <a:srgbClr val="FFD700"/>
                 </a:solidFill>
               </a:defRPr>
             </a:pPr>
             <a:r>
-              <a:t>🔒 100% Private</a:t>
+              <a:t>100% PRIVATE</a:t>
             </a:r>
           </a:p>
           <a:p>
             <a:pPr>
               <a:defRPr sz="950">
                 <a:solidFill>
-                  <a:srgbClr val="AAB2C8"/>
+                  <a:srgbClr val="A5AFC3"/>
                 </a:solidFill>
               </a:defRPr>
             </a:pPr>
@@ -3436,18 +3436,18 @@
         </p:nvSpPr>
         <p:spPr>
           <a:xfrm>
-            <a:off x="731520" y="5440679"/>
-            <a:ext cx="2926080" cy="868680"/>
+            <a:off x="731520" y="5303520"/>
+            <a:ext cx="2697480" cy="868680"/>
           </a:xfrm>
           <a:prstGeom prst="roundRect">
             <a:avLst/>
           </a:prstGeom>
           <a:solidFill>
-            <a:srgbClr val="121520"/>
+            <a:srgbClr val="10141E"/>
           </a:solidFill>
           <a:ln>
             <a:solidFill>
-              <a:srgbClr val="2A3046"/>
+              <a:srgbClr val="262D3E"/>
             </a:solidFill>
           </a:ln>
         </p:spPr>
@@ -3470,21 +3470,21 @@
           <a:lstStyle/>
           <a:p>
             <a:pPr algn="ctr">
-              <a:defRPr sz="1200" b="1">
+              <a:defRPr sz="1100" b="1">
                 <a:solidFill>
                   <a:srgbClr val="FFD700"/>
                 </a:solidFill>
               </a:defRPr>
             </a:pPr>
             <a:r>
-              <a:t>✈️ Fully Offline</a:t>
+              <a:t>FULLY OFFLINE</a:t>
             </a:r>
           </a:p>
           <a:p>
             <a:pPr>
               <a:defRPr sz="950">
                 <a:solidFill>
-                  <a:srgbClr val="AAB2C8"/>
+                  <a:srgbClr val="A5AFC3"/>
                 </a:solidFill>
               </a:defRPr>
             </a:pPr>
@@ -3502,18 +3502,18 @@
         </p:nvSpPr>
         <p:spPr>
           <a:xfrm>
-            <a:off x="3794760" y="5440679"/>
-            <a:ext cx="2926080" cy="868680"/>
+            <a:off x="3520439" y="5303520"/>
+            <a:ext cx="2697480" cy="868680"/>
           </a:xfrm>
           <a:prstGeom prst="roundRect">
             <a:avLst/>
           </a:prstGeom>
           <a:solidFill>
-            <a:srgbClr val="121520"/>
+            <a:srgbClr val="10141E"/>
           </a:solidFill>
           <a:ln>
             <a:solidFill>
-              <a:srgbClr val="2A3046"/>
+              <a:srgbClr val="262D3E"/>
             </a:solidFill>
           </a:ln>
         </p:spPr>
@@ -3536,26 +3536,26 @@
           <a:lstStyle/>
           <a:p>
             <a:pPr algn="ctr">
-              <a:defRPr sz="1200" b="1">
+              <a:defRPr sz="1100" b="1">
                 <a:solidFill>
                   <a:srgbClr val="FFD700"/>
                 </a:solidFill>
               </a:defRPr>
             </a:pPr>
             <a:r>
-              <a:t>🏠 Smart Living</a:t>
+              <a:t>SMART LIVING</a:t>
             </a:r>
           </a:p>
           <a:p>
             <a:pPr>
               <a:defRPr sz="950">
                 <a:solidFill>
-                  <a:srgbClr val="AAB2C8"/>
-                </a:solidFill>
-              </a:defRPr>
-            </a:pPr>
-            <a:r>
-              <a:t>Real daily independence</a:t>
+                  <a:srgbClr val="A5AFC3"/>
+                </a:solidFill>
+              </a:defRPr>
+            </a:pPr>
+            <a:r>
+              <a:t>Everyday independence</a:t>
             </a:r>
           </a:p>
         </p:txBody>
@@ -3568,18 +3568,18 @@
         </p:nvSpPr>
         <p:spPr>
           <a:xfrm>
-            <a:off x="7040880" y="777240"/>
-            <a:ext cx="4389120" cy="5440680"/>
+            <a:off x="6583680" y="822960"/>
+            <a:ext cx="4876495" cy="5349240"/>
           </a:xfrm>
           <a:prstGeom prst="roundRect">
             <a:avLst/>
           </a:prstGeom>
           <a:solidFill>
-            <a:srgbClr val="121520"/>
+            <a:srgbClr val="10141E"/>
           </a:solidFill>
-          <a:ln w="15240">
+          <a:ln w="12700">
             <a:solidFill>
-              <a:srgbClr val="2A3046"/>
+              <a:srgbClr val="262D3E"/>
             </a:solidFill>
           </a:ln>
         </p:spPr>
@@ -3607,7 +3607,7 @@
       </p:sp>
       <p:pic>
         <p:nvPicPr>
-          <p:cNvPr id="11" name="Picture 10" descr="iqoo-spatial-hallway.jpg"/>
+          <p:cNvPr id="11" name="Picture 10" descr="real_smartphone_camera_held.jpg"/>
           <p:cNvPicPr>
             <a:picLocks noChangeAspect="1"/>
           </p:cNvPicPr>
@@ -3621,8 +3621,8 @@
         </p:blipFill>
         <p:spPr>
           <a:xfrm>
-            <a:off x="7114032" y="850392"/>
-            <a:ext cx="4242816" cy="4846320"/>
+            <a:off x="6656832" y="896112"/>
+            <a:ext cx="4730191" cy="4425696"/>
           </a:xfrm>
           <a:prstGeom prst="rect">
             <a:avLst/>
@@ -3637,8 +3637,8 @@
         </p:nvSpPr>
         <p:spPr>
           <a:xfrm>
-            <a:off x="7178040" y="5715000"/>
-            <a:ext cx="4114800" cy="457200"/>
+            <a:off x="6720840" y="5340096"/>
+            <a:ext cx="4602175" cy="685800"/>
           </a:xfrm>
           <a:prstGeom prst="rect">
             <a:avLst/>
@@ -3646,20 +3646,35 @@
           <a:noFill/>
         </p:spPr>
         <p:txBody>
-          <a:bodyPr wrap="square">
+          <a:bodyPr wrap="square" lIns="0" rIns="0" tIns="0" bIns="0">
             <a:spAutoFit/>
           </a:bodyPr>
           <a:lstStyle/>
           <a:p>
-            <a:pPr algn="ctr">
-              <a:defRPr sz="950" b="1">
+            <a:pPr>
+              <a:defRPr sz="850" b="1">
                 <a:solidFill>
                   <a:srgbClr val="FFD700"/>
                 </a:solidFill>
               </a:defRPr>
             </a:pPr>
             <a:r>
-              <a:t>iQOO On-Device Spatial Guidance HUD (Hallway Navigation)</a:t>
+              <a:t>PHONE-FIRST ASSISTIVE TECH</a:t>
+            </a:r>
+          </a:p>
+          <a:p>
+            <a:pPr>
+              <a:spcBef>
+                <a:spcPts val="200"/>
+              </a:spcBef>
+              <a:defRPr sz="950">
+                <a:solidFill>
+                  <a:srgbClr val="A5AFC3"/>
+                </a:solidFill>
+              </a:defRPr>
+            </a:pPr>
+            <a:r>
+              <a:t>Transforming everyday smartphone cameras into instant, private spatial sensory prosthetics.</a:t>
             </a:r>
           </a:p>
         </p:txBody>
@@ -3697,7 +3712,7 @@
             <a:avLst/>
           </a:prstGeom>
           <a:solidFill>
-            <a:srgbClr val="05060A"/>
+            <a:srgbClr val="07090F"/>
           </a:solidFill>
           <a:ln>
             <a:noFill/>
@@ -3733,8 +3748,8 @@
         </p:nvSpPr>
         <p:spPr>
           <a:xfrm>
-            <a:off x="731520" y="365760"/>
-            <a:ext cx="10515600" cy="320040"/>
+            <a:off x="731520" y="384048"/>
+            <a:ext cx="10728655" cy="292608"/>
           </a:xfrm>
           <a:prstGeom prst="rect">
             <a:avLst/>
@@ -3742,13 +3757,13 @@
           <a:noFill/>
         </p:spPr>
         <p:txBody>
-          <a:bodyPr wrap="none">
+          <a:bodyPr wrap="none" lIns="0" rIns="0" tIns="0" bIns="0">
             <a:spAutoFit/>
           </a:bodyPr>
           <a:lstStyle/>
           <a:p>
             <a:pPr>
-              <a:defRPr sz="1000" b="1">
+              <a:defRPr sz="950" b="1">
                 <a:solidFill>
                   <a:srgbClr val="FFD700"/>
                 </a:solidFill>
@@ -3768,8 +3783,8 @@
         </p:nvSpPr>
         <p:spPr>
           <a:xfrm>
-            <a:off x="731520" y="640080"/>
-            <a:ext cx="10515600" cy="685800"/>
+            <a:off x="731520" y="658368"/>
+            <a:ext cx="10728655" cy="594360"/>
           </a:xfrm>
           <a:prstGeom prst="rect">
             <a:avLst/>
@@ -3777,7 +3792,7 @@
           <a:noFill/>
         </p:spPr>
         <p:txBody>
-          <a:bodyPr wrap="none">
+          <a:bodyPr wrap="none" lIns="0" rIns="0" tIns="0" bIns="0">
             <a:spAutoFit/>
           </a:bodyPr>
           <a:lstStyle/>
@@ -3803,8 +3818,8 @@
         </p:nvSpPr>
         <p:spPr>
           <a:xfrm>
-            <a:off x="731520" y="1234440"/>
-            <a:ext cx="10515600" cy="411480"/>
+            <a:off x="731520" y="1243584"/>
+            <a:ext cx="10728655" cy="384048"/>
           </a:xfrm>
           <a:prstGeom prst="rect">
             <a:avLst/>
@@ -3812,15 +3827,15 @@
           <a:noFill/>
         </p:spPr>
         <p:txBody>
-          <a:bodyPr wrap="none">
+          <a:bodyPr wrap="none" lIns="0" rIns="0" tIns="0" bIns="0">
             <a:spAutoFit/>
           </a:bodyPr>
           <a:lstStyle/>
           <a:p>
             <a:pPr>
-              <a:defRPr sz="1200">
-                <a:solidFill>
-                  <a:srgbClr val="AAB2C8"/>
+              <a:defRPr sz="1150">
+                <a:solidFill>
+                  <a:srgbClr val="A5AFC3"/>
                 </a:solidFill>
               </a:defRPr>
             </a:pPr>
@@ -3845,11 +3860,11 @@
             <a:avLst/>
           </a:prstGeom>
           <a:solidFill>
-            <a:srgbClr val="121520"/>
+            <a:srgbClr val="10141E"/>
           </a:solidFill>
-          <a:ln w="15240">
+          <a:ln w="12700">
             <a:solidFill>
-              <a:srgbClr val="2A3046"/>
+              <a:srgbClr val="262D3E"/>
             </a:solidFill>
           </a:ln>
         </p:spPr>
@@ -3877,7 +3892,7 @@
       </p:sp>
       <p:pic>
         <p:nvPicPr>
-          <p:cNvPr id="7" name="Picture 6" descr="visually-impaired-nav.jpg"/>
+          <p:cNvPr id="7" name="Picture 6" descr="real_blind_cane_walking.jpg"/>
           <p:cNvPicPr>
             <a:picLocks noChangeAspect="1"/>
           </p:cNvPicPr>
@@ -3892,7 +3907,7 @@
         <p:spPr>
           <a:xfrm>
             <a:off x="804672" y="1856232"/>
-            <a:ext cx="3785616" cy="3931920"/>
+            <a:ext cx="3785616" cy="3602736"/>
           </a:xfrm>
           <a:prstGeom prst="rect">
             <a:avLst/>
@@ -3907,8 +3922,8 @@
         </p:nvSpPr>
         <p:spPr>
           <a:xfrm>
-            <a:off x="868680" y="5806440"/>
-            <a:ext cx="3657600" cy="457200"/>
+            <a:off x="868680" y="5477256"/>
+            <a:ext cx="3657600" cy="685800"/>
           </a:xfrm>
           <a:prstGeom prst="rect">
             <a:avLst/>
@@ -3916,20 +3931,35 @@
           <a:noFill/>
         </p:spPr>
         <p:txBody>
-          <a:bodyPr wrap="square">
+          <a:bodyPr wrap="square" lIns="0" rIns="0" tIns="0" bIns="0">
             <a:spAutoFit/>
           </a:bodyPr>
           <a:lstStyle/>
           <a:p>
-            <a:pPr algn="ctr">
-              <a:defRPr sz="950" b="1">
+            <a:pPr>
+              <a:defRPr sz="850" b="1">
                 <a:solidFill>
                   <a:srgbClr val="FFD700"/>
                 </a:solidFill>
               </a:defRPr>
             </a:pPr>
             <a:r>
-              <a:t>40M+ visually impaired in India face dangerous cloud latency &amp; privacy loss</a:t>
+              <a:t>THE EVERYDAY HAZARD</a:t>
+            </a:r>
+          </a:p>
+          <a:p>
+            <a:pPr>
+              <a:spcBef>
+                <a:spcPts val="200"/>
+              </a:spcBef>
+              <a:defRPr sz="950">
+                <a:solidFill>
+                  <a:srgbClr val="A5AFC3"/>
+                </a:solidFill>
+              </a:defRPr>
+            </a:pPr>
+            <a:r>
+              <a:t>Navigating city crosswalks requires sub-second reflex. A 2-second cloud vision lag causes physical injury and collisions.</a:t>
             </a:r>
           </a:p>
         </p:txBody>
@@ -3942,16 +3972,16 @@
         </p:nvSpPr>
         <p:spPr>
           <a:xfrm>
-            <a:off x="4846320" y="1783080"/>
-            <a:ext cx="6675120" cy="1371600"/>
+            <a:off x="5029200" y="1783080"/>
+            <a:ext cx="6430975" cy="1353312"/>
           </a:xfrm>
           <a:prstGeom prst="roundRect">
             <a:avLst/>
           </a:prstGeom>
           <a:solidFill>
-            <a:srgbClr val="121520"/>
+            <a:srgbClr val="10141E"/>
           </a:solidFill>
-          <a:ln w="15240">
+          <a:ln w="12700">
             <a:solidFill>
               <a:srgbClr val="F87171"/>
             </a:solidFill>
@@ -3972,33 +4002,21 @@
           </a:fontRef>
         </p:style>
         <p:txBody>
-          <a:bodyPr rtlCol="0" anchor="ctr" wrap="square" lIns="228600" rIns="228600" tIns="201168" bIns="182880"/>
+          <a:bodyPr rtlCol="0" anchor="ctr" wrap="square" lIns="219456" rIns="219456" tIns="182880" bIns="164592"/>
           <a:lstStyle/>
           <a:p>
             <a:pPr algn="ctr">
-              <a:defRPr sz="850" b="1">
-                <a:solidFill>
-                  <a:srgbClr val="F87171"/>
-                </a:solidFill>
-              </a:defRPr>
-            </a:pPr>
-            <a:r>
-              <a:t>HAZARD 1</a:t>
-            </a:r>
-          </a:p>
-          <a:p>
-            <a:pPr>
               <a:spcAft>
-                <a:spcPts val="600"/>
+                <a:spcPts val="500"/>
               </a:spcAft>
-              <a:defRPr sz="1400" b="1">
+              <a:defRPr sz="1350" b="1">
                 <a:solidFill>
                   <a:srgbClr val="FFFFFF"/>
                 </a:solidFill>
               </a:defRPr>
             </a:pPr>
             <a:r>
-              <a:t>⚠️  Cloud Latency is Dangerous</a:t>
+              <a:t>01  Cloud Latency is Dangerous</a:t>
             </a:r>
           </a:p>
           <a:p>
@@ -4008,7 +4026,7 @@
               </a:spcAft>
               <a:defRPr sz="1000">
                 <a:solidFill>
-                  <a:srgbClr val="AAB2C8"/>
+                  <a:srgbClr val="A5AFC3"/>
                 </a:solidFill>
               </a:defRPr>
             </a:pPr>
@@ -4023,7 +4041,7 @@
               </a:spcAft>
               <a:defRPr sz="1000">
                 <a:solidFill>
-                  <a:srgbClr val="AAB2C8"/>
+                  <a:srgbClr val="A5AFC3"/>
                 </a:solidFill>
               </a:defRPr>
             </a:pPr>
@@ -4038,12 +4056,12 @@
               </a:spcAft>
               <a:defRPr sz="1000">
                 <a:solidFill>
-                  <a:srgbClr val="AAB2C8"/>
-                </a:solidFill>
-              </a:defRPr>
-            </a:pPr>
-            <a:r>
-              <a:t>•  In obstacle avoidance, that delay causes physical injury and collisions.</a:t>
+                  <a:srgbClr val="A5AFC3"/>
+                </a:solidFill>
+              </a:defRPr>
+            </a:pPr>
+            <a:r>
+              <a:t>•  In obstacle avoidance, that delay causes collisions with poles, doors, and stairs.</a:t>
             </a:r>
           </a:p>
         </p:txBody>
@@ -4056,16 +4074,16 @@
         </p:nvSpPr>
         <p:spPr>
           <a:xfrm>
-            <a:off x="4846320" y="3337560"/>
-            <a:ext cx="6675120" cy="1371600"/>
+            <a:off x="5029200" y="3364992"/>
+            <a:ext cx="6430975" cy="1353312"/>
           </a:xfrm>
           <a:prstGeom prst="roundRect">
             <a:avLst/>
           </a:prstGeom>
           <a:solidFill>
-            <a:srgbClr val="121520"/>
+            <a:srgbClr val="10141E"/>
           </a:solidFill>
-          <a:ln w="15240">
+          <a:ln w="12700">
             <a:solidFill>
               <a:srgbClr val="FFD700"/>
             </a:solidFill>
@@ -4086,33 +4104,21 @@
           </a:fontRef>
         </p:style>
         <p:txBody>
-          <a:bodyPr rtlCol="0" anchor="ctr" wrap="square" lIns="228600" rIns="228600" tIns="201168" bIns="182880"/>
+          <a:bodyPr rtlCol="0" anchor="ctr" wrap="square" lIns="219456" rIns="219456" tIns="182880" bIns="164592"/>
           <a:lstStyle/>
           <a:p>
             <a:pPr algn="ctr">
-              <a:defRPr sz="850" b="1">
-                <a:solidFill>
-                  <a:srgbClr val="FFD700"/>
-                </a:solidFill>
-              </a:defRPr>
-            </a:pPr>
-            <a:r>
-              <a:t>HAZARD 2</a:t>
-            </a:r>
-          </a:p>
-          <a:p>
-            <a:pPr>
               <a:spcAft>
-                <a:spcPts val="600"/>
+                <a:spcPts val="500"/>
               </a:spcAft>
-              <a:defRPr sz="1400" b="1">
+              <a:defRPr sz="1350" b="1">
                 <a:solidFill>
                   <a:srgbClr val="FFFFFF"/>
                 </a:solidFill>
               </a:defRPr>
             </a:pPr>
             <a:r>
-              <a:t>🔒  Severe Privacy Vulnerability</a:t>
+              <a:t>02  Severe Privacy Vulnerability</a:t>
             </a:r>
           </a:p>
           <a:p>
@@ -4122,7 +4128,7 @@
               </a:spcAft>
               <a:defRPr sz="1000">
                 <a:solidFill>
-                  <a:srgbClr val="AAB2C8"/>
+                  <a:srgbClr val="A5AFC3"/>
                 </a:solidFill>
               </a:defRPr>
             </a:pPr>
@@ -4137,12 +4143,12 @@
               </a:spcAft>
               <a:defRPr sz="1000">
                 <a:solidFill>
-                  <a:srgbClr val="AAB2C8"/>
-                </a:solidFill>
-              </a:defRPr>
-            </a:pPr>
-            <a:r>
-              <a:t>•  Transmits personal documents (Aadhaar, prescriptions) to 3rd-party servers.</a:t>
+                  <a:srgbClr val="A5AFC3"/>
+                </a:solidFill>
+              </a:defRPr>
+            </a:pPr>
+            <a:r>
+              <a:t>•  Transmits sensitive documents (Aadhaar, prescriptions) to 3rd-party servers.</a:t>
             </a:r>
           </a:p>
           <a:p>
@@ -4152,12 +4158,12 @@
               </a:spcAft>
               <a:defRPr sz="1000">
                 <a:solidFill>
-                  <a:srgbClr val="AAB2C8"/>
-                </a:solidFill>
-              </a:defRPr>
-            </a:pPr>
-            <a:r>
-              <a:t>•  Sacrifices personal privacy just to achieve basic mobility.</a:t>
+                  <a:srgbClr val="A5AFC3"/>
+                </a:solidFill>
+              </a:defRPr>
+            </a:pPr>
+            <a:r>
+              <a:t>•  Users should never have to surrender their privacy just to achieve basic mobility.</a:t>
             </a:r>
           </a:p>
         </p:txBody>
@@ -4170,18 +4176,18 @@
         </p:nvSpPr>
         <p:spPr>
           <a:xfrm>
-            <a:off x="4846320" y="4892040"/>
-            <a:ext cx="6675120" cy="1371600"/>
+            <a:off x="5029200" y="4956048"/>
+            <a:ext cx="6430975" cy="1353312"/>
           </a:xfrm>
           <a:prstGeom prst="roundRect">
             <a:avLst/>
           </a:prstGeom>
           <a:solidFill>
-            <a:srgbClr val="121520"/>
+            <a:srgbClr val="10141E"/>
           </a:solidFill>
-          <a:ln w="15240">
+          <a:ln w="12700">
             <a:solidFill>
-              <a:srgbClr val="00E5FF"/>
+              <a:srgbClr val="00D7FA"/>
             </a:solidFill>
           </a:ln>
         </p:spPr>
@@ -4200,33 +4206,21 @@
           </a:fontRef>
         </p:style>
         <p:txBody>
-          <a:bodyPr rtlCol="0" anchor="ctr" wrap="square" lIns="228600" rIns="228600" tIns="201168" bIns="182880"/>
+          <a:bodyPr rtlCol="0" anchor="ctr" wrap="square" lIns="219456" rIns="219456" tIns="182880" bIns="164592"/>
           <a:lstStyle/>
           <a:p>
             <a:pPr algn="ctr">
-              <a:defRPr sz="850" b="1">
-                <a:solidFill>
-                  <a:srgbClr val="00E5FF"/>
-                </a:solidFill>
-              </a:defRPr>
-            </a:pPr>
-            <a:r>
-              <a:t>HAZARD 3</a:t>
-            </a:r>
-          </a:p>
-          <a:p>
-            <a:pPr>
               <a:spcAft>
-                <a:spcPts val="600"/>
+                <a:spcPts val="500"/>
               </a:spcAft>
-              <a:defRPr sz="1400" b="1">
+              <a:defRPr sz="1350" b="1">
                 <a:solidFill>
                   <a:srgbClr val="FFFFFF"/>
                 </a:solidFill>
               </a:defRPr>
             </a:pPr>
             <a:r>
-              <a:t>📡  Connectivity Fragility</a:t>
+              <a:t>03  Connectivity Fragility</a:t>
             </a:r>
           </a:p>
           <a:p>
@@ -4236,12 +4230,12 @@
               </a:spcAft>
               <a:defRPr sz="1000">
                 <a:solidFill>
-                  <a:srgbClr val="AAB2C8"/>
-                </a:solidFill>
-              </a:defRPr>
-            </a:pPr>
-            <a:r>
-              <a:t>•  Transit corridors (metro stations, elevators, rural zones) lack stable internet.</a:t>
+                  <a:srgbClr val="A5AFC3"/>
+                </a:solidFill>
+              </a:defRPr>
+            </a:pPr>
+            <a:r>
+              <a:t>•  Essential transit corridors (metro stations, elevators, rural zones) lack internet.</a:t>
             </a:r>
           </a:p>
           <a:p>
@@ -4251,12 +4245,12 @@
               </a:spcAft>
               <a:defRPr sz="1000">
                 <a:solidFill>
-                  <a:srgbClr val="AAB2C8"/>
-                </a:solidFill>
-              </a:defRPr>
-            </a:pPr>
-            <a:r>
-              <a:t>•  When the connection drops, cloud-tethered apps instantly disable.</a:t>
+                  <a:srgbClr val="A5AFC3"/>
+                </a:solidFill>
+              </a:defRPr>
+            </a:pPr>
+            <a:r>
+              <a:t>•  The moment connection drops, cloud-tethered apps instantly disable.</a:t>
             </a:r>
           </a:p>
           <a:p>
@@ -4266,12 +4260,12 @@
               </a:spcAft>
               <a:defRPr sz="1000">
                 <a:solidFill>
-                  <a:srgbClr val="AAB2C8"/>
-                </a:solidFill>
-              </a:defRPr>
-            </a:pPr>
-            <a:r>
-              <a:t>•  Leaves visually impaired users stranded and functionally blinded.</a:t>
+                  <a:srgbClr val="A5AFC3"/>
+                </a:solidFill>
+              </a:defRPr>
+            </a:pPr>
+            <a:r>
+              <a:t>•  Leaves visually impaired users stranded and functionally blinded when they need help most.</a:t>
             </a:r>
           </a:p>
         </p:txBody>
@@ -4309,7 +4303,7 @@
             <a:avLst/>
           </a:prstGeom>
           <a:solidFill>
-            <a:srgbClr val="05060A"/>
+            <a:srgbClr val="07090F"/>
           </a:solidFill>
           <a:ln>
             <a:noFill/>
@@ -4345,8 +4339,8 @@
         </p:nvSpPr>
         <p:spPr>
           <a:xfrm>
-            <a:off x="731520" y="365760"/>
-            <a:ext cx="10515600" cy="320040"/>
+            <a:off x="731520" y="384048"/>
+            <a:ext cx="10728655" cy="292608"/>
           </a:xfrm>
           <a:prstGeom prst="rect">
             <a:avLst/>
@@ -4354,13 +4348,13 @@
           <a:noFill/>
         </p:spPr>
         <p:txBody>
-          <a:bodyPr wrap="none">
+          <a:bodyPr wrap="none" lIns="0" rIns="0" tIns="0" bIns="0">
             <a:spAutoFit/>
           </a:bodyPr>
           <a:lstStyle/>
           <a:p>
             <a:pPr>
-              <a:defRPr sz="1000" b="1">
+              <a:defRPr sz="950" b="1">
                 <a:solidFill>
                   <a:srgbClr val="FFD700"/>
                 </a:solidFill>
@@ -4380,8 +4374,8 @@
         </p:nvSpPr>
         <p:spPr>
           <a:xfrm>
-            <a:off x="731520" y="640080"/>
-            <a:ext cx="10515600" cy="685800"/>
+            <a:off x="731520" y="658368"/>
+            <a:ext cx="10728655" cy="594360"/>
           </a:xfrm>
           <a:prstGeom prst="rect">
             <a:avLst/>
@@ -4389,7 +4383,7 @@
           <a:noFill/>
         </p:spPr>
         <p:txBody>
-          <a:bodyPr wrap="none">
+          <a:bodyPr wrap="none" lIns="0" rIns="0" tIns="0" bIns="0">
             <a:spAutoFit/>
           </a:bodyPr>
           <a:lstStyle/>
@@ -4415,8 +4409,8 @@
         </p:nvSpPr>
         <p:spPr>
           <a:xfrm>
-            <a:off x="731520" y="1234440"/>
-            <a:ext cx="10515600" cy="411480"/>
+            <a:off x="731520" y="1243584"/>
+            <a:ext cx="10728655" cy="384048"/>
           </a:xfrm>
           <a:prstGeom prst="rect">
             <a:avLst/>
@@ -4424,15 +4418,15 @@
           <a:noFill/>
         </p:spPr>
         <p:txBody>
-          <a:bodyPr wrap="none">
+          <a:bodyPr wrap="none" lIns="0" rIns="0" tIns="0" bIns="0">
             <a:spAutoFit/>
           </a:bodyPr>
           <a:lstStyle/>
           <a:p>
             <a:pPr>
-              <a:defRPr sz="1200">
-                <a:solidFill>
-                  <a:srgbClr val="AAB2C8"/>
+              <a:defRPr sz="1150">
+                <a:solidFill>
+                  <a:srgbClr val="A5AFC3"/>
                 </a:solidFill>
               </a:defRPr>
             </a:pPr>
@@ -4451,15 +4445,15 @@
         <p:spPr>
           <a:xfrm>
             <a:off x="731520" y="1783080"/>
-            <a:ext cx="3246120" cy="2148840"/>
+            <a:ext cx="3108960" cy="2148840"/>
           </a:xfrm>
           <a:prstGeom prst="roundRect">
             <a:avLst/>
           </a:prstGeom>
           <a:solidFill>
-            <a:srgbClr val="121520"/>
+            <a:srgbClr val="10141E"/>
           </a:solidFill>
-          <a:ln w="15240">
+          <a:ln w="12700">
             <a:solidFill>
               <a:srgbClr val="FFD700"/>
             </a:solidFill>
@@ -4480,33 +4474,21 @@
           </a:fontRef>
         </p:style>
         <p:txBody>
-          <a:bodyPr rtlCol="0" anchor="ctr" wrap="square" lIns="228600" rIns="228600" tIns="201168" bIns="182880"/>
+          <a:bodyPr rtlCol="0" anchor="ctr" wrap="square" lIns="219456" rIns="219456" tIns="182880" bIns="164592"/>
           <a:lstStyle/>
           <a:p>
             <a:pPr algn="ctr">
-              <a:defRPr sz="850" b="1">
-                <a:solidFill>
-                  <a:srgbClr val="FFD700"/>
-                </a:solidFill>
-              </a:defRPr>
-            </a:pPr>
-            <a:r>
-              <a:t>CAPABILITY 1</a:t>
-            </a:r>
-          </a:p>
-          <a:p>
-            <a:pPr>
               <a:spcAft>
-                <a:spcPts val="600"/>
+                <a:spcPts val="500"/>
               </a:spcAft>
-              <a:defRPr sz="1350" b="1">
+              <a:defRPr sz="1300" b="1">
                 <a:solidFill>
                   <a:srgbClr val="FFFFFF"/>
                 </a:solidFill>
               </a:defRPr>
             </a:pPr>
             <a:r>
-              <a:t>🧭  Spatial &amp; Scene Guidance</a:t>
+              <a:t>01  Spatial &amp; Scene Guidance</a:t>
             </a:r>
           </a:p>
           <a:p>
@@ -4516,7 +4498,7 @@
               </a:spcAft>
               <a:defRPr sz="950">
                 <a:solidFill>
-                  <a:srgbClr val="AAB2C8"/>
+                  <a:srgbClr val="A5AFC3"/>
                 </a:solidFill>
               </a:defRPr>
             </a:pPr>
@@ -4531,7 +4513,7 @@
               </a:spcAft>
               <a:defRPr sz="950">
                 <a:solidFill>
-                  <a:srgbClr val="AAB2C8"/>
+                  <a:srgbClr val="A5AFC3"/>
                 </a:solidFill>
               </a:defRPr>
             </a:pPr>
@@ -4546,12 +4528,12 @@
               </a:spcAft>
               <a:defRPr sz="950">
                 <a:solidFill>
-                  <a:srgbClr val="AAB2C8"/>
-                </a:solidFill>
-              </a:defRPr>
-            </a:pPr>
-            <a:r>
-              <a:t>•  Directional haptic motor pulses guide around hazards.</a:t>
+                  <a:srgbClr val="A5AFC3"/>
+                </a:solidFill>
+              </a:defRPr>
+            </a:pPr>
+            <a:r>
+              <a:t>•  Directional linear haptic pulses guide around hazards.</a:t>
             </a:r>
           </a:p>
         </p:txBody>
@@ -4564,16 +4546,16 @@
         </p:nvSpPr>
         <p:spPr>
           <a:xfrm>
-            <a:off x="4114800" y="1783080"/>
-            <a:ext cx="3246120" cy="2148840"/>
+            <a:off x="3977639" y="1783080"/>
+            <a:ext cx="3108960" cy="2148840"/>
           </a:xfrm>
           <a:prstGeom prst="roundRect">
             <a:avLst/>
           </a:prstGeom>
           <a:solidFill>
-            <a:srgbClr val="121520"/>
+            <a:srgbClr val="10141E"/>
           </a:solidFill>
-          <a:ln w="15240">
+          <a:ln w="12700">
             <a:solidFill>
               <a:srgbClr val="34C759"/>
             </a:solidFill>
@@ -4594,33 +4576,21 @@
           </a:fontRef>
         </p:style>
         <p:txBody>
-          <a:bodyPr rtlCol="0" anchor="ctr" wrap="square" lIns="228600" rIns="228600" tIns="201168" bIns="182880"/>
+          <a:bodyPr rtlCol="0" anchor="ctr" wrap="square" lIns="219456" rIns="219456" tIns="182880" bIns="164592"/>
           <a:lstStyle/>
           <a:p>
             <a:pPr algn="ctr">
-              <a:defRPr sz="850" b="1">
-                <a:solidFill>
-                  <a:srgbClr val="34C759"/>
-                </a:solidFill>
-              </a:defRPr>
-            </a:pPr>
-            <a:r>
-              <a:t>CAPABILITY 2</a:t>
-            </a:r>
-          </a:p>
-          <a:p>
-            <a:pPr>
               <a:spcAft>
-                <a:spcPts val="600"/>
+                <a:spcPts val="500"/>
               </a:spcAft>
-              <a:defRPr sz="1350" b="1">
+              <a:defRPr sz="1300" b="1">
                 <a:solidFill>
                   <a:srgbClr val="FFFFFF"/>
                 </a:solidFill>
               </a:defRPr>
             </a:pPr>
             <a:r>
-              <a:t>💊  Smart-Scan for Medicine</a:t>
+              <a:t>02  Smart-Scan for Medicine</a:t>
             </a:r>
           </a:p>
           <a:p>
@@ -4630,12 +4600,12 @@
               </a:spcAft>
               <a:defRPr sz="950">
                 <a:solidFill>
-                  <a:srgbClr val="AAB2C8"/>
-                </a:solidFill>
-              </a:defRPr>
-            </a:pPr>
-            <a:r>
-              <a:t>•  On-device OCR + local LLM filters noisy packaging.</a:t>
+                  <a:srgbClr val="A5AFC3"/>
+                </a:solidFill>
+              </a:defRPr>
+            </a:pPr>
+            <a:r>
+              <a:t>•  On-device OCR + local LLM filters noisy blister packs.</a:t>
             </a:r>
           </a:p>
           <a:p>
@@ -4645,7 +4615,7 @@
               </a:spcAft>
               <a:defRPr sz="950">
                 <a:solidFill>
-                  <a:srgbClr val="AAB2C8"/>
+                  <a:srgbClr val="A5AFC3"/>
                 </a:solidFill>
               </a:defRPr>
             </a:pPr>
@@ -4660,7 +4630,7 @@
               </a:spcAft>
               <a:defRPr sz="950">
                 <a:solidFill>
-                  <a:srgbClr val="AAB2C8"/>
+                  <a:srgbClr val="A5AFC3"/>
                 </a:solidFill>
               </a:defRPr>
             </a:pPr>
@@ -4678,18 +4648,18 @@
         </p:nvSpPr>
         <p:spPr>
           <a:xfrm>
-            <a:off x="731520" y="4114800"/>
-            <a:ext cx="3246120" cy="2148840"/>
+            <a:off x="731520" y="4160520"/>
+            <a:ext cx="3108960" cy="2148840"/>
           </a:xfrm>
           <a:prstGeom prst="roundRect">
             <a:avLst/>
           </a:prstGeom>
           <a:solidFill>
-            <a:srgbClr val="121520"/>
+            <a:srgbClr val="10141E"/>
           </a:solidFill>
-          <a:ln w="15240">
+          <a:ln w="12700">
             <a:solidFill>
-              <a:srgbClr val="00E5FF"/>
+              <a:srgbClr val="00D7FA"/>
             </a:solidFill>
           </a:ln>
         </p:spPr>
@@ -4708,33 +4678,21 @@
           </a:fontRef>
         </p:style>
         <p:txBody>
-          <a:bodyPr rtlCol="0" anchor="ctr" wrap="square" lIns="228600" rIns="228600" tIns="201168" bIns="182880"/>
+          <a:bodyPr rtlCol="0" anchor="ctr" wrap="square" lIns="219456" rIns="219456" tIns="182880" bIns="164592"/>
           <a:lstStyle/>
           <a:p>
             <a:pPr algn="ctr">
-              <a:defRPr sz="850" b="1">
-                <a:solidFill>
-                  <a:srgbClr val="00E5FF"/>
-                </a:solidFill>
-              </a:defRPr>
-            </a:pPr>
-            <a:r>
-              <a:t>CAPABILITY 3</a:t>
-            </a:r>
-          </a:p>
-          <a:p>
-            <a:pPr>
               <a:spcAft>
-                <a:spcPts val="600"/>
+                <a:spcPts val="500"/>
               </a:spcAft>
-              <a:defRPr sz="1350" b="1">
+              <a:defRPr sz="1300" b="1">
                 <a:solidFill>
                   <a:srgbClr val="FFFFFF"/>
                 </a:solidFill>
               </a:defRPr>
             </a:pPr>
             <a:r>
-              <a:t>👤  'Who's Near Me' Face Scan</a:t>
+              <a:t>03  'Who's Near Me' Contact Scan</a:t>
             </a:r>
           </a:p>
           <a:p>
@@ -4744,7 +4702,7 @@
               </a:spcAft>
               <a:defRPr sz="950">
                 <a:solidFill>
-                  <a:srgbClr val="AAB2C8"/>
+                  <a:srgbClr val="A5AFC3"/>
                 </a:solidFill>
               </a:defRPr>
             </a:pPr>
@@ -4759,7 +4717,7 @@
               </a:spcAft>
               <a:defRPr sz="950">
                 <a:solidFill>
-                  <a:srgbClr val="AAB2C8"/>
+                  <a:srgbClr val="A5AFC3"/>
                 </a:solidFill>
               </a:defRPr>
             </a:pPr>
@@ -4774,7 +4732,7 @@
               </a:spcAft>
               <a:defRPr sz="950">
                 <a:solidFill>
-                  <a:srgbClr val="AAB2C8"/>
+                  <a:srgbClr val="A5AFC3"/>
                 </a:solidFill>
               </a:defRPr>
             </a:pPr>
@@ -4792,18 +4750,18 @@
         </p:nvSpPr>
         <p:spPr>
           <a:xfrm>
-            <a:off x="4114800" y="4114800"/>
-            <a:ext cx="3246120" cy="2148840"/>
+            <a:off x="3977639" y="4160520"/>
+            <a:ext cx="3108960" cy="2148840"/>
           </a:xfrm>
           <a:prstGeom prst="roundRect">
             <a:avLst/>
           </a:prstGeom>
           <a:solidFill>
-            <a:srgbClr val="121520"/>
+            <a:srgbClr val="10141E"/>
           </a:solidFill>
-          <a:ln w="15240">
+          <a:ln w="12700">
             <a:solidFill>
-              <a:srgbClr val="FFEB78"/>
+              <a:srgbClr val="E6C33C"/>
             </a:solidFill>
           </a:ln>
         </p:spPr>
@@ -4822,33 +4780,21 @@
           </a:fontRef>
         </p:style>
         <p:txBody>
-          <a:bodyPr rtlCol="0" anchor="ctr" wrap="square" lIns="228600" rIns="228600" tIns="201168" bIns="182880"/>
+          <a:bodyPr rtlCol="0" anchor="ctr" wrap="square" lIns="219456" rIns="219456" tIns="182880" bIns="164592"/>
           <a:lstStyle/>
           <a:p>
             <a:pPr algn="ctr">
-              <a:defRPr sz="850" b="1">
-                <a:solidFill>
-                  <a:srgbClr val="FFEB78"/>
-                </a:solidFill>
-              </a:defRPr>
-            </a:pPr>
-            <a:r>
-              <a:t>CAPABILITY 4</a:t>
-            </a:r>
-          </a:p>
-          <a:p>
-            <a:pPr>
               <a:spcAft>
-                <a:spcPts val="600"/>
+                <a:spcPts val="500"/>
               </a:spcAft>
-              <a:defRPr sz="1350" b="1">
+              <a:defRPr sz="1300" b="1">
                 <a:solidFill>
                   <a:srgbClr val="FFFFFF"/>
                 </a:solidFill>
               </a:defRPr>
             </a:pPr>
             <a:r>
-              <a:t>📳  Pure Tactile &amp; Voice UX</a:t>
+              <a:t>04  Pure Tactile &amp; Voice UX</a:t>
             </a:r>
           </a:p>
           <a:p>
@@ -4858,7 +4804,7 @@
               </a:spcAft>
               <a:defRPr sz="950">
                 <a:solidFill>
-                  <a:srgbClr val="AAB2C8"/>
+                  <a:srgbClr val="A5AFC3"/>
                 </a:solidFill>
               </a:defRPr>
             </a:pPr>
@@ -4873,7 +4819,7 @@
               </a:spcAft>
               <a:defRPr sz="950">
                 <a:solidFill>
-                  <a:srgbClr val="AAB2C8"/>
+                  <a:srgbClr val="A5AFC3"/>
                 </a:solidFill>
               </a:defRPr>
             </a:pPr>
@@ -4888,7 +4834,7 @@
               </a:spcAft>
               <a:defRPr sz="950">
                 <a:solidFill>
-                  <a:srgbClr val="AAB2C8"/>
+                  <a:srgbClr val="A5AFC3"/>
                 </a:solidFill>
               </a:defRPr>
             </a:pPr>
@@ -4906,18 +4852,18 @@
         </p:nvSpPr>
         <p:spPr>
           <a:xfrm>
-            <a:off x="7543800" y="1783080"/>
-            <a:ext cx="3886200" cy="4480560"/>
+            <a:off x="7406640" y="1783080"/>
+            <a:ext cx="4053535" cy="4526280"/>
           </a:xfrm>
           <a:prstGeom prst="roundRect">
             <a:avLst/>
           </a:prstGeom>
           <a:solidFill>
-            <a:srgbClr val="121520"/>
+            <a:srgbClr val="10141E"/>
           </a:solidFill>
-          <a:ln w="15240">
+          <a:ln w="12700">
             <a:solidFill>
-              <a:srgbClr val="2A3046"/>
+              <a:srgbClr val="262D3E"/>
             </a:solidFill>
           </a:ln>
         </p:spPr>
@@ -4945,7 +4891,7 @@
       </p:sp>
       <p:pic>
         <p:nvPicPr>
-          <p:cNvPr id="11" name="Picture 10" descr="iqoo-interface-medicine.jpg"/>
+          <p:cNvPr id="11" name="Picture 10" descr="real_hands_blister_pack.jpg"/>
           <p:cNvPicPr>
             <a:picLocks noChangeAspect="1"/>
           </p:cNvPicPr>
@@ -4959,8 +4905,8 @@
         </p:blipFill>
         <p:spPr>
           <a:xfrm>
-            <a:off x="7616952" y="1856232"/>
-            <a:ext cx="3739896" cy="3886200"/>
+            <a:off x="7479792" y="1856232"/>
+            <a:ext cx="3907231" cy="3602736"/>
           </a:xfrm>
           <a:prstGeom prst="rect">
             <a:avLst/>
@@ -4975,8 +4921,8 @@
         </p:nvSpPr>
         <p:spPr>
           <a:xfrm>
-            <a:off x="7680960" y="5760720"/>
-            <a:ext cx="3611880" cy="457200"/>
+            <a:off x="7543800" y="5477256"/>
+            <a:ext cx="3779215" cy="685800"/>
           </a:xfrm>
           <a:prstGeom prst="rect">
             <a:avLst/>
@@ -4984,20 +4930,35 @@
           <a:noFill/>
         </p:spPr>
         <p:txBody>
-          <a:bodyPr wrap="square">
+          <a:bodyPr wrap="square" lIns="0" rIns="0" tIns="0" bIns="0">
             <a:spAutoFit/>
           </a:bodyPr>
           <a:lstStyle/>
           <a:p>
-            <a:pPr algn="ctr">
-              <a:defRPr sz="950" b="1">
+            <a:pPr>
+              <a:defRPr sz="850" b="1">
                 <a:solidFill>
                   <a:srgbClr val="FFD700"/>
                 </a:solidFill>
               </a:defRPr>
             </a:pPr>
             <a:r>
-              <a:t>Drishti on iQOO: On-Device Medicine Scanner &amp; Spatial Radar</a:t>
+              <a:t>MEDICINE SMART-SCAN IN ACTION</a:t>
+            </a:r>
+          </a:p>
+          <a:p>
+            <a:pPr>
+              <a:spcBef>
+                <a:spcPts val="200"/>
+              </a:spcBef>
+              <a:defRPr sz="950">
+                <a:solidFill>
+                  <a:srgbClr val="A5AFC3"/>
+                </a:solidFill>
+              </a:defRPr>
+            </a:pPr>
+            <a:r>
+              <a:t>Reads noisy pharmaceutical strips, dosage, and expiry dates offline in sub-second time.</a:t>
             </a:r>
           </a:p>
         </p:txBody>
@@ -5035,7 +4996,7 @@
             <a:avLst/>
           </a:prstGeom>
           <a:solidFill>
-            <a:srgbClr val="05060A"/>
+            <a:srgbClr val="07090F"/>
           </a:solidFill>
           <a:ln>
             <a:noFill/>
@@ -5071,8 +5032,8 @@
         </p:nvSpPr>
         <p:spPr>
           <a:xfrm>
-            <a:off x="731520" y="365760"/>
-            <a:ext cx="10515600" cy="320040"/>
+            <a:off x="731520" y="384048"/>
+            <a:ext cx="10728655" cy="292608"/>
           </a:xfrm>
           <a:prstGeom prst="rect">
             <a:avLst/>
@@ -5080,13 +5041,13 @@
           <a:noFill/>
         </p:spPr>
         <p:txBody>
-          <a:bodyPr wrap="none">
+          <a:bodyPr wrap="none" lIns="0" rIns="0" tIns="0" bIns="0">
             <a:spAutoFit/>
           </a:bodyPr>
           <a:lstStyle/>
           <a:p>
             <a:pPr>
-              <a:defRPr sz="1000" b="1">
+              <a:defRPr sz="950" b="1">
                 <a:solidFill>
                   <a:srgbClr val="FFD700"/>
                 </a:solidFill>
@@ -5106,8 +5067,8 @@
         </p:nvSpPr>
         <p:spPr>
           <a:xfrm>
-            <a:off x="731520" y="640080"/>
-            <a:ext cx="10515600" cy="685800"/>
+            <a:off x="731520" y="658368"/>
+            <a:ext cx="10728655" cy="594360"/>
           </a:xfrm>
           <a:prstGeom prst="rect">
             <a:avLst/>
@@ -5115,7 +5076,7 @@
           <a:noFill/>
         </p:spPr>
         <p:txBody>
-          <a:bodyPr wrap="none">
+          <a:bodyPr wrap="none" lIns="0" rIns="0" tIns="0" bIns="0">
             <a:spAutoFit/>
           </a:bodyPr>
           <a:lstStyle/>
@@ -5141,8 +5102,8 @@
         </p:nvSpPr>
         <p:spPr>
           <a:xfrm>
-            <a:off x="731520" y="1234440"/>
-            <a:ext cx="10515600" cy="411480"/>
+            <a:off x="731520" y="1243584"/>
+            <a:ext cx="10728655" cy="384048"/>
           </a:xfrm>
           <a:prstGeom prst="rect">
             <a:avLst/>
@@ -5150,15 +5111,15 @@
           <a:noFill/>
         </p:spPr>
         <p:txBody>
-          <a:bodyPr wrap="none">
+          <a:bodyPr wrap="none" lIns="0" rIns="0" tIns="0" bIns="0">
             <a:spAutoFit/>
           </a:bodyPr>
           <a:lstStyle/>
           <a:p>
             <a:pPr>
-              <a:defRPr sz="1200">
-                <a:solidFill>
-                  <a:srgbClr val="AAB2C8"/>
+              <a:defRPr sz="1150">
+                <a:solidFill>
+                  <a:srgbClr val="A5AFC3"/>
                 </a:solidFill>
               </a:defRPr>
             </a:pPr>
@@ -5177,15 +5138,15 @@
         <p:spPr>
           <a:xfrm>
             <a:off x="731520" y="1783080"/>
-            <a:ext cx="5166360" cy="2148840"/>
+            <a:ext cx="5180990" cy="2148840"/>
           </a:xfrm>
           <a:prstGeom prst="roundRect">
             <a:avLst/>
           </a:prstGeom>
           <a:solidFill>
-            <a:srgbClr val="121520"/>
+            <a:srgbClr val="10141E"/>
           </a:solidFill>
-          <a:ln w="15240">
+          <a:ln w="12700">
             <a:solidFill>
               <a:srgbClr val="FFD700"/>
             </a:solidFill>
@@ -5206,33 +5167,21 @@
           </a:fontRef>
         </p:style>
         <p:txBody>
-          <a:bodyPr rtlCol="0" anchor="ctr" wrap="square" lIns="228600" rIns="228600" tIns="201168" bIns="182880"/>
+          <a:bodyPr rtlCol="0" anchor="ctr" wrap="square" lIns="219456" rIns="219456" tIns="182880" bIns="164592"/>
           <a:lstStyle/>
           <a:p>
             <a:pPr algn="ctr">
-              <a:defRPr sz="850" b="1">
-                <a:solidFill>
-                  <a:srgbClr val="FFD700"/>
-                </a:solidFill>
-              </a:defRPr>
-            </a:pPr>
-            <a:r>
-              <a:t>STRATEGY 1</a:t>
-            </a:r>
-          </a:p>
-          <a:p>
-            <a:pPr>
               <a:spcAft>
-                <a:spcPts val="600"/>
+                <a:spcPts val="500"/>
               </a:spcAft>
-              <a:defRPr sz="1500" b="1">
+              <a:defRPr sz="1350" b="1">
                 <a:solidFill>
                   <a:srgbClr val="FFFFFF"/>
                 </a:solidFill>
               </a:defRPr>
             </a:pPr>
             <a:r>
-              <a:t>⚡  Tiered Model Strategy</a:t>
+              <a:t>01  Tiered Model Strategy</a:t>
             </a:r>
           </a:p>
           <a:p>
@@ -5240,9 +5189,9 @@
               <a:spcAft>
                 <a:spcPts val="300"/>
               </a:spcAft>
-              <a:defRPr sz="1050">
-                <a:solidFill>
-                  <a:srgbClr val="AAB2C8"/>
+              <a:defRPr sz="1000">
+                <a:solidFill>
+                  <a:srgbClr val="A5AFC3"/>
                 </a:solidFill>
               </a:defRPr>
             </a:pPr>
@@ -5255,9 +5204,9 @@
               <a:spcAft>
                 <a:spcPts val="300"/>
               </a:spcAft>
-              <a:defRPr sz="1050">
-                <a:solidFill>
-                  <a:srgbClr val="AAB2C8"/>
+              <a:defRPr sz="1000">
+                <a:solidFill>
+                  <a:srgbClr val="A5AFC3"/>
                 </a:solidFill>
               </a:defRPr>
             </a:pPr>
@@ -5270,9 +5219,9 @@
               <a:spcAft>
                 <a:spcPts val="300"/>
               </a:spcAft>
-              <a:defRPr sz="1050">
-                <a:solidFill>
-                  <a:srgbClr val="AAB2C8"/>
+              <a:defRPr sz="1000">
+                <a:solidFill>
+                  <a:srgbClr val="A5AFC3"/>
                 </a:solidFill>
               </a:defRPr>
             </a:pPr>
@@ -5290,18 +5239,18 @@
         </p:nvSpPr>
         <p:spPr>
           <a:xfrm>
-            <a:off x="6217920" y="1783080"/>
-            <a:ext cx="5166360" cy="2148840"/>
+            <a:off x="6278270" y="1783080"/>
+            <a:ext cx="5180990" cy="2148840"/>
           </a:xfrm>
           <a:prstGeom prst="roundRect">
             <a:avLst/>
           </a:prstGeom>
           <a:solidFill>
-            <a:srgbClr val="121520"/>
+            <a:srgbClr val="10141E"/>
           </a:solidFill>
-          <a:ln w="15240">
+          <a:ln w="12700">
             <a:solidFill>
-              <a:srgbClr val="00E5FF"/>
+              <a:srgbClr val="00D7FA"/>
             </a:solidFill>
           </a:ln>
         </p:spPr>
@@ -5320,33 +5269,21 @@
           </a:fontRef>
         </p:style>
         <p:txBody>
-          <a:bodyPr rtlCol="0" anchor="ctr" wrap="square" lIns="228600" rIns="228600" tIns="201168" bIns="182880"/>
+          <a:bodyPr rtlCol="0" anchor="ctr" wrap="square" lIns="219456" rIns="219456" tIns="182880" bIns="164592"/>
           <a:lstStyle/>
           <a:p>
             <a:pPr algn="ctr">
-              <a:defRPr sz="850" b="1">
-                <a:solidFill>
-                  <a:srgbClr val="00E5FF"/>
-                </a:solidFill>
-              </a:defRPr>
-            </a:pPr>
-            <a:r>
-              <a:t>STRATEGY 2</a:t>
-            </a:r>
-          </a:p>
-          <a:p>
-            <a:pPr>
               <a:spcAft>
-                <a:spcPts val="600"/>
+                <a:spcPts val="500"/>
               </a:spcAft>
-              <a:defRPr sz="1500" b="1">
+              <a:defRPr sz="1350" b="1">
                 <a:solidFill>
                   <a:srgbClr val="FFFFFF"/>
                 </a:solidFill>
               </a:defRPr>
             </a:pPr>
             <a:r>
-              <a:t>⏱️  Live Real-World Latency Benchmark</a:t>
+              <a:t>02  Live Real-World Latency Benchmark</a:t>
             </a:r>
           </a:p>
           <a:p>
@@ -5354,9 +5291,9 @@
               <a:spcAft>
                 <a:spcPts val="300"/>
               </a:spcAft>
-              <a:defRPr sz="1050">
-                <a:solidFill>
-                  <a:srgbClr val="AAB2C8"/>
+              <a:defRPr sz="1000">
+                <a:solidFill>
+                  <a:srgbClr val="A5AFC3"/>
                 </a:solidFill>
               </a:defRPr>
             </a:pPr>
@@ -5369,9 +5306,9 @@
               <a:spcAft>
                 <a:spcPts val="300"/>
               </a:spcAft>
-              <a:defRPr sz="1050">
-                <a:solidFill>
-                  <a:srgbClr val="AAB2C8"/>
+              <a:defRPr sz="1000">
+                <a:solidFill>
+                  <a:srgbClr val="A5AFC3"/>
                 </a:solidFill>
               </a:defRPr>
             </a:pPr>
@@ -5384,9 +5321,9 @@
               <a:spcAft>
                 <a:spcPts val="300"/>
               </a:spcAft>
-              <a:defRPr sz="1050">
-                <a:solidFill>
-                  <a:srgbClr val="AAB2C8"/>
+              <a:defRPr sz="1000">
+                <a:solidFill>
+                  <a:srgbClr val="A5AFC3"/>
                 </a:solidFill>
               </a:defRPr>
             </a:pPr>
@@ -5404,16 +5341,16 @@
         </p:nvSpPr>
         <p:spPr>
           <a:xfrm>
-            <a:off x="731520" y="4114800"/>
-            <a:ext cx="5166360" cy="2148840"/>
+            <a:off x="731520" y="4160520"/>
+            <a:ext cx="5180990" cy="2148840"/>
           </a:xfrm>
           <a:prstGeom prst="roundRect">
             <a:avLst/>
           </a:prstGeom>
           <a:solidFill>
-            <a:srgbClr val="121520"/>
+            <a:srgbClr val="10141E"/>
           </a:solidFill>
-          <a:ln w="15240">
+          <a:ln w="12700">
             <a:solidFill>
               <a:srgbClr val="34C759"/>
             </a:solidFill>
@@ -5434,33 +5371,21 @@
           </a:fontRef>
         </p:style>
         <p:txBody>
-          <a:bodyPr rtlCol="0" anchor="ctr" wrap="square" lIns="228600" rIns="228600" tIns="201168" bIns="182880"/>
+          <a:bodyPr rtlCol="0" anchor="ctr" wrap="square" lIns="219456" rIns="219456" tIns="182880" bIns="164592"/>
           <a:lstStyle/>
           <a:p>
             <a:pPr algn="ctr">
-              <a:defRPr sz="850" b="1">
-                <a:solidFill>
-                  <a:srgbClr val="34C759"/>
-                </a:solidFill>
-              </a:defRPr>
-            </a:pPr>
-            <a:r>
-              <a:t>STRATEGY 3</a:t>
-            </a:r>
-          </a:p>
-          <a:p>
-            <a:pPr>
               <a:spcAft>
-                <a:spcPts val="600"/>
+                <a:spcPts val="500"/>
               </a:spcAft>
-              <a:defRPr sz="1500" b="1">
+              <a:defRPr sz="1350" b="1">
                 <a:solidFill>
                   <a:srgbClr val="FFFFFF"/>
                 </a:solidFill>
               </a:defRPr>
             </a:pPr>
             <a:r>
-              <a:t>✈️  100% Offline-Verifiable (Airplane Mode)</a:t>
+              <a:t>03  100% Offline-Verifiable (Airplane Mode)</a:t>
             </a:r>
           </a:p>
           <a:p>
@@ -5468,9 +5393,9 @@
               <a:spcAft>
                 <a:spcPts val="300"/>
               </a:spcAft>
-              <a:defRPr sz="1050">
-                <a:solidFill>
-                  <a:srgbClr val="AAB2C8"/>
+              <a:defRPr sz="1000">
+                <a:solidFill>
+                  <a:srgbClr val="A5AFC3"/>
                 </a:solidFill>
               </a:defRPr>
             </a:pPr>
@@ -5483,9 +5408,9 @@
               <a:spcAft>
                 <a:spcPts val="300"/>
               </a:spcAft>
-              <a:defRPr sz="1050">
-                <a:solidFill>
-                  <a:srgbClr val="AAB2C8"/>
+              <a:defRPr sz="1000">
+                <a:solidFill>
+                  <a:srgbClr val="A5AFC3"/>
                 </a:solidFill>
               </a:defRPr>
             </a:pPr>
@@ -5498,9 +5423,9 @@
               <a:spcAft>
                 <a:spcPts val="300"/>
               </a:spcAft>
-              <a:defRPr sz="1050">
-                <a:solidFill>
-                  <a:srgbClr val="AAB2C8"/>
+              <a:defRPr sz="1000">
+                <a:solidFill>
+                  <a:srgbClr val="A5AFC3"/>
                 </a:solidFill>
               </a:defRPr>
             </a:pPr>
@@ -5518,18 +5443,18 @@
         </p:nvSpPr>
         <p:spPr>
           <a:xfrm>
-            <a:off x="6217920" y="4114800"/>
-            <a:ext cx="5166360" cy="2148840"/>
+            <a:off x="6278270" y="4160520"/>
+            <a:ext cx="5180990" cy="2148840"/>
           </a:xfrm>
           <a:prstGeom prst="roundRect">
             <a:avLst/>
           </a:prstGeom>
           <a:solidFill>
-            <a:srgbClr val="121520"/>
+            <a:srgbClr val="10141E"/>
           </a:solidFill>
-          <a:ln w="15240">
+          <a:ln w="12700">
             <a:solidFill>
-              <a:srgbClr val="FFEB78"/>
+              <a:srgbClr val="E6C33C"/>
             </a:solidFill>
           </a:ln>
         </p:spPr>
@@ -5548,33 +5473,21 @@
           </a:fontRef>
         </p:style>
         <p:txBody>
-          <a:bodyPr rtlCol="0" anchor="ctr" wrap="square" lIns="228600" rIns="228600" tIns="201168" bIns="182880"/>
+          <a:bodyPr rtlCol="0" anchor="ctr" wrap="square" lIns="219456" rIns="219456" tIns="182880" bIns="164592"/>
           <a:lstStyle/>
           <a:p>
             <a:pPr algn="ctr">
-              <a:defRPr sz="850" b="1">
-                <a:solidFill>
-                  <a:srgbClr val="FFEB78"/>
-                </a:solidFill>
-              </a:defRPr>
-            </a:pPr>
-            <a:r>
-              <a:t>STRATEGY 4</a:t>
-            </a:r>
-          </a:p>
-          <a:p>
-            <a:pPr>
               <a:spcAft>
-                <a:spcPts val="600"/>
+                <a:spcPts val="500"/>
               </a:spcAft>
-              <a:defRPr sz="1500" b="1">
+              <a:defRPr sz="1350" b="1">
                 <a:solidFill>
                   <a:srgbClr val="FFFFFF"/>
                 </a:solidFill>
               </a:defRPr>
             </a:pPr>
             <a:r>
-              <a:t>🔐  Local Encrypted Face Recognition</a:t>
+              <a:t>04  Local Encrypted Face Recognition</a:t>
             </a:r>
           </a:p>
           <a:p>
@@ -5582,9 +5495,9 @@
               <a:spcAft>
                 <a:spcPts val="300"/>
               </a:spcAft>
-              <a:defRPr sz="1050">
-                <a:solidFill>
-                  <a:srgbClr val="AAB2C8"/>
+              <a:defRPr sz="1000">
+                <a:solidFill>
+                  <a:srgbClr val="A5AFC3"/>
                 </a:solidFill>
               </a:defRPr>
             </a:pPr>
@@ -5597,9 +5510,9 @@
               <a:spcAft>
                 <a:spcPts val="300"/>
               </a:spcAft>
-              <a:defRPr sz="1050">
-                <a:solidFill>
-                  <a:srgbClr val="AAB2C8"/>
+              <a:defRPr sz="1000">
+                <a:solidFill>
+                  <a:srgbClr val="A5AFC3"/>
                 </a:solidFill>
               </a:defRPr>
             </a:pPr>
@@ -5612,9 +5525,9 @@
               <a:spcAft>
                 <a:spcPts val="300"/>
               </a:spcAft>
-              <a:defRPr sz="1050">
-                <a:solidFill>
-                  <a:srgbClr val="AAB2C8"/>
+              <a:defRPr sz="1000">
+                <a:solidFill>
+                  <a:srgbClr val="A5AFC3"/>
                 </a:solidFill>
               </a:defRPr>
             </a:pPr>
@@ -5657,7 +5570,7 @@
             <a:avLst/>
           </a:prstGeom>
           <a:solidFill>
-            <a:srgbClr val="05060A"/>
+            <a:srgbClr val="07090F"/>
           </a:solidFill>
           <a:ln>
             <a:noFill/>
@@ -5693,8 +5606,8 @@
         </p:nvSpPr>
         <p:spPr>
           <a:xfrm>
-            <a:off x="731520" y="365760"/>
-            <a:ext cx="10515600" cy="320040"/>
+            <a:off x="731520" y="384048"/>
+            <a:ext cx="10728655" cy="292608"/>
           </a:xfrm>
           <a:prstGeom prst="rect">
             <a:avLst/>
@@ -5702,13 +5615,13 @@
           <a:noFill/>
         </p:spPr>
         <p:txBody>
-          <a:bodyPr wrap="none">
+          <a:bodyPr wrap="none" lIns="0" rIns="0" tIns="0" bIns="0">
             <a:spAutoFit/>
           </a:bodyPr>
           <a:lstStyle/>
           <a:p>
             <a:pPr>
-              <a:defRPr sz="1000" b="1">
+              <a:defRPr sz="950" b="1">
                 <a:solidFill>
                   <a:srgbClr val="FFD700"/>
                 </a:solidFill>
@@ -5728,8 +5641,8 @@
         </p:nvSpPr>
         <p:spPr>
           <a:xfrm>
-            <a:off x="731520" y="640080"/>
-            <a:ext cx="10515600" cy="685800"/>
+            <a:off x="731520" y="658368"/>
+            <a:ext cx="10728655" cy="594360"/>
           </a:xfrm>
           <a:prstGeom prst="rect">
             <a:avLst/>
@@ -5737,7 +5650,7 @@
           <a:noFill/>
         </p:spPr>
         <p:txBody>
-          <a:bodyPr wrap="none">
+          <a:bodyPr wrap="none" lIns="0" rIns="0" tIns="0" bIns="0">
             <a:spAutoFit/>
           </a:bodyPr>
           <a:lstStyle/>
@@ -5763,8 +5676,8 @@
         </p:nvSpPr>
         <p:spPr>
           <a:xfrm>
-            <a:off x="731520" y="1234440"/>
-            <a:ext cx="10515600" cy="411480"/>
+            <a:off x="731520" y="1243584"/>
+            <a:ext cx="10728655" cy="384048"/>
           </a:xfrm>
           <a:prstGeom prst="rect">
             <a:avLst/>
@@ -5772,15 +5685,15 @@
           <a:noFill/>
         </p:spPr>
         <p:txBody>
-          <a:bodyPr wrap="none">
+          <a:bodyPr wrap="none" lIns="0" rIns="0" tIns="0" bIns="0">
             <a:spAutoFit/>
           </a:bodyPr>
           <a:lstStyle/>
           <a:p>
             <a:pPr>
-              <a:defRPr sz="1200">
-                <a:solidFill>
-                  <a:srgbClr val="AAB2C8"/>
+              <a:defRPr sz="1150">
+                <a:solidFill>
+                  <a:srgbClr val="A5AFC3"/>
                 </a:solidFill>
               </a:defRPr>
             </a:pPr>
@@ -5799,15 +5712,15 @@
         <p:spPr>
           <a:xfrm>
             <a:off x="731520" y="1783080"/>
-            <a:ext cx="3429000" cy="2651760"/>
+            <a:ext cx="3332073" cy="2651760"/>
           </a:xfrm>
           <a:prstGeom prst="roundRect">
             <a:avLst/>
           </a:prstGeom>
           <a:solidFill>
-            <a:srgbClr val="121520"/>
+            <a:srgbClr val="10141E"/>
           </a:solidFill>
-          <a:ln w="15240">
+          <a:ln w="12700">
             <a:solidFill>
               <a:srgbClr val="FFD700"/>
             </a:solidFill>
@@ -5828,33 +5741,21 @@
           </a:fontRef>
         </p:style>
         <p:txBody>
-          <a:bodyPr rtlCol="0" anchor="ctr" wrap="square" lIns="228600" rIns="228600" tIns="201168" bIns="182880"/>
+          <a:bodyPr rtlCol="0" anchor="ctr" wrap="square" lIns="219456" rIns="219456" tIns="182880" bIns="164592"/>
           <a:lstStyle/>
           <a:p>
             <a:pPr algn="ctr">
-              <a:defRPr sz="850" b="1">
-                <a:solidFill>
-                  <a:srgbClr val="FFD700"/>
-                </a:solidFill>
-              </a:defRPr>
-            </a:pPr>
-            <a:r>
-              <a:t>1. SENSORY INPUT</a:t>
-            </a:r>
-          </a:p>
-          <a:p>
-            <a:pPr>
               <a:spcAft>
-                <a:spcPts val="600"/>
+                <a:spcPts val="500"/>
               </a:spcAft>
-              <a:defRPr sz="1500" b="1">
+              <a:defRPr sz="1400" b="1">
                 <a:solidFill>
                   <a:srgbClr val="FFFFFF"/>
                 </a:solidFill>
               </a:defRPr>
             </a:pPr>
             <a:r>
-              <a:t>Camera &amp; IMU Sensors</a:t>
+              <a:t>01  Sensory Input Layer</a:t>
             </a:r>
           </a:p>
           <a:p>
@@ -5864,7 +5765,7 @@
               </a:spcAft>
               <a:defRPr sz="1050">
                 <a:solidFill>
-                  <a:srgbClr val="AAB2C8"/>
+                  <a:srgbClr val="A5AFC3"/>
                 </a:solidFill>
               </a:defRPr>
             </a:pPr>
@@ -5879,7 +5780,7 @@
               </a:spcAft>
               <a:defRPr sz="1050">
                 <a:solidFill>
-                  <a:srgbClr val="AAB2C8"/>
+                  <a:srgbClr val="A5AFC3"/>
                 </a:solidFill>
               </a:defRPr>
             </a:pPr>
@@ -5894,7 +5795,7 @@
               </a:spcAft>
               <a:defRPr sz="1050">
                 <a:solidFill>
-                  <a:srgbClr val="AAB2C8"/>
+                  <a:srgbClr val="A5AFC3"/>
                 </a:solidFill>
               </a:defRPr>
             </a:pPr>
@@ -5912,18 +5813,18 @@
         </p:nvSpPr>
         <p:spPr>
           <a:xfrm>
-            <a:off x="4389120" y="1783080"/>
-            <a:ext cx="3429000" cy="2651760"/>
+            <a:off x="4429353" y="1783080"/>
+            <a:ext cx="3332073" cy="2651760"/>
           </a:xfrm>
           <a:prstGeom prst="roundRect">
             <a:avLst/>
           </a:prstGeom>
           <a:solidFill>
-            <a:srgbClr val="121520"/>
+            <a:srgbClr val="10141E"/>
           </a:solidFill>
-          <a:ln w="15240">
+          <a:ln w="12700">
             <a:solidFill>
-              <a:srgbClr val="00E5FF"/>
+              <a:srgbClr val="00D7FA"/>
             </a:solidFill>
           </a:ln>
         </p:spPr>
@@ -5942,33 +5843,21 @@
           </a:fontRef>
         </p:style>
         <p:txBody>
-          <a:bodyPr rtlCol="0" anchor="ctr" wrap="square" lIns="228600" rIns="228600" tIns="201168" bIns="182880"/>
+          <a:bodyPr rtlCol="0" anchor="ctr" wrap="square" lIns="219456" rIns="219456" tIns="182880" bIns="164592"/>
           <a:lstStyle/>
           <a:p>
             <a:pPr algn="ctr">
-              <a:defRPr sz="850" b="1">
-                <a:solidFill>
-                  <a:srgbClr val="00E5FF"/>
-                </a:solidFill>
-              </a:defRPr>
-            </a:pPr>
-            <a:r>
-              <a:t>2. ON-DEVICE INFERENCE</a:t>
-            </a:r>
-          </a:p>
-          <a:p>
-            <a:pPr>
               <a:spcAft>
-                <a:spcPts val="600"/>
+                <a:spcPts val="500"/>
               </a:spcAft>
-              <a:defRPr sz="1500" b="1">
+              <a:defRPr sz="1400" b="1">
                 <a:solidFill>
                   <a:srgbClr val="FFFFFF"/>
                 </a:solidFill>
               </a:defRPr>
             </a:pPr>
             <a:r>
-              <a:t>Quantized VLM + OCR + LLM</a:t>
+              <a:t>02  On-Device Inference</a:t>
             </a:r>
           </a:p>
           <a:p>
@@ -5978,7 +5867,7 @@
               </a:spcAft>
               <a:defRPr sz="1050">
                 <a:solidFill>
-                  <a:srgbClr val="AAB2C8"/>
+                  <a:srgbClr val="A5AFC3"/>
                 </a:solidFill>
               </a:defRPr>
             </a:pPr>
@@ -5993,7 +5882,7 @@
               </a:spcAft>
               <a:defRPr sz="1050">
                 <a:solidFill>
-                  <a:srgbClr val="AAB2C8"/>
+                  <a:srgbClr val="A5AFC3"/>
                 </a:solidFill>
               </a:defRPr>
             </a:pPr>
@@ -6008,7 +5897,7 @@
               </a:spcAft>
               <a:defRPr sz="1050">
                 <a:solidFill>
-                  <a:srgbClr val="AAB2C8"/>
+                  <a:srgbClr val="A5AFC3"/>
                 </a:solidFill>
               </a:defRPr>
             </a:pPr>
@@ -6026,16 +5915,16 @@
         </p:nvSpPr>
         <p:spPr>
           <a:xfrm>
-            <a:off x="8046720" y="1783080"/>
-            <a:ext cx="3429000" cy="2651760"/>
+            <a:off x="8127187" y="1783080"/>
+            <a:ext cx="3332073" cy="2651760"/>
           </a:xfrm>
           <a:prstGeom prst="roundRect">
             <a:avLst/>
           </a:prstGeom>
           <a:solidFill>
-            <a:srgbClr val="121520"/>
+            <a:srgbClr val="10141E"/>
           </a:solidFill>
-          <a:ln w="15240">
+          <a:ln w="12700">
             <a:solidFill>
               <a:srgbClr val="34C759"/>
             </a:solidFill>
@@ -6056,33 +5945,21 @@
           </a:fontRef>
         </p:style>
         <p:txBody>
-          <a:bodyPr rtlCol="0" anchor="ctr" wrap="square" lIns="228600" rIns="228600" tIns="201168" bIns="182880"/>
+          <a:bodyPr rtlCol="0" anchor="ctr" wrap="square" lIns="219456" rIns="219456" tIns="182880" bIns="164592"/>
           <a:lstStyle/>
           <a:p>
             <a:pPr algn="ctr">
-              <a:defRPr sz="850" b="1">
-                <a:solidFill>
-                  <a:srgbClr val="34C759"/>
-                </a:solidFill>
-              </a:defRPr>
-            </a:pPr>
-            <a:r>
-              <a:t>3. MULTI-MODAL OUTPUT</a:t>
-            </a:r>
-          </a:p>
-          <a:p>
-            <a:pPr>
               <a:spcAft>
-                <a:spcPts val="600"/>
+                <a:spcPts val="500"/>
               </a:spcAft>
-              <a:defRPr sz="1500" b="1">
+              <a:defRPr sz="1400" b="1">
                 <a:solidFill>
                   <a:srgbClr val="FFFFFF"/>
                 </a:solidFill>
               </a:defRPr>
             </a:pPr>
             <a:r>
-              <a:t>Neural TTS + Linear Haptics</a:t>
+              <a:t>03  Multi-Sensory Output</a:t>
             </a:r>
           </a:p>
           <a:p>
@@ -6092,7 +5969,7 @@
               </a:spcAft>
               <a:defRPr sz="1050">
                 <a:solidFill>
-                  <a:srgbClr val="AAB2C8"/>
+                  <a:srgbClr val="A5AFC3"/>
                 </a:solidFill>
               </a:defRPr>
             </a:pPr>
@@ -6107,7 +5984,7 @@
               </a:spcAft>
               <a:defRPr sz="1050">
                 <a:solidFill>
-                  <a:srgbClr val="AAB2C8"/>
+                  <a:srgbClr val="A5AFC3"/>
                 </a:solidFill>
               </a:defRPr>
             </a:pPr>
@@ -6122,7 +5999,7 @@
               </a:spcAft>
               <a:defRPr sz="1050">
                 <a:solidFill>
-                  <a:srgbClr val="AAB2C8"/>
+                  <a:srgbClr val="A5AFC3"/>
                 </a:solidFill>
               </a:defRPr>
             </a:pPr>
@@ -6141,15 +6018,15 @@
         <p:spPr>
           <a:xfrm>
             <a:off x="731520" y="4663440"/>
-            <a:ext cx="10744200" cy="1600200"/>
+            <a:ext cx="10728655" cy="1645920"/>
           </a:xfrm>
           <a:prstGeom prst="roundRect">
             <a:avLst/>
           </a:prstGeom>
           <a:solidFill>
-            <a:srgbClr val="121520"/>
+            <a:srgbClr val="10141E"/>
           </a:solidFill>
-          <a:ln>
+          <a:ln w="12700">
             <a:solidFill>
               <a:srgbClr val="FFD700"/>
             </a:solidFill>
@@ -6170,7 +6047,7 @@
           </a:fontRef>
         </p:style>
         <p:txBody>
-          <a:bodyPr rtlCol="0" anchor="ctr" lIns="365760" tIns="228600"/>
+          <a:bodyPr rtlCol="0" anchor="ctr" lIns="320040" tIns="182880"/>
           <a:lstStyle/>
           <a:p>
             <a:pPr algn="ctr">
@@ -6181,15 +6058,15 @@
               </a:defRPr>
             </a:pPr>
             <a:r>
-              <a:t>TIERED MODEL SELECTION  &amp;  ZERO-NETWORK GUARANTEE</a:t>
+              <a:t>HARDWARE SCALING &amp; AIR-GAPPED PRIVACY GUARANTEE</a:t>
             </a:r>
           </a:p>
           <a:p>
             <a:pPr>
               <a:spcBef>
-                <a:spcPts val="400"/>
+                <a:spcPts val="300"/>
               </a:spcBef>
-              <a:defRPr sz="1100">
+              <a:defRPr sz="1050">
                 <a:solidFill>
                   <a:srgbClr val="FFFFFF"/>
                 </a:solidFill>
@@ -6201,9 +6078,9 @@
           </a:p>
           <a:p>
             <a:pPr>
-              <a:defRPr sz="1100">
-                <a:solidFill>
-                  <a:srgbClr val="AAB2C8"/>
+              <a:defRPr sz="1050">
+                <a:solidFill>
+                  <a:srgbClr val="A5AFC3"/>
                 </a:solidFill>
               </a:defRPr>
             </a:pPr>
@@ -6213,7 +6090,7 @@
           </a:p>
           <a:p>
             <a:pPr>
-              <a:defRPr sz="1100">
+              <a:defRPr sz="1050">
                 <a:solidFill>
                   <a:srgbClr val="34C759"/>
                 </a:solidFill>
@@ -6258,7 +6135,7 @@
             <a:avLst/>
           </a:prstGeom>
           <a:solidFill>
-            <a:srgbClr val="05060A"/>
+            <a:srgbClr val="07090F"/>
           </a:solidFill>
           <a:ln>
             <a:noFill/>
@@ -6294,8 +6171,8 @@
         </p:nvSpPr>
         <p:spPr>
           <a:xfrm>
-            <a:off x="731520" y="365760"/>
-            <a:ext cx="10515600" cy="320040"/>
+            <a:off x="731520" y="384048"/>
+            <a:ext cx="10728655" cy="292608"/>
           </a:xfrm>
           <a:prstGeom prst="rect">
             <a:avLst/>
@@ -6303,13 +6180,13 @@
           <a:noFill/>
         </p:spPr>
         <p:txBody>
-          <a:bodyPr wrap="none">
+          <a:bodyPr wrap="none" lIns="0" rIns="0" tIns="0" bIns="0">
             <a:spAutoFit/>
           </a:bodyPr>
           <a:lstStyle/>
           <a:p>
             <a:pPr>
-              <a:defRPr sz="1000" b="1">
+              <a:defRPr sz="950" b="1">
                 <a:solidFill>
                   <a:srgbClr val="FFD700"/>
                 </a:solidFill>
@@ -6329,8 +6206,8 @@
         </p:nvSpPr>
         <p:spPr>
           <a:xfrm>
-            <a:off x="731520" y="640080"/>
-            <a:ext cx="10515600" cy="685800"/>
+            <a:off x="731520" y="658368"/>
+            <a:ext cx="10728655" cy="594360"/>
           </a:xfrm>
           <a:prstGeom prst="rect">
             <a:avLst/>
@@ -6338,7 +6215,7 @@
           <a:noFill/>
         </p:spPr>
         <p:txBody>
-          <a:bodyPr wrap="none">
+          <a:bodyPr wrap="none" lIns="0" rIns="0" tIns="0" bIns="0">
             <a:spAutoFit/>
           </a:bodyPr>
           <a:lstStyle/>
@@ -6364,8 +6241,8 @@
         </p:nvSpPr>
         <p:spPr>
           <a:xfrm>
-            <a:off x="731520" y="1234440"/>
-            <a:ext cx="10515600" cy="411480"/>
+            <a:off x="731520" y="1243584"/>
+            <a:ext cx="10728655" cy="384048"/>
           </a:xfrm>
           <a:prstGeom prst="rect">
             <a:avLst/>
@@ -6373,15 +6250,15 @@
           <a:noFill/>
         </p:spPr>
         <p:txBody>
-          <a:bodyPr wrap="none">
+          <a:bodyPr wrap="none" lIns="0" rIns="0" tIns="0" bIns="0">
             <a:spAutoFit/>
           </a:bodyPr>
           <a:lstStyle/>
           <a:p>
             <a:pPr>
-              <a:defRPr sz="1200">
-                <a:solidFill>
-                  <a:srgbClr val="AAB2C8"/>
+              <a:defRPr sz="1150">
+                <a:solidFill>
+                  <a:srgbClr val="A5AFC3"/>
                 </a:solidFill>
               </a:defRPr>
             </a:pPr>
@@ -6400,17 +6277,17 @@
         <p:spPr>
           <a:xfrm>
             <a:off x="731520" y="1783080"/>
-            <a:ext cx="6400800" cy="786384"/>
+            <a:ext cx="6309360" cy="786384"/>
           </a:xfrm>
           <a:prstGeom prst="roundRect">
             <a:avLst/>
           </a:prstGeom>
           <a:solidFill>
-            <a:srgbClr val="121520"/>
+            <a:srgbClr val="10141E"/>
           </a:solidFill>
-          <a:ln>
+          <a:ln w="12700">
             <a:solidFill>
-              <a:srgbClr val="2A3046"/>
+              <a:srgbClr val="262D3E"/>
             </a:solidFill>
           </a:ln>
         </p:spPr>
@@ -6433,7 +6310,7 @@
           <a:lstStyle/>
           <a:p>
             <a:pPr algn="ctr">
-              <a:defRPr sz="1200" b="1">
+              <a:defRPr sz="1150" b="1">
                 <a:solidFill>
                   <a:srgbClr val="FFFFFF"/>
                 </a:solidFill>
@@ -6447,7 +6324,7 @@
             <a:pPr>
               <a:defRPr sz="950">
                 <a:solidFill>
-                  <a:srgbClr val="AAB2C8"/>
+                  <a:srgbClr val="A5AFC3"/>
                 </a:solidFill>
               </a:defRPr>
             </a:pPr>
@@ -6466,15 +6343,15 @@
         <p:spPr>
           <a:xfrm>
             <a:off x="731520" y="2679191"/>
-            <a:ext cx="6400800" cy="786384"/>
+            <a:ext cx="6309360" cy="786384"/>
           </a:xfrm>
           <a:prstGeom prst="roundRect">
             <a:avLst/>
           </a:prstGeom>
           <a:solidFill>
-            <a:srgbClr val="121520"/>
+            <a:srgbClr val="10141E"/>
           </a:solidFill>
-          <a:ln>
+          <a:ln w="12700">
             <a:solidFill>
               <a:srgbClr val="FFD700"/>
             </a:solidFill>
@@ -6499,7 +6376,7 @@
           <a:lstStyle/>
           <a:p>
             <a:pPr algn="ctr">
-              <a:defRPr sz="1200" b="1">
+              <a:defRPr sz="1150" b="1">
                 <a:solidFill>
                   <a:srgbClr val="FFD700"/>
                 </a:solidFill>
@@ -6513,7 +6390,7 @@
             <a:pPr>
               <a:defRPr sz="950">
                 <a:solidFill>
-                  <a:srgbClr val="AAB2C8"/>
+                  <a:srgbClr val="A5AFC3"/>
                 </a:solidFill>
               </a:defRPr>
             </a:pPr>
@@ -6532,17 +6409,17 @@
         <p:spPr>
           <a:xfrm>
             <a:off x="731520" y="3575304"/>
-            <a:ext cx="6400800" cy="786384"/>
+            <a:ext cx="6309360" cy="786384"/>
           </a:xfrm>
           <a:prstGeom prst="roundRect">
             <a:avLst/>
           </a:prstGeom>
           <a:solidFill>
-            <a:srgbClr val="121520"/>
+            <a:srgbClr val="10141E"/>
           </a:solidFill>
-          <a:ln>
+          <a:ln w="12700">
             <a:solidFill>
-              <a:srgbClr val="2A3046"/>
+              <a:srgbClr val="262D3E"/>
             </a:solidFill>
           </a:ln>
         </p:spPr>
@@ -6565,7 +6442,7 @@
           <a:lstStyle/>
           <a:p>
             <a:pPr algn="ctr">
-              <a:defRPr sz="1200" b="1">
+              <a:defRPr sz="1150" b="1">
                 <a:solidFill>
                   <a:srgbClr val="FFFFFF"/>
                 </a:solidFill>
@@ -6579,7 +6456,7 @@
             <a:pPr>
               <a:defRPr sz="950">
                 <a:solidFill>
-                  <a:srgbClr val="AAB2C8"/>
+                  <a:srgbClr val="A5AFC3"/>
                 </a:solidFill>
               </a:defRPr>
             </a:pPr>
@@ -6598,17 +6475,17 @@
         <p:spPr>
           <a:xfrm>
             <a:off x="731520" y="4471416"/>
-            <a:ext cx="6400800" cy="786384"/>
+            <a:ext cx="6309360" cy="786384"/>
           </a:xfrm>
           <a:prstGeom prst="roundRect">
             <a:avLst/>
           </a:prstGeom>
           <a:solidFill>
-            <a:srgbClr val="121520"/>
+            <a:srgbClr val="10141E"/>
           </a:solidFill>
-          <a:ln>
+          <a:ln w="12700">
             <a:solidFill>
-              <a:srgbClr val="2A3046"/>
+              <a:srgbClr val="262D3E"/>
             </a:solidFill>
           </a:ln>
         </p:spPr>
@@ -6631,7 +6508,7 @@
           <a:lstStyle/>
           <a:p>
             <a:pPr algn="ctr">
-              <a:defRPr sz="1200" b="1">
+              <a:defRPr sz="1150" b="1">
                 <a:solidFill>
                   <a:srgbClr val="FFFFFF"/>
                 </a:solidFill>
@@ -6645,7 +6522,7 @@
             <a:pPr>
               <a:defRPr sz="950">
                 <a:solidFill>
-                  <a:srgbClr val="AAB2C8"/>
+                  <a:srgbClr val="A5AFC3"/>
                 </a:solidFill>
               </a:defRPr>
             </a:pPr>
@@ -6664,17 +6541,17 @@
         <p:spPr>
           <a:xfrm>
             <a:off x="731520" y="5367528"/>
-            <a:ext cx="6400800" cy="786384"/>
+            <a:ext cx="6309360" cy="786384"/>
           </a:xfrm>
           <a:prstGeom prst="roundRect">
             <a:avLst/>
           </a:prstGeom>
           <a:solidFill>
-            <a:srgbClr val="121520"/>
+            <a:srgbClr val="10141E"/>
           </a:solidFill>
-          <a:ln>
+          <a:ln w="12700">
             <a:solidFill>
-              <a:srgbClr val="2A3046"/>
+              <a:srgbClr val="262D3E"/>
             </a:solidFill>
           </a:ln>
         </p:spPr>
@@ -6697,7 +6574,7 @@
           <a:lstStyle/>
           <a:p>
             <a:pPr algn="ctr">
-              <a:defRPr sz="1200" b="1">
+              <a:defRPr sz="1150" b="1">
                 <a:solidFill>
                   <a:srgbClr val="FFFFFF"/>
                 </a:solidFill>
@@ -6711,7 +6588,7 @@
             <a:pPr>
               <a:defRPr sz="950">
                 <a:solidFill>
-                  <a:srgbClr val="AAB2C8"/>
+                  <a:srgbClr val="A5AFC3"/>
                 </a:solidFill>
               </a:defRPr>
             </a:pPr>
@@ -6729,18 +6606,18 @@
         </p:nvSpPr>
         <p:spPr>
           <a:xfrm>
-            <a:off x="7406640" y="1783080"/>
-            <a:ext cx="4023360" cy="4434840"/>
+            <a:off x="7315200" y="1783080"/>
+            <a:ext cx="4144975" cy="4434840"/>
           </a:xfrm>
           <a:prstGeom prst="roundRect">
             <a:avLst/>
           </a:prstGeom>
           <a:solidFill>
-            <a:srgbClr val="121520"/>
+            <a:srgbClr val="10141E"/>
           </a:solidFill>
-          <a:ln w="15240">
+          <a:ln w="12700">
             <a:solidFill>
-              <a:srgbClr val="2A3046"/>
+              <a:srgbClr val="262D3E"/>
             </a:solidFill>
           </a:ln>
         </p:spPr>
@@ -6768,7 +6645,7 @@
       </p:sp>
       <p:pic>
         <p:nvPicPr>
-          <p:cNvPr id="12" name="Picture 11" descr="iqoo-spatial-hallway.jpg"/>
+          <p:cNvPr id="12" name="Picture 11" descr="real_tactile_yellow_paving.jpg"/>
           <p:cNvPicPr>
             <a:picLocks noChangeAspect="1"/>
           </p:cNvPicPr>
@@ -6782,8 +6659,8 @@
         </p:blipFill>
         <p:spPr>
           <a:xfrm>
-            <a:off x="7479792" y="1856232"/>
-            <a:ext cx="3877056" cy="3840480"/>
+            <a:off x="7388352" y="1856232"/>
+            <a:ext cx="3998671" cy="3511296"/>
           </a:xfrm>
           <a:prstGeom prst="rect">
             <a:avLst/>
@@ -6798,8 +6675,8 @@
         </p:nvSpPr>
         <p:spPr>
           <a:xfrm>
-            <a:off x="7543800" y="5715000"/>
-            <a:ext cx="3749040" cy="457200"/>
+            <a:off x="7452360" y="5385816"/>
+            <a:ext cx="3870655" cy="685800"/>
           </a:xfrm>
           <a:prstGeom prst="rect">
             <a:avLst/>
@@ -6807,20 +6684,35 @@
           <a:noFill/>
         </p:spPr>
         <p:txBody>
-          <a:bodyPr wrap="square">
+          <a:bodyPr wrap="square" lIns="0" rIns="0" tIns="0" bIns="0">
             <a:spAutoFit/>
           </a:bodyPr>
           <a:lstStyle/>
           <a:p>
-            <a:pPr algn="ctr">
-              <a:defRPr sz="950" b="1">
+            <a:pPr>
+              <a:defRPr sz="850" b="1">
                 <a:solidFill>
                   <a:srgbClr val="FFD700"/>
                 </a:solidFill>
               </a:defRPr>
             </a:pPr>
             <a:r>
-              <a:t>iQOO On-Device Spatial Guidance: 12-Sector Radar &amp; Obstacle HUD</a:t>
+              <a:t>TACTILE ACCESSIBILITY PROOF</a:t>
+            </a:r>
+          </a:p>
+          <a:p>
+            <a:pPr>
+              <a:spcBef>
+                <a:spcPts val="200"/>
+              </a:spcBef>
+              <a:defRPr sz="950">
+                <a:solidFill>
+                  <a:srgbClr val="A5AFC3"/>
+                </a:solidFill>
+              </a:defRPr>
+            </a:pPr>
+            <a:r>
+              <a:t>100% verifiable offline operation in Airplane Mode — zero dependence on venue Wi-Fi or cellular networks.</a:t>
             </a:r>
           </a:p>
         </p:txBody>
@@ -6858,7 +6750,7 @@
             <a:avLst/>
           </a:prstGeom>
           <a:solidFill>
-            <a:srgbClr val="05060A"/>
+            <a:srgbClr val="07090F"/>
           </a:solidFill>
           <a:ln>
             <a:noFill/>
@@ -6894,8 +6786,8 @@
         </p:nvSpPr>
         <p:spPr>
           <a:xfrm>
-            <a:off x="731520" y="365760"/>
-            <a:ext cx="10515600" cy="320040"/>
+            <a:off x="731520" y="384048"/>
+            <a:ext cx="10728655" cy="292608"/>
           </a:xfrm>
           <a:prstGeom prst="rect">
             <a:avLst/>
@@ -6903,13 +6795,13 @@
           <a:noFill/>
         </p:spPr>
         <p:txBody>
-          <a:bodyPr wrap="none">
+          <a:bodyPr wrap="none" lIns="0" rIns="0" tIns="0" bIns="0">
             <a:spAutoFit/>
           </a:bodyPr>
           <a:lstStyle/>
           <a:p>
             <a:pPr>
-              <a:defRPr sz="1000" b="1">
+              <a:defRPr sz="950" b="1">
                 <a:solidFill>
                   <a:srgbClr val="FFD700"/>
                 </a:solidFill>
@@ -6929,8 +6821,8 @@
         </p:nvSpPr>
         <p:spPr>
           <a:xfrm>
-            <a:off x="731520" y="640080"/>
-            <a:ext cx="10515600" cy="685800"/>
+            <a:off x="731520" y="658368"/>
+            <a:ext cx="10728655" cy="594360"/>
           </a:xfrm>
           <a:prstGeom prst="rect">
             <a:avLst/>
@@ -6938,7 +6830,7 @@
           <a:noFill/>
         </p:spPr>
         <p:txBody>
-          <a:bodyPr wrap="none">
+          <a:bodyPr wrap="none" lIns="0" rIns="0" tIns="0" bIns="0">
             <a:spAutoFit/>
           </a:bodyPr>
           <a:lstStyle/>
@@ -6964,8 +6856,8 @@
         </p:nvSpPr>
         <p:spPr>
           <a:xfrm>
-            <a:off x="731520" y="1234440"/>
-            <a:ext cx="10515600" cy="411480"/>
+            <a:off x="731520" y="1243584"/>
+            <a:ext cx="10728655" cy="384048"/>
           </a:xfrm>
           <a:prstGeom prst="rect">
             <a:avLst/>
@@ -6973,15 +6865,15 @@
           <a:noFill/>
         </p:spPr>
         <p:txBody>
-          <a:bodyPr wrap="none">
+          <a:bodyPr wrap="none" lIns="0" rIns="0" tIns="0" bIns="0">
             <a:spAutoFit/>
           </a:bodyPr>
           <a:lstStyle/>
           <a:p>
             <a:pPr>
-              <a:defRPr sz="1200">
-                <a:solidFill>
-                  <a:srgbClr val="AAB2C8"/>
+              <a:defRPr sz="1150">
+                <a:solidFill>
+                  <a:srgbClr val="A5AFC3"/>
                 </a:solidFill>
               </a:defRPr>
             </a:pPr>
@@ -7000,17 +6892,17 @@
         <p:spPr>
           <a:xfrm>
             <a:off x="731520" y="1783080"/>
-            <a:ext cx="4114800" cy="4526280"/>
+            <a:ext cx="3931920" cy="4526280"/>
           </a:xfrm>
           <a:prstGeom prst="roundRect">
             <a:avLst/>
           </a:prstGeom>
           <a:solidFill>
-            <a:srgbClr val="121520"/>
+            <a:srgbClr val="10141E"/>
           </a:solidFill>
-          <a:ln w="15240">
+          <a:ln w="12700">
             <a:solidFill>
-              <a:srgbClr val="2A3046"/>
+              <a:srgbClr val="262D3E"/>
             </a:solidFill>
           </a:ln>
         </p:spPr>
@@ -7038,7 +6930,7 @@
       </p:sp>
       <p:pic>
         <p:nvPicPr>
-          <p:cNvPr id="7" name="Picture 6" descr="elderly-medicine-scan.jpg"/>
+          <p:cNvPr id="7" name="Picture 6" descr="real_elderly_reading.jpg"/>
           <p:cNvPicPr>
             <a:picLocks noChangeAspect="1"/>
           </p:cNvPicPr>
@@ -7053,7 +6945,7 @@
         <p:spPr>
           <a:xfrm>
             <a:off x="804672" y="1856232"/>
-            <a:ext cx="3968496" cy="3931920"/>
+            <a:ext cx="3785616" cy="3602736"/>
           </a:xfrm>
           <a:prstGeom prst="rect">
             <a:avLst/>
@@ -7068,8 +6960,8 @@
         </p:nvSpPr>
         <p:spPr>
           <a:xfrm>
-            <a:off x="868680" y="5806440"/>
-            <a:ext cx="3840480" cy="457200"/>
+            <a:off x="868680" y="5477256"/>
+            <a:ext cx="3657600" cy="685800"/>
           </a:xfrm>
           <a:prstGeom prst="rect">
             <a:avLst/>
@@ -7077,20 +6969,35 @@
           <a:noFill/>
         </p:spPr>
         <p:txBody>
-          <a:bodyPr wrap="square">
+          <a:bodyPr wrap="square" lIns="0" rIns="0" tIns="0" bIns="0">
             <a:spAutoFit/>
           </a:bodyPr>
           <a:lstStyle/>
           <a:p>
-            <a:pPr algn="ctr">
-              <a:defRPr sz="950" b="1">
+            <a:pPr>
+              <a:defRPr sz="850" b="1">
                 <a:solidFill>
                   <a:srgbClr val="FFD700"/>
                 </a:solidFill>
               </a:defRPr>
             </a:pPr>
             <a:r>
-              <a:t>Everyday Independence: Empowering elderly &amp; visually impaired users at home</a:t>
+              <a:t>EVERYDAY INDEPENDENCE</a:t>
+            </a:r>
+          </a:p>
+          <a:p>
+            <a:pPr>
+              <a:spcBef>
+                <a:spcPts val="200"/>
+              </a:spcBef>
+              <a:defRPr sz="950">
+                <a:solidFill>
+                  <a:srgbClr val="A5AFC3"/>
+                </a:solidFill>
+              </a:defRPr>
+            </a:pPr>
+            <a:r>
+              <a:t>Enabling elderly and low-vision individuals to read prescriptions, verify dosages, and navigate independently.</a:t>
             </a:r>
           </a:p>
         </p:txBody>
@@ -7104,15 +7011,15 @@
         <p:spPr>
           <a:xfrm>
             <a:off x="5029200" y="1783080"/>
-            <a:ext cx="6492240" cy="1371600"/>
+            <a:ext cx="6430975" cy="1353312"/>
           </a:xfrm>
           <a:prstGeom prst="roundRect">
             <a:avLst/>
           </a:prstGeom>
           <a:solidFill>
-            <a:srgbClr val="121520"/>
+            <a:srgbClr val="10141E"/>
           </a:solidFill>
-          <a:ln w="15240">
+          <a:ln w="12700">
             <a:solidFill>
               <a:srgbClr val="FFD700"/>
             </a:solidFill>
@@ -7133,33 +7040,21 @@
           </a:fontRef>
         </p:style>
         <p:txBody>
-          <a:bodyPr rtlCol="0" anchor="ctr" wrap="square" lIns="228600" rIns="228600" tIns="201168" bIns="182880"/>
+          <a:bodyPr rtlCol="0" anchor="ctr" wrap="square" lIns="219456" rIns="219456" tIns="182880" bIns="164592"/>
           <a:lstStyle/>
           <a:p>
             <a:pPr algn="ctr">
-              <a:defRPr sz="850" b="1">
-                <a:solidFill>
-                  <a:srgbClr val="FFD700"/>
-                </a:solidFill>
-              </a:defRPr>
-            </a:pPr>
-            <a:r>
-              <a:t>PILLAR 1</a:t>
-            </a:r>
-          </a:p>
-          <a:p>
-            <a:pPr>
               <a:spcAft>
-                <a:spcPts val="600"/>
+                <a:spcPts val="500"/>
               </a:spcAft>
-              <a:defRPr sz="1400" b="1">
+              <a:defRPr sz="1350" b="1">
                 <a:solidFill>
                   <a:srgbClr val="FFFFFF"/>
                 </a:solidFill>
               </a:defRPr>
             </a:pPr>
             <a:r>
-              <a:t>🌟  Real Everyday Independence</a:t>
+              <a:t>01  Real Everyday Independence</a:t>
             </a:r>
           </a:p>
           <a:p>
@@ -7169,7 +7064,7 @@
               </a:spcAft>
               <a:defRPr sz="1000">
                 <a:solidFill>
-                  <a:srgbClr val="AAB2C8"/>
+                  <a:srgbClr val="A5AFC3"/>
                 </a:solidFill>
               </a:defRPr>
             </a:pPr>
@@ -7184,7 +7079,7 @@
               </a:spcAft>
               <a:defRPr sz="1000">
                 <a:solidFill>
-                  <a:srgbClr val="AAB2C8"/>
+                  <a:srgbClr val="A5AFC3"/>
                 </a:solidFill>
               </a:defRPr>
             </a:pPr>
@@ -7199,7 +7094,7 @@
               </a:spcAft>
               <a:defRPr sz="1000">
                 <a:solidFill>
-                  <a:srgbClr val="AAB2C8"/>
+                  <a:srgbClr val="A5AFC3"/>
                 </a:solidFill>
               </a:defRPr>
             </a:pPr>
@@ -7217,16 +7112,16 @@
         </p:nvSpPr>
         <p:spPr>
           <a:xfrm>
-            <a:off x="5029200" y="3337560"/>
-            <a:ext cx="6492240" cy="1371600"/>
+            <a:off x="5029200" y="3364992"/>
+            <a:ext cx="6430975" cy="1353312"/>
           </a:xfrm>
           <a:prstGeom prst="roundRect">
             <a:avLst/>
           </a:prstGeom>
           <a:solidFill>
-            <a:srgbClr val="121520"/>
+            <a:srgbClr val="10141E"/>
           </a:solidFill>
-          <a:ln w="15240">
+          <a:ln w="12700">
             <a:solidFill>
               <a:srgbClr val="34C759"/>
             </a:solidFill>
@@ -7247,33 +7142,21 @@
           </a:fontRef>
         </p:style>
         <p:txBody>
-          <a:bodyPr rtlCol="0" anchor="ctr" wrap="square" lIns="228600" rIns="228600" tIns="201168" bIns="182880"/>
+          <a:bodyPr rtlCol="0" anchor="ctr" wrap="square" lIns="219456" rIns="219456" tIns="182880" bIns="164592"/>
           <a:lstStyle/>
           <a:p>
             <a:pPr algn="ctr">
-              <a:defRPr sz="850" b="1">
-                <a:solidFill>
-                  <a:srgbClr val="34C759"/>
-                </a:solidFill>
-              </a:defRPr>
-            </a:pPr>
-            <a:r>
-              <a:t>PILLAR 2</a:t>
-            </a:r>
-          </a:p>
-          <a:p>
-            <a:pPr>
               <a:spcAft>
-                <a:spcPts val="600"/>
+                <a:spcPts val="500"/>
               </a:spcAft>
-              <a:defRPr sz="1400" b="1">
+              <a:defRPr sz="1350" b="1">
                 <a:solidFill>
                   <a:srgbClr val="FFFFFF"/>
                 </a:solidFill>
               </a:defRPr>
             </a:pPr>
             <a:r>
-              <a:t>📱  Works on Budget Phones</a:t>
+              <a:t>02  Works on Budget Phones</a:t>
             </a:r>
           </a:p>
           <a:p>
@@ -7283,7 +7166,7 @@
               </a:spcAft>
               <a:defRPr sz="1000">
                 <a:solidFill>
-                  <a:srgbClr val="AAB2C8"/>
+                  <a:srgbClr val="A5AFC3"/>
                 </a:solidFill>
               </a:defRPr>
             </a:pPr>
@@ -7298,7 +7181,7 @@
               </a:spcAft>
               <a:defRPr sz="1000">
                 <a:solidFill>
-                  <a:srgbClr val="AAB2C8"/>
+                  <a:srgbClr val="A5AFC3"/>
                 </a:solidFill>
               </a:defRPr>
             </a:pPr>
@@ -7313,7 +7196,7 @@
               </a:spcAft>
               <a:defRPr sz="1000">
                 <a:solidFill>
-                  <a:srgbClr val="AAB2C8"/>
+                  <a:srgbClr val="A5AFC3"/>
                 </a:solidFill>
               </a:defRPr>
             </a:pPr>
@@ -7331,18 +7214,18 @@
         </p:nvSpPr>
         <p:spPr>
           <a:xfrm>
-            <a:off x="5029200" y="4892040"/>
-            <a:ext cx="6492240" cy="1371600"/>
+            <a:off x="5029200" y="4956048"/>
+            <a:ext cx="6430975" cy="1353312"/>
           </a:xfrm>
           <a:prstGeom prst="roundRect">
             <a:avLst/>
           </a:prstGeom>
           <a:solidFill>
-            <a:srgbClr val="121520"/>
+            <a:srgbClr val="10141E"/>
           </a:solidFill>
-          <a:ln w="15240">
+          <a:ln w="12700">
             <a:solidFill>
-              <a:srgbClr val="00E5FF"/>
+              <a:srgbClr val="00D7FA"/>
             </a:solidFill>
           </a:ln>
         </p:spPr>
@@ -7361,33 +7244,21 @@
           </a:fontRef>
         </p:style>
         <p:txBody>
-          <a:bodyPr rtlCol="0" anchor="ctr" wrap="square" lIns="228600" rIns="228600" tIns="201168" bIns="182880"/>
+          <a:bodyPr rtlCol="0" anchor="ctr" wrap="square" lIns="219456" rIns="219456" tIns="182880" bIns="164592"/>
           <a:lstStyle/>
           <a:p>
             <a:pPr algn="ctr">
-              <a:defRPr sz="850" b="1">
-                <a:solidFill>
-                  <a:srgbClr val="00E5FF"/>
-                </a:solidFill>
-              </a:defRPr>
-            </a:pPr>
-            <a:r>
-              <a:t>PILLAR 3</a:t>
-            </a:r>
-          </a:p>
-          <a:p>
-            <a:pPr>
               <a:spcAft>
-                <a:spcPts val="600"/>
+                <a:spcPts val="500"/>
               </a:spcAft>
-              <a:defRPr sz="1400" b="1">
+              <a:defRPr sz="1350" b="1">
                 <a:solidFill>
                   <a:srgbClr val="FFFFFF"/>
                 </a:solidFill>
               </a:defRPr>
             </a:pPr>
             <a:r>
-              <a:t>🛡️  No Subscriptions, Data Harvesting, or Cloud Dependency</a:t>
+              <a:t>03  Zero Subscriptions &amp; Zero Data Harvesting</a:t>
             </a:r>
           </a:p>
           <a:p>
@@ -7397,7 +7268,7 @@
               </a:spcAft>
               <a:defRPr sz="1000">
                 <a:solidFill>
-                  <a:srgbClr val="AAB2C8"/>
+                  <a:srgbClr val="A5AFC3"/>
                 </a:solidFill>
               </a:defRPr>
             </a:pPr>
@@ -7412,7 +7283,7 @@
               </a:spcAft>
               <a:defRPr sz="1000">
                 <a:solidFill>
-                  <a:srgbClr val="AAB2C8"/>
+                  <a:srgbClr val="A5AFC3"/>
                 </a:solidFill>
               </a:defRPr>
             </a:pPr>
@@ -7427,7 +7298,7 @@
               </a:spcAft>
               <a:defRPr sz="1000">
                 <a:solidFill>
-                  <a:srgbClr val="AAB2C8"/>
+                  <a:srgbClr val="A5AFC3"/>
                 </a:solidFill>
               </a:defRPr>
             </a:pPr>
@@ -7470,7 +7341,7 @@
             <a:avLst/>
           </a:prstGeom>
           <a:solidFill>
-            <a:srgbClr val="05060A"/>
+            <a:srgbClr val="07090F"/>
           </a:solidFill>
           <a:ln>
             <a:noFill/>
@@ -7506,14 +7377,14 @@
         </p:nvSpPr>
         <p:spPr>
           <a:xfrm>
-            <a:off x="731520" y="1097280"/>
-            <a:ext cx="5486400" cy="384048"/>
+            <a:off x="731520" y="1005840"/>
+            <a:ext cx="5303520" cy="365760"/>
           </a:xfrm>
           <a:prstGeom prst="roundRect">
             <a:avLst/>
           </a:prstGeom>
           <a:solidFill>
-            <a:srgbClr val="19160A"/>
+            <a:srgbClr val="16140A"/>
           </a:solidFill>
           <a:ln>
             <a:solidFill>
@@ -7560,8 +7431,8 @@
         </p:nvSpPr>
         <p:spPr>
           <a:xfrm>
-            <a:off x="731520" y="1645920"/>
-            <a:ext cx="5669280" cy="1188720"/>
+            <a:off x="731520" y="1554480"/>
+            <a:ext cx="5486400" cy="1188720"/>
           </a:xfrm>
           <a:prstGeom prst="rect">
             <a:avLst/>
@@ -7569,7 +7440,7 @@
           <a:noFill/>
         </p:spPr>
         <p:txBody>
-          <a:bodyPr wrap="none">
+          <a:bodyPr wrap="none" lIns="0" rIns="0" tIns="0" bIns="0">
             <a:spAutoFit/>
           </a:bodyPr>
           <a:lstStyle/>
@@ -7587,7 +7458,7 @@
           </a:p>
           <a:p>
             <a:pPr>
-              <a:defRPr sz="1700">
+              <a:defRPr sz="1600">
                 <a:solidFill>
                   <a:srgbClr val="FFD700"/>
                 </a:solidFill>
@@ -7607,14 +7478,14 @@
         </p:nvSpPr>
         <p:spPr>
           <a:xfrm>
-            <a:off x="731520" y="3108960"/>
-            <a:ext cx="5669280" cy="1280160"/>
+            <a:off x="731520" y="3017520"/>
+            <a:ext cx="5486400" cy="1280160"/>
           </a:xfrm>
           <a:prstGeom prst="roundRect">
             <a:avLst/>
           </a:prstGeom>
           <a:solidFill>
-            <a:srgbClr val="121520"/>
+            <a:srgbClr val="10141E"/>
           </a:solidFill>
           <a:ln>
             <a:solidFill>
@@ -7641,7 +7512,7 @@
           <a:lstStyle/>
           <a:p>
             <a:pPr algn="ctr">
-              <a:defRPr sz="1800" b="1">
+              <a:defRPr sz="1750" b="1">
                 <a:solidFill>
                   <a:srgbClr val="FFF0B4"/>
                 </a:solidFill>
@@ -7665,18 +7536,18 @@
         </p:nvSpPr>
         <p:spPr>
           <a:xfrm>
-            <a:off x="731520" y="4617720"/>
-            <a:ext cx="5669280" cy="1600200"/>
+            <a:off x="731520" y="4526280"/>
+            <a:ext cx="5486400" cy="1600200"/>
           </a:xfrm>
           <a:prstGeom prst="roundRect">
             <a:avLst/>
           </a:prstGeom>
           <a:solidFill>
-            <a:srgbClr val="121520"/>
+            <a:srgbClr val="10141E"/>
           </a:solidFill>
           <a:ln>
             <a:solidFill>
-              <a:srgbClr val="2A3046"/>
+              <a:srgbClr val="262D3E"/>
             </a:solidFill>
           </a:ln>
         </p:spPr>
@@ -7695,11 +7566,11 @@
           </a:fontRef>
         </p:style>
         <p:txBody>
-          <a:bodyPr rtlCol="0" anchor="ctr" lIns="274320" tIns="182880"/>
+          <a:bodyPr rtlCol="0" anchor="ctr" lIns="256032" tIns="164592"/>
           <a:lstStyle/>
           <a:p>
             <a:pPr algn="ctr">
-              <a:defRPr sz="1300" b="1">
+              <a:defRPr sz="1250" b="1">
                 <a:solidFill>
                   <a:srgbClr val="FFFFFF"/>
                 </a:solidFill>
@@ -7707,21 +7578,6 @@
             </a:pPr>
             <a:r>
               <a:t>TEAM: [Team Name / Team Members]</a:t>
-            </a:r>
-          </a:p>
-          <a:p>
-            <a:pPr>
-              <a:spcBef>
-                <a:spcPts val="400"/>
-              </a:spcBef>
-              <a:defRPr sz="1050">
-                <a:solidFill>
-                  <a:srgbClr val="FFD700"/>
-                </a:solidFill>
-              </a:defRPr>
-            </a:pPr>
-            <a:r>
-              <a:t>Track: Smart Living / Accessibility Tech (Hyderabad City Battle)</a:t>
             </a:r>
           </a:p>
           <a:p>
@@ -7731,7 +7587,22 @@
               </a:spcBef>
               <a:defRPr sz="1000">
                 <a:solidFill>
-                  <a:srgbClr val="AAB2C8"/>
+                  <a:srgbClr val="FFD700"/>
+                </a:solidFill>
+              </a:defRPr>
+            </a:pPr>
+            <a:r>
+              <a:t>Track: Smart Living / Accessibility Tech (Hyderabad City Battle)</a:t>
+            </a:r>
+          </a:p>
+          <a:p>
+            <a:pPr>
+              <a:spcBef>
+                <a:spcPts val="200"/>
+              </a:spcBef>
+              <a:defRPr sz="950">
+                <a:solidFill>
+                  <a:srgbClr val="A5AFC3"/>
                 </a:solidFill>
               </a:defRPr>
             </a:pPr>
@@ -7741,9 +7612,9 @@
           </a:p>
           <a:p>
             <a:pPr>
-              <a:defRPr sz="1000">
-                <a:solidFill>
-                  <a:srgbClr val="00E5FF"/>
+              <a:defRPr sz="950">
+                <a:solidFill>
+                  <a:srgbClr val="00D7FA"/>
                 </a:solidFill>
               </a:defRPr>
             </a:pPr>
@@ -7761,18 +7632,18 @@
         </p:nvSpPr>
         <p:spPr>
           <a:xfrm>
-            <a:off x="6766560" y="1097280"/>
-            <a:ext cx="4663440" cy="5120640"/>
+            <a:off x="6583680" y="1005840"/>
+            <a:ext cx="4876495" cy="5120640"/>
           </a:xfrm>
           <a:prstGeom prst="roundRect">
             <a:avLst/>
           </a:prstGeom>
           <a:solidFill>
-            <a:srgbClr val="121520"/>
+            <a:srgbClr val="10141E"/>
           </a:solidFill>
-          <a:ln w="15240">
+          <a:ln w="12700">
             <a:solidFill>
-              <a:srgbClr val="2A3046"/>
+              <a:srgbClr val="262D3E"/>
             </a:solidFill>
           </a:ln>
         </p:spPr>
@@ -7800,7 +7671,7 @@
       </p:sp>
       <p:pic>
         <p:nvPicPr>
-          <p:cNvPr id="8" name="Picture 7" descr="visually-impaired-nav.jpg"/>
+          <p:cNvPr id="8" name="Picture 7" descr="real_blind_cane_walking.jpg"/>
           <p:cNvPicPr>
             <a:picLocks noChangeAspect="1"/>
           </p:cNvPicPr>
@@ -7814,8 +7685,8 @@
         </p:blipFill>
         <p:spPr>
           <a:xfrm>
-            <a:off x="6839712" y="1170432"/>
-            <a:ext cx="4517136" cy="4526280"/>
+            <a:off x="6656832" y="1078992"/>
+            <a:ext cx="4730191" cy="4197096"/>
           </a:xfrm>
           <a:prstGeom prst="rect">
             <a:avLst/>
@@ -7830,8 +7701,8 @@
         </p:nvSpPr>
         <p:spPr>
           <a:xfrm>
-            <a:off x="6903720" y="5715000"/>
-            <a:ext cx="4389120" cy="457200"/>
+            <a:off x="6720840" y="5294376"/>
+            <a:ext cx="4602175" cy="685800"/>
           </a:xfrm>
           <a:prstGeom prst="rect">
             <a:avLst/>
@@ -7839,20 +7710,35 @@
           <a:noFill/>
         </p:spPr>
         <p:txBody>
-          <a:bodyPr wrap="square">
+          <a:bodyPr wrap="square" lIns="0" rIns="0" tIns="0" bIns="0">
             <a:spAutoFit/>
           </a:bodyPr>
           <a:lstStyle/>
           <a:p>
-            <a:pPr algn="ctr">
-              <a:defRPr sz="950" b="1">
+            <a:pPr>
+              <a:defRPr sz="850" b="1">
                 <a:solidFill>
                   <a:srgbClr val="FFD700"/>
                 </a:solidFill>
               </a:defRPr>
             </a:pPr>
             <a:r>
-              <a:t>Drishti: Empowering visually impaired individuals with on-device AI</a:t>
+              <a:t>AUTONOMY IN SMART LIVING</a:t>
+            </a:r>
+          </a:p>
+          <a:p>
+            <a:pPr>
+              <a:spcBef>
+                <a:spcPts val="200"/>
+              </a:spcBef>
+              <a:defRPr sz="950">
+                <a:solidFill>
+                  <a:srgbClr val="A5AFC3"/>
+                </a:solidFill>
+              </a:defRPr>
+            </a:pPr>
+            <a:r>
+              <a:t>Restoring mobility, safety, and personal dignity through zero-cloud on-device intelligence.</a:t>
             </a:r>
           </a:p>
         </p:txBody>

</xml_diff>

<commit_message>
Add comprehensive 2000+ word Problem Statement and Technical Solution document, updated pitch deck
</commit_message>
<xml_diff>
--- a/Drishti_Pitch_Deck.pptx
+++ b/Drishti_Pitch_Deck.pptx
@@ -5,16 +5,16 @@
     <p:sldMasterId id="2147483648" r:id="rId1"/>
   </p:sldMasterIdLst>
   <p:sldIdLst>
-    <p:sldId id="256" r:id="rId7"/>
-    <p:sldId id="257" r:id="rId8"/>
-    <p:sldId id="258" r:id="rId9"/>
-    <p:sldId id="259" r:id="rId10"/>
-    <p:sldId id="260" r:id="rId11"/>
-    <p:sldId id="261" r:id="rId12"/>
-    <p:sldId id="262" r:id="rId13"/>
-    <p:sldId id="263" r:id="rId14"/>
+    <p:sldId id="256" r:id="rId2"/>
+    <p:sldId id="257" r:id="rId3"/>
+    <p:sldId id="258" r:id="rId4"/>
+    <p:sldId id="259" r:id="rId5"/>
+    <p:sldId id="260" r:id="rId6"/>
+    <p:sldId id="261" r:id="rId7"/>
+    <p:sldId id="262" r:id="rId8"/>
+    <p:sldId id="263" r:id="rId9"/>
   </p:sldIdLst>
-  <p:sldSz cx="12191695" cy="6858000" type="screen4x3"/>
+  <p:sldSz cx="12192000" cy="6858000"/>
   <p:notesSz cx="6858000" cy="9144000"/>
   <p:defaultTextStyle>
     <a:defPPr>
@@ -111,6 +111,22 @@
       </a:defRPr>
     </a:lvl9pPr>
   </p:defaultTextStyle>
+  <p:extLst>
+    <p:ext uri="{EFAFB233-063F-42B5-8137-9DF3F51BA10A}">
+      <p15:sldGuideLst xmlns:p15="http://schemas.microsoft.com/office/powerpoint/2012/main">
+        <p15:guide id="1" orient="horz" pos="2160">
+          <p15:clr>
+            <a:srgbClr val="A4A3A4"/>
+          </p15:clr>
+        </p15:guide>
+        <p15:guide id="2" pos="2880">
+          <p15:clr>
+            <a:srgbClr val="A4A3A4"/>
+          </p15:clr>
+        </p15:guide>
+      </p15:sldGuideLst>
+    </p:ext>
+  </p:extLst>
 </p:presentation>
 </file>
 
@@ -152,10 +168,9 @@
           <a:lstStyle/>
           <a:p>
             <a:r>
-              <a:rPr lang="en-US" smtClean="0"/>
+              <a:rPr lang="en-US"/>
               <a:t>Click to edit Master title style</a:t>
             </a:r>
-            <a:endParaRPr lang="en-US"/>
           </a:p>
         </p:txBody>
       </p:sp>
@@ -271,10 +286,9 @@
           </a:lstStyle>
           <a:p>
             <a:r>
-              <a:rPr lang="en-US" smtClean="0"/>
+              <a:rPr lang="en-US"/>
               <a:t>Click to edit Master subtitle style</a:t>
             </a:r>
-            <a:endParaRPr lang="en-US"/>
           </a:p>
         </p:txBody>
       </p:sp>
@@ -295,7 +309,7 @@
           <a:p>
             <a:fld id="{5BCAD085-E8A6-8845-BD4E-CB4CCA059FC4}" type="datetimeFigureOut">
               <a:rPr lang="en-US" smtClean="0"/>
-              <a:t>1/27/13</a:t>
+              <a:t>9/22/2026</a:t>
             </a:fld>
             <a:endParaRPr lang="en-US"/>
           </a:p>
@@ -389,10 +403,9 @@
           <a:lstStyle/>
           <a:p>
             <a:r>
-              <a:rPr lang="en-US" smtClean="0"/>
+              <a:rPr lang="en-US"/>
               <a:t>Click to edit Master title style</a:t>
             </a:r>
-            <a:endParaRPr lang="en-US"/>
           </a:p>
         </p:txBody>
       </p:sp>
@@ -413,38 +426,37 @@
           <a:p>
             <a:pPr lvl="0"/>
             <a:r>
-              <a:rPr lang="en-US" smtClean="0"/>
+              <a:rPr lang="en-US"/>
               <a:t>Click to edit Master text styles</a:t>
             </a:r>
           </a:p>
           <a:p>
             <a:pPr lvl="1"/>
             <a:r>
-              <a:rPr lang="en-US" smtClean="0"/>
+              <a:rPr lang="en-US"/>
               <a:t>Second level</a:t>
             </a:r>
           </a:p>
           <a:p>
             <a:pPr lvl="2"/>
             <a:r>
-              <a:rPr lang="en-US" smtClean="0"/>
+              <a:rPr lang="en-US"/>
               <a:t>Third level</a:t>
             </a:r>
           </a:p>
           <a:p>
             <a:pPr lvl="3"/>
             <a:r>
-              <a:rPr lang="en-US" smtClean="0"/>
+              <a:rPr lang="en-US"/>
               <a:t>Fourth level</a:t>
             </a:r>
           </a:p>
           <a:p>
             <a:pPr lvl="4"/>
             <a:r>
-              <a:rPr lang="en-US" smtClean="0"/>
+              <a:rPr lang="en-US"/>
               <a:t>Fifth level</a:t>
             </a:r>
-            <a:endParaRPr lang="en-US"/>
           </a:p>
         </p:txBody>
       </p:sp>
@@ -465,7 +477,7 @@
           <a:p>
             <a:fld id="{5BCAD085-E8A6-8845-BD4E-CB4CCA059FC4}" type="datetimeFigureOut">
               <a:rPr lang="en-US" smtClean="0"/>
-              <a:t>1/27/13</a:t>
+              <a:t>9/22/2026</a:t>
             </a:fld>
             <a:endParaRPr lang="en-US"/>
           </a:p>
@@ -564,10 +576,9 @@
           <a:lstStyle/>
           <a:p>
             <a:r>
-              <a:rPr lang="en-US" smtClean="0"/>
+              <a:rPr lang="en-US"/>
               <a:t>Click to edit Master title style</a:t>
             </a:r>
-            <a:endParaRPr lang="en-US"/>
           </a:p>
         </p:txBody>
       </p:sp>
@@ -593,38 +604,37 @@
           <a:p>
             <a:pPr lvl="0"/>
             <a:r>
-              <a:rPr lang="en-US" smtClean="0"/>
+              <a:rPr lang="en-US"/>
               <a:t>Click to edit Master text styles</a:t>
             </a:r>
           </a:p>
           <a:p>
             <a:pPr lvl="1"/>
             <a:r>
-              <a:rPr lang="en-US" smtClean="0"/>
+              <a:rPr lang="en-US"/>
               <a:t>Second level</a:t>
             </a:r>
           </a:p>
           <a:p>
             <a:pPr lvl="2"/>
             <a:r>
-              <a:rPr lang="en-US" smtClean="0"/>
+              <a:rPr lang="en-US"/>
               <a:t>Third level</a:t>
             </a:r>
           </a:p>
           <a:p>
             <a:pPr lvl="3"/>
             <a:r>
-              <a:rPr lang="en-US" smtClean="0"/>
+              <a:rPr lang="en-US"/>
               <a:t>Fourth level</a:t>
             </a:r>
           </a:p>
           <a:p>
             <a:pPr lvl="4"/>
             <a:r>
-              <a:rPr lang="en-US" smtClean="0"/>
+              <a:rPr lang="en-US"/>
               <a:t>Fifth level</a:t>
             </a:r>
-            <a:endParaRPr lang="en-US"/>
           </a:p>
         </p:txBody>
       </p:sp>
@@ -645,7 +655,7 @@
           <a:p>
             <a:fld id="{5BCAD085-E8A6-8845-BD4E-CB4CCA059FC4}" type="datetimeFigureOut">
               <a:rPr lang="en-US" smtClean="0"/>
-              <a:t>1/27/13</a:t>
+              <a:t>9/22/2026</a:t>
             </a:fld>
             <a:endParaRPr lang="en-US"/>
           </a:p>
@@ -739,10 +749,9 @@
           <a:lstStyle/>
           <a:p>
             <a:r>
-              <a:rPr lang="en-US" smtClean="0"/>
+              <a:rPr lang="en-US"/>
               <a:t>Click to edit Master title style</a:t>
             </a:r>
-            <a:endParaRPr lang="en-US"/>
           </a:p>
         </p:txBody>
       </p:sp>
@@ -763,38 +772,37 @@
           <a:p>
             <a:pPr lvl="0"/>
             <a:r>
-              <a:rPr lang="en-US" smtClean="0"/>
+              <a:rPr lang="en-US"/>
               <a:t>Click to edit Master text styles</a:t>
             </a:r>
           </a:p>
           <a:p>
             <a:pPr lvl="1"/>
             <a:r>
-              <a:rPr lang="en-US" smtClean="0"/>
+              <a:rPr lang="en-US"/>
               <a:t>Second level</a:t>
             </a:r>
           </a:p>
           <a:p>
             <a:pPr lvl="2"/>
             <a:r>
-              <a:rPr lang="en-US" smtClean="0"/>
+              <a:rPr lang="en-US"/>
               <a:t>Third level</a:t>
             </a:r>
           </a:p>
           <a:p>
             <a:pPr lvl="3"/>
             <a:r>
-              <a:rPr lang="en-US" smtClean="0"/>
+              <a:rPr lang="en-US"/>
               <a:t>Fourth level</a:t>
             </a:r>
           </a:p>
           <a:p>
             <a:pPr lvl="4"/>
             <a:r>
-              <a:rPr lang="en-US" smtClean="0"/>
+              <a:rPr lang="en-US"/>
               <a:t>Fifth level</a:t>
             </a:r>
-            <a:endParaRPr lang="en-US"/>
           </a:p>
         </p:txBody>
       </p:sp>
@@ -815,7 +823,7 @@
           <a:p>
             <a:fld id="{5BCAD085-E8A6-8845-BD4E-CB4CCA059FC4}" type="datetimeFigureOut">
               <a:rPr lang="en-US" smtClean="0"/>
-              <a:t>1/27/13</a:t>
+              <a:t>9/22/2026</a:t>
             </a:fld>
             <a:endParaRPr lang="en-US"/>
           </a:p>
@@ -918,10 +926,9 @@
           </a:lstStyle>
           <a:p>
             <a:r>
-              <a:rPr lang="en-US" smtClean="0"/>
+              <a:rPr lang="en-US"/>
               <a:t>Click to edit Master title style</a:t>
             </a:r>
-            <a:endParaRPr lang="en-US"/>
           </a:p>
         </p:txBody>
       </p:sp>
@@ -1038,7 +1045,7 @@
           <a:p>
             <a:pPr lvl="0"/>
             <a:r>
-              <a:rPr lang="en-US" smtClean="0"/>
+              <a:rPr lang="en-US"/>
               <a:t>Click to edit Master text styles</a:t>
             </a:r>
           </a:p>
@@ -1061,7 +1068,7 @@
           <a:p>
             <a:fld id="{5BCAD085-E8A6-8845-BD4E-CB4CCA059FC4}" type="datetimeFigureOut">
               <a:rPr lang="en-US" smtClean="0"/>
-              <a:t>1/27/13</a:t>
+              <a:t>9/22/2026</a:t>
             </a:fld>
             <a:endParaRPr lang="en-US"/>
           </a:p>
@@ -1155,10 +1162,9 @@
           <a:lstStyle/>
           <a:p>
             <a:r>
-              <a:rPr lang="en-US" smtClean="0"/>
+              <a:rPr lang="en-US"/>
               <a:t>Click to edit Master title style</a:t>
             </a:r>
-            <a:endParaRPr lang="en-US"/>
           </a:p>
         </p:txBody>
       </p:sp>
@@ -1212,38 +1218,37 @@
           <a:p>
             <a:pPr lvl="0"/>
             <a:r>
-              <a:rPr lang="en-US" smtClean="0"/>
+              <a:rPr lang="en-US"/>
               <a:t>Click to edit Master text styles</a:t>
             </a:r>
           </a:p>
           <a:p>
             <a:pPr lvl="1"/>
             <a:r>
-              <a:rPr lang="en-US" smtClean="0"/>
+              <a:rPr lang="en-US"/>
               <a:t>Second level</a:t>
             </a:r>
           </a:p>
           <a:p>
             <a:pPr lvl="2"/>
             <a:r>
-              <a:rPr lang="en-US" smtClean="0"/>
+              <a:rPr lang="en-US"/>
               <a:t>Third level</a:t>
             </a:r>
           </a:p>
           <a:p>
             <a:pPr lvl="3"/>
             <a:r>
-              <a:rPr lang="en-US" smtClean="0"/>
+              <a:rPr lang="en-US"/>
               <a:t>Fourth level</a:t>
             </a:r>
           </a:p>
           <a:p>
             <a:pPr lvl="4"/>
             <a:r>
-              <a:rPr lang="en-US" smtClean="0"/>
+              <a:rPr lang="en-US"/>
               <a:t>Fifth level</a:t>
             </a:r>
-            <a:endParaRPr lang="en-US"/>
           </a:p>
         </p:txBody>
       </p:sp>
@@ -1297,38 +1302,37 @@
           <a:p>
             <a:pPr lvl="0"/>
             <a:r>
-              <a:rPr lang="en-US" smtClean="0"/>
+              <a:rPr lang="en-US"/>
               <a:t>Click to edit Master text styles</a:t>
             </a:r>
           </a:p>
           <a:p>
             <a:pPr lvl="1"/>
             <a:r>
-              <a:rPr lang="en-US" smtClean="0"/>
+              <a:rPr lang="en-US"/>
               <a:t>Second level</a:t>
             </a:r>
           </a:p>
           <a:p>
             <a:pPr lvl="2"/>
             <a:r>
-              <a:rPr lang="en-US" smtClean="0"/>
+              <a:rPr lang="en-US"/>
               <a:t>Third level</a:t>
             </a:r>
           </a:p>
           <a:p>
             <a:pPr lvl="3"/>
             <a:r>
-              <a:rPr lang="en-US" smtClean="0"/>
+              <a:rPr lang="en-US"/>
               <a:t>Fourth level</a:t>
             </a:r>
           </a:p>
           <a:p>
             <a:pPr lvl="4"/>
             <a:r>
-              <a:rPr lang="en-US" smtClean="0"/>
+              <a:rPr lang="en-US"/>
               <a:t>Fifth level</a:t>
             </a:r>
-            <a:endParaRPr lang="en-US"/>
           </a:p>
         </p:txBody>
       </p:sp>
@@ -1349,7 +1353,7 @@
           <a:p>
             <a:fld id="{5BCAD085-E8A6-8845-BD4E-CB4CCA059FC4}" type="datetimeFigureOut">
               <a:rPr lang="en-US" smtClean="0"/>
-              <a:t>1/27/13</a:t>
+              <a:t>9/22/2026</a:t>
             </a:fld>
             <a:endParaRPr lang="en-US"/>
           </a:p>
@@ -1447,10 +1451,9 @@
           </a:lstStyle>
           <a:p>
             <a:r>
-              <a:rPr lang="en-US" smtClean="0"/>
+              <a:rPr lang="en-US"/>
               <a:t>Click to edit Master title style</a:t>
             </a:r>
-            <a:endParaRPr lang="en-US"/>
           </a:p>
         </p:txBody>
       </p:sp>
@@ -1513,7 +1516,7 @@
           <a:p>
             <a:pPr lvl="0"/>
             <a:r>
-              <a:rPr lang="en-US" smtClean="0"/>
+              <a:rPr lang="en-US"/>
               <a:t>Click to edit Master text styles</a:t>
             </a:r>
           </a:p>
@@ -1569,38 +1572,37 @@
           <a:p>
             <a:pPr lvl="0"/>
             <a:r>
-              <a:rPr lang="en-US" smtClean="0"/>
+              <a:rPr lang="en-US"/>
               <a:t>Click to edit Master text styles</a:t>
             </a:r>
           </a:p>
           <a:p>
             <a:pPr lvl="1"/>
             <a:r>
-              <a:rPr lang="en-US" smtClean="0"/>
+              <a:rPr lang="en-US"/>
               <a:t>Second level</a:t>
             </a:r>
           </a:p>
           <a:p>
             <a:pPr lvl="2"/>
             <a:r>
-              <a:rPr lang="en-US" smtClean="0"/>
+              <a:rPr lang="en-US"/>
               <a:t>Third level</a:t>
             </a:r>
           </a:p>
           <a:p>
             <a:pPr lvl="3"/>
             <a:r>
-              <a:rPr lang="en-US" smtClean="0"/>
+              <a:rPr lang="en-US"/>
               <a:t>Fourth level</a:t>
             </a:r>
           </a:p>
           <a:p>
             <a:pPr lvl="4"/>
             <a:r>
-              <a:rPr lang="en-US" smtClean="0"/>
+              <a:rPr lang="en-US"/>
               <a:t>Fifth level</a:t>
             </a:r>
-            <a:endParaRPr lang="en-US"/>
           </a:p>
         </p:txBody>
       </p:sp>
@@ -1663,7 +1665,7 @@
           <a:p>
             <a:pPr lvl="0"/>
             <a:r>
-              <a:rPr lang="en-US" smtClean="0"/>
+              <a:rPr lang="en-US"/>
               <a:t>Click to edit Master text styles</a:t>
             </a:r>
           </a:p>
@@ -1719,38 +1721,37 @@
           <a:p>
             <a:pPr lvl="0"/>
             <a:r>
-              <a:rPr lang="en-US" smtClean="0"/>
+              <a:rPr lang="en-US"/>
               <a:t>Click to edit Master text styles</a:t>
             </a:r>
           </a:p>
           <a:p>
             <a:pPr lvl="1"/>
             <a:r>
-              <a:rPr lang="en-US" smtClean="0"/>
+              <a:rPr lang="en-US"/>
               <a:t>Second level</a:t>
             </a:r>
           </a:p>
           <a:p>
             <a:pPr lvl="2"/>
             <a:r>
-              <a:rPr lang="en-US" smtClean="0"/>
+              <a:rPr lang="en-US"/>
               <a:t>Third level</a:t>
             </a:r>
           </a:p>
           <a:p>
             <a:pPr lvl="3"/>
             <a:r>
-              <a:rPr lang="en-US" smtClean="0"/>
+              <a:rPr lang="en-US"/>
               <a:t>Fourth level</a:t>
             </a:r>
           </a:p>
           <a:p>
             <a:pPr lvl="4"/>
             <a:r>
-              <a:rPr lang="en-US" smtClean="0"/>
+              <a:rPr lang="en-US"/>
               <a:t>Fifth level</a:t>
             </a:r>
-            <a:endParaRPr lang="en-US"/>
           </a:p>
         </p:txBody>
       </p:sp>
@@ -1771,7 +1772,7 @@
           <a:p>
             <a:fld id="{5BCAD085-E8A6-8845-BD4E-CB4CCA059FC4}" type="datetimeFigureOut">
               <a:rPr lang="en-US" smtClean="0"/>
-              <a:t>1/27/13</a:t>
+              <a:t>9/22/2026</a:t>
             </a:fld>
             <a:endParaRPr lang="en-US"/>
           </a:p>
@@ -1865,10 +1866,9 @@
           <a:lstStyle/>
           <a:p>
             <a:r>
-              <a:rPr lang="en-US" smtClean="0"/>
+              <a:rPr lang="en-US"/>
               <a:t>Click to edit Master title style</a:t>
             </a:r>
-            <a:endParaRPr lang="en-US"/>
           </a:p>
         </p:txBody>
       </p:sp>
@@ -1889,7 +1889,7 @@
           <a:p>
             <a:fld id="{5BCAD085-E8A6-8845-BD4E-CB4CCA059FC4}" type="datetimeFigureOut">
               <a:rPr lang="en-US" smtClean="0"/>
-              <a:t>1/27/13</a:t>
+              <a:t>9/22/2026</a:t>
             </a:fld>
             <a:endParaRPr lang="en-US"/>
           </a:p>
@@ -1984,7 +1984,7 @@
           <a:p>
             <a:fld id="{5BCAD085-E8A6-8845-BD4E-CB4CCA059FC4}" type="datetimeFigureOut">
               <a:rPr lang="en-US" smtClean="0"/>
-              <a:t>1/27/13</a:t>
+              <a:t>9/22/2026</a:t>
             </a:fld>
             <a:endParaRPr lang="en-US"/>
           </a:p>
@@ -2087,10 +2087,9 @@
           </a:lstStyle>
           <a:p>
             <a:r>
-              <a:rPr lang="en-US" smtClean="0"/>
+              <a:rPr lang="en-US"/>
               <a:t>Click to edit Master title style</a:t>
             </a:r>
-            <a:endParaRPr lang="en-US"/>
           </a:p>
         </p:txBody>
       </p:sp>
@@ -2144,38 +2143,37 @@
           <a:p>
             <a:pPr lvl="0"/>
             <a:r>
-              <a:rPr lang="en-US" smtClean="0"/>
+              <a:rPr lang="en-US"/>
               <a:t>Click to edit Master text styles</a:t>
             </a:r>
           </a:p>
           <a:p>
             <a:pPr lvl="1"/>
             <a:r>
-              <a:rPr lang="en-US" smtClean="0"/>
+              <a:rPr lang="en-US"/>
               <a:t>Second level</a:t>
             </a:r>
           </a:p>
           <a:p>
             <a:pPr lvl="2"/>
             <a:r>
-              <a:rPr lang="en-US" smtClean="0"/>
+              <a:rPr lang="en-US"/>
               <a:t>Third level</a:t>
             </a:r>
           </a:p>
           <a:p>
             <a:pPr lvl="3"/>
             <a:r>
-              <a:rPr lang="en-US" smtClean="0"/>
+              <a:rPr lang="en-US"/>
               <a:t>Fourth level</a:t>
             </a:r>
           </a:p>
           <a:p>
             <a:pPr lvl="4"/>
             <a:r>
-              <a:rPr lang="en-US" smtClean="0"/>
+              <a:rPr lang="en-US"/>
               <a:t>Fifth level</a:t>
             </a:r>
-            <a:endParaRPr lang="en-US"/>
           </a:p>
         </p:txBody>
       </p:sp>
@@ -2238,7 +2236,7 @@
           <a:p>
             <a:pPr lvl="0"/>
             <a:r>
-              <a:rPr lang="en-US" smtClean="0"/>
+              <a:rPr lang="en-US"/>
               <a:t>Click to edit Master text styles</a:t>
             </a:r>
           </a:p>
@@ -2261,7 +2259,7 @@
           <a:p>
             <a:fld id="{5BCAD085-E8A6-8845-BD4E-CB4CCA059FC4}" type="datetimeFigureOut">
               <a:rPr lang="en-US" smtClean="0"/>
-              <a:t>1/27/13</a:t>
+              <a:t>9/22/2026</a:t>
             </a:fld>
             <a:endParaRPr lang="en-US"/>
           </a:p>
@@ -2364,10 +2362,9 @@
           </a:lstStyle>
           <a:p>
             <a:r>
-              <a:rPr lang="en-US" smtClean="0"/>
+              <a:rPr lang="en-US"/>
               <a:t>Click to edit Master title style</a:t>
             </a:r>
-            <a:endParaRPr lang="en-US"/>
           </a:p>
         </p:txBody>
       </p:sp>
@@ -2491,7 +2488,7 @@
           <a:p>
             <a:pPr lvl="0"/>
             <a:r>
-              <a:rPr lang="en-US" smtClean="0"/>
+              <a:rPr lang="en-US"/>
               <a:t>Click to edit Master text styles</a:t>
             </a:r>
           </a:p>
@@ -2514,7 +2511,7 @@
           <a:p>
             <a:fld id="{5BCAD085-E8A6-8845-BD4E-CB4CCA059FC4}" type="datetimeFigureOut">
               <a:rPr lang="en-US" smtClean="0"/>
-              <a:t>1/27/13</a:t>
+              <a:t>9/22/2026</a:t>
             </a:fld>
             <a:endParaRPr lang="en-US"/>
           </a:p>
@@ -2623,10 +2620,9 @@
           <a:lstStyle/>
           <a:p>
             <a:r>
-              <a:rPr lang="en-US" smtClean="0"/>
+              <a:rPr lang="en-US"/>
               <a:t>Click to edit Master title style</a:t>
             </a:r>
-            <a:endParaRPr lang="en-US"/>
           </a:p>
         </p:txBody>
       </p:sp>
@@ -2657,38 +2653,37 @@
           <a:p>
             <a:pPr lvl="0"/>
             <a:r>
-              <a:rPr lang="en-US" smtClean="0"/>
+              <a:rPr lang="en-US"/>
               <a:t>Click to edit Master text styles</a:t>
             </a:r>
           </a:p>
           <a:p>
             <a:pPr lvl="1"/>
             <a:r>
-              <a:rPr lang="en-US" smtClean="0"/>
+              <a:rPr lang="en-US"/>
               <a:t>Second level</a:t>
             </a:r>
           </a:p>
           <a:p>
             <a:pPr lvl="2"/>
             <a:r>
-              <a:rPr lang="en-US" smtClean="0"/>
+              <a:rPr lang="en-US"/>
               <a:t>Third level</a:t>
             </a:r>
           </a:p>
           <a:p>
             <a:pPr lvl="3"/>
             <a:r>
-              <a:rPr lang="en-US" smtClean="0"/>
+              <a:rPr lang="en-US"/>
               <a:t>Fourth level</a:t>
             </a:r>
           </a:p>
           <a:p>
             <a:pPr lvl="4"/>
             <a:r>
-              <a:rPr lang="en-US" smtClean="0"/>
+              <a:rPr lang="en-US"/>
               <a:t>Fifth level</a:t>
             </a:r>
-            <a:endParaRPr lang="en-US"/>
           </a:p>
         </p:txBody>
       </p:sp>
@@ -2727,7 +2722,7 @@
           <a:p>
             <a:fld id="{5BCAD085-E8A6-8845-BD4E-CB4CCA059FC4}" type="datetimeFigureOut">
               <a:rPr lang="en-US" smtClean="0"/>
-              <a:t>1/27/13</a:t>
+              <a:t>9/22/2026</a:t>
             </a:fld>
             <a:endParaRPr lang="en-US"/>
           </a:p>
@@ -3086,7 +3081,7 @@
 </file>
 
 <file path=ppt/slides/slide1.xml><?xml version="1.0" encoding="utf-8"?>
-<p:sld xmlns:a="http://schemas.openxmlformats.org/drawingml/2006/main" xmlns:p="http://schemas.openxmlformats.org/presentationml/2006/main" xmlns:r="http://schemas.openxmlformats.org/officeDocument/2006/relationships">
+<p:sld xmlns:a="http://schemas.openxmlformats.org/drawingml/2006/main" xmlns:r="http://schemas.openxmlformats.org/officeDocument/2006/relationships" xmlns:p="http://schemas.openxmlformats.org/presentationml/2006/main">
   <p:cSld>
     <p:spTree>
       <p:nvGrpSpPr>
@@ -3094,7 +3089,14 @@
         <p:cNvGrpSpPr/>
         <p:nvPr/>
       </p:nvGrpSpPr>
-      <p:grpSpPr/>
+      <p:grpSpPr>
+        <a:xfrm>
+          <a:off x="0" y="0"/>
+          <a:ext cx="0" cy="0"/>
+          <a:chOff x="0" y="0"/>
+          <a:chExt cx="0" cy="0"/>
+        </a:xfrm>
+      </p:grpSpPr>
       <p:sp>
         <p:nvSpPr>
           <p:cNvPr id="2" name="Rectangle 1"/>
@@ -3135,6 +3137,7 @@
           <a:lstStyle/>
           <a:p>
             <a:pPr algn="ctr"/>
+            <a:endParaRPr/>
           </a:p>
         </p:txBody>
       </p:sp>
@@ -3209,7 +3212,7 @@
           <a:noFill/>
         </p:spPr>
         <p:txBody>
-          <a:bodyPr wrap="none" lIns="0" rIns="0" tIns="0" bIns="0">
+          <a:bodyPr wrap="none" lIns="0" tIns="0" rIns="0" bIns="0">
             <a:spAutoFit/>
           </a:bodyPr>
           <a:lstStyle/>
@@ -3280,7 +3283,7 @@
           </a:fontRef>
         </p:style>
         <p:txBody>
-          <a:bodyPr rtlCol="0" anchor="ctr" lIns="256032" tIns="201168"/>
+          <a:bodyPr lIns="256032" tIns="201168" rtlCol="0" anchor="ctr"/>
           <a:lstStyle/>
           <a:p>
             <a:pPr algn="ctr">
@@ -3334,7 +3337,7 @@
           </a:fontRef>
         </p:style>
         <p:txBody>
-          <a:bodyPr rtlCol="0" anchor="ctr" tIns="164592"/>
+          <a:bodyPr tIns="164592" rtlCol="0" anchor="ctr"/>
           <a:lstStyle/>
           <a:p>
             <a:pPr algn="ctr">
@@ -3400,7 +3403,7 @@
           </a:fontRef>
         </p:style>
         <p:txBody>
-          <a:bodyPr rtlCol="0" anchor="ctr" tIns="164592"/>
+          <a:bodyPr tIns="164592" rtlCol="0" anchor="ctr"/>
           <a:lstStyle/>
           <a:p>
             <a:pPr algn="ctr">
@@ -3466,7 +3469,7 @@
           </a:fontRef>
         </p:style>
         <p:txBody>
-          <a:bodyPr rtlCol="0" anchor="ctr" tIns="164592"/>
+          <a:bodyPr tIns="164592" rtlCol="0" anchor="ctr"/>
           <a:lstStyle/>
           <a:p>
             <a:pPr algn="ctr">
@@ -3532,7 +3535,7 @@
           </a:fontRef>
         </p:style>
         <p:txBody>
-          <a:bodyPr rtlCol="0" anchor="ctr" tIns="164592"/>
+          <a:bodyPr tIns="164592" rtlCol="0" anchor="ctr"/>
           <a:lstStyle/>
           <a:p>
             <a:pPr algn="ctr">
@@ -3602,6 +3605,7 @@
           <a:lstStyle/>
           <a:p>
             <a:pPr algn="ctr"/>
+            <a:endParaRPr/>
           </a:p>
         </p:txBody>
       </p:sp>
@@ -3621,8 +3625,8 @@
         </p:blipFill>
         <p:spPr>
           <a:xfrm>
-            <a:off x="6656832" y="896112"/>
-            <a:ext cx="4730191" cy="4425696"/>
+            <a:off x="6720839" y="1307592"/>
+            <a:ext cx="4602175" cy="3995928"/>
           </a:xfrm>
           <a:prstGeom prst="rect">
             <a:avLst/>
@@ -3646,7 +3650,7 @@
           <a:noFill/>
         </p:spPr>
         <p:txBody>
-          <a:bodyPr wrap="square" lIns="0" rIns="0" tIns="0" bIns="0">
+          <a:bodyPr wrap="square" lIns="0" tIns="0" rIns="0" bIns="0">
             <a:spAutoFit/>
           </a:bodyPr>
           <a:lstStyle/>
@@ -3688,7 +3692,7 @@
 </file>
 
 <file path=ppt/slides/slide2.xml><?xml version="1.0" encoding="utf-8"?>
-<p:sld xmlns:a="http://schemas.openxmlformats.org/drawingml/2006/main" xmlns:p="http://schemas.openxmlformats.org/presentationml/2006/main" xmlns:r="http://schemas.openxmlformats.org/officeDocument/2006/relationships">
+<p:sld xmlns:a="http://schemas.openxmlformats.org/drawingml/2006/main" xmlns:r="http://schemas.openxmlformats.org/officeDocument/2006/relationships" xmlns:p="http://schemas.openxmlformats.org/presentationml/2006/main">
   <p:cSld>
     <p:spTree>
       <p:nvGrpSpPr>
@@ -3696,7 +3700,14 @@
         <p:cNvGrpSpPr/>
         <p:nvPr/>
       </p:nvGrpSpPr>
-      <p:grpSpPr/>
+      <p:grpSpPr>
+        <a:xfrm>
+          <a:off x="0" y="0"/>
+          <a:ext cx="0" cy="0"/>
+          <a:chOff x="0" y="0"/>
+          <a:chExt cx="0" cy="0"/>
+        </a:xfrm>
+      </p:grpSpPr>
       <p:sp>
         <p:nvSpPr>
           <p:cNvPr id="2" name="Rectangle 1"/>
@@ -3737,6 +3748,7 @@
           <a:lstStyle/>
           <a:p>
             <a:pPr algn="ctr"/>
+            <a:endParaRPr/>
           </a:p>
         </p:txBody>
       </p:sp>
@@ -3757,7 +3769,7 @@
           <a:noFill/>
         </p:spPr>
         <p:txBody>
-          <a:bodyPr wrap="none" lIns="0" rIns="0" tIns="0" bIns="0">
+          <a:bodyPr wrap="none" lIns="0" tIns="0" rIns="0" bIns="0">
             <a:spAutoFit/>
           </a:bodyPr>
           <a:lstStyle/>
@@ -3792,7 +3804,7 @@
           <a:noFill/>
         </p:spPr>
         <p:txBody>
-          <a:bodyPr wrap="none" lIns="0" rIns="0" tIns="0" bIns="0">
+          <a:bodyPr wrap="none" lIns="0" tIns="0" rIns="0" bIns="0">
             <a:spAutoFit/>
           </a:bodyPr>
           <a:lstStyle/>
@@ -3827,7 +3839,7 @@
           <a:noFill/>
         </p:spPr>
         <p:txBody>
-          <a:bodyPr wrap="none" lIns="0" rIns="0" tIns="0" bIns="0">
+          <a:bodyPr wrap="none" lIns="0" tIns="0" rIns="0" bIns="0">
             <a:spAutoFit/>
           </a:bodyPr>
           <a:lstStyle/>
@@ -3853,7 +3865,7 @@
         </p:nvSpPr>
         <p:spPr>
           <a:xfrm>
-            <a:off x="731520" y="1783080"/>
+            <a:off x="658368" y="1819656"/>
             <a:ext cx="3931920" cy="4526280"/>
           </a:xfrm>
           <a:prstGeom prst="roundRect">
@@ -3887,6 +3899,7 @@
           <a:lstStyle/>
           <a:p>
             <a:pPr algn="ctr"/>
+            <a:endParaRPr/>
           </a:p>
         </p:txBody>
       </p:sp>
@@ -3906,8 +3919,8 @@
         </p:blipFill>
         <p:spPr>
           <a:xfrm>
-            <a:off x="804672" y="1856232"/>
-            <a:ext cx="3785616" cy="3602736"/>
+            <a:off x="795528" y="2213192"/>
+            <a:ext cx="3657600" cy="3168052"/>
           </a:xfrm>
           <a:prstGeom prst="rect">
             <a:avLst/>
@@ -3931,7 +3944,7 @@
           <a:noFill/>
         </p:spPr>
         <p:txBody>
-          <a:bodyPr wrap="square" lIns="0" rIns="0" tIns="0" bIns="0">
+          <a:bodyPr wrap="square" lIns="0" tIns="0" rIns="0" bIns="0">
             <a:spAutoFit/>
           </a:bodyPr>
           <a:lstStyle/>
@@ -4002,7 +4015,7 @@
           </a:fontRef>
         </p:style>
         <p:txBody>
-          <a:bodyPr rtlCol="0" anchor="ctr" wrap="square" lIns="219456" rIns="219456" tIns="182880" bIns="164592"/>
+          <a:bodyPr wrap="square" lIns="219456" tIns="182880" rIns="219456" bIns="164592" rtlCol="0" anchor="ctr"/>
           <a:lstStyle/>
           <a:p>
             <a:pPr algn="ctr">
@@ -4104,7 +4117,7 @@
           </a:fontRef>
         </p:style>
         <p:txBody>
-          <a:bodyPr rtlCol="0" anchor="ctr" wrap="square" lIns="219456" rIns="219456" tIns="182880" bIns="164592"/>
+          <a:bodyPr wrap="square" lIns="219456" tIns="182880" rIns="219456" bIns="164592" rtlCol="0" anchor="ctr"/>
           <a:lstStyle/>
           <a:p>
             <a:pPr algn="ctr">
@@ -4206,7 +4219,7 @@
           </a:fontRef>
         </p:style>
         <p:txBody>
-          <a:bodyPr rtlCol="0" anchor="ctr" wrap="square" lIns="219456" rIns="219456" tIns="182880" bIns="164592"/>
+          <a:bodyPr wrap="square" lIns="219456" tIns="182880" rIns="219456" bIns="164592" rtlCol="0" anchor="ctr"/>
           <a:lstStyle/>
           <a:p>
             <a:pPr algn="ctr">
@@ -4279,7 +4292,7 @@
 </file>
 
 <file path=ppt/slides/slide3.xml><?xml version="1.0" encoding="utf-8"?>
-<p:sld xmlns:a="http://schemas.openxmlformats.org/drawingml/2006/main" xmlns:p="http://schemas.openxmlformats.org/presentationml/2006/main" xmlns:r="http://schemas.openxmlformats.org/officeDocument/2006/relationships">
+<p:sld xmlns:a="http://schemas.openxmlformats.org/drawingml/2006/main" xmlns:r="http://schemas.openxmlformats.org/officeDocument/2006/relationships" xmlns:p="http://schemas.openxmlformats.org/presentationml/2006/main">
   <p:cSld>
     <p:spTree>
       <p:nvGrpSpPr>
@@ -4287,7 +4300,14 @@
         <p:cNvGrpSpPr/>
         <p:nvPr/>
       </p:nvGrpSpPr>
-      <p:grpSpPr/>
+      <p:grpSpPr>
+        <a:xfrm>
+          <a:off x="0" y="0"/>
+          <a:ext cx="0" cy="0"/>
+          <a:chOff x="0" y="0"/>
+          <a:chExt cx="0" cy="0"/>
+        </a:xfrm>
+      </p:grpSpPr>
       <p:sp>
         <p:nvSpPr>
           <p:cNvPr id="2" name="Rectangle 1"/>
@@ -4328,6 +4348,7 @@
           <a:lstStyle/>
           <a:p>
             <a:pPr algn="ctr"/>
+            <a:endParaRPr/>
           </a:p>
         </p:txBody>
       </p:sp>
@@ -4348,7 +4369,7 @@
           <a:noFill/>
         </p:spPr>
         <p:txBody>
-          <a:bodyPr wrap="none" lIns="0" rIns="0" tIns="0" bIns="0">
+          <a:bodyPr wrap="none" lIns="0" tIns="0" rIns="0" bIns="0">
             <a:spAutoFit/>
           </a:bodyPr>
           <a:lstStyle/>
@@ -4383,7 +4404,7 @@
           <a:noFill/>
         </p:spPr>
         <p:txBody>
-          <a:bodyPr wrap="none" lIns="0" rIns="0" tIns="0" bIns="0">
+          <a:bodyPr wrap="none" lIns="0" tIns="0" rIns="0" bIns="0">
             <a:spAutoFit/>
           </a:bodyPr>
           <a:lstStyle/>
@@ -4418,7 +4439,7 @@
           <a:noFill/>
         </p:spPr>
         <p:txBody>
-          <a:bodyPr wrap="none" lIns="0" rIns="0" tIns="0" bIns="0">
+          <a:bodyPr wrap="none" lIns="0" tIns="0" rIns="0" bIns="0">
             <a:spAutoFit/>
           </a:bodyPr>
           <a:lstStyle/>
@@ -4474,7 +4495,7 @@
           </a:fontRef>
         </p:style>
         <p:txBody>
-          <a:bodyPr rtlCol="0" anchor="ctr" wrap="square" lIns="219456" rIns="219456" tIns="182880" bIns="164592"/>
+          <a:bodyPr wrap="square" lIns="219456" tIns="182880" rIns="219456" bIns="164592" rtlCol="0" anchor="ctr"/>
           <a:lstStyle/>
           <a:p>
             <a:pPr algn="ctr">
@@ -4576,7 +4597,7 @@
           </a:fontRef>
         </p:style>
         <p:txBody>
-          <a:bodyPr rtlCol="0" anchor="ctr" wrap="square" lIns="219456" rIns="219456" tIns="182880" bIns="164592"/>
+          <a:bodyPr wrap="square" lIns="219456" tIns="182880" rIns="219456" bIns="164592" rtlCol="0" anchor="ctr"/>
           <a:lstStyle/>
           <a:p>
             <a:pPr algn="ctr">
@@ -4678,7 +4699,7 @@
           </a:fontRef>
         </p:style>
         <p:txBody>
-          <a:bodyPr rtlCol="0" anchor="ctr" wrap="square" lIns="219456" rIns="219456" tIns="182880" bIns="164592"/>
+          <a:bodyPr wrap="square" lIns="219456" tIns="182880" rIns="219456" bIns="164592" rtlCol="0" anchor="ctr"/>
           <a:lstStyle/>
           <a:p>
             <a:pPr algn="ctr">
@@ -4780,7 +4801,7 @@
           </a:fontRef>
         </p:style>
         <p:txBody>
-          <a:bodyPr rtlCol="0" anchor="ctr" wrap="square" lIns="219456" rIns="219456" tIns="182880" bIns="164592"/>
+          <a:bodyPr wrap="square" lIns="219456" tIns="182880" rIns="219456" bIns="164592" rtlCol="0" anchor="ctr"/>
           <a:lstStyle/>
           <a:p>
             <a:pPr algn="ctr">
@@ -4852,8 +4873,8 @@
         </p:nvSpPr>
         <p:spPr>
           <a:xfrm>
-            <a:off x="7406640" y="1783080"/>
-            <a:ext cx="4053535" cy="4526280"/>
+            <a:off x="7406640" y="1399032"/>
+            <a:ext cx="4053535" cy="4910328"/>
           </a:xfrm>
           <a:prstGeom prst="roundRect">
             <a:avLst/>
@@ -4886,6 +4907,7 @@
           <a:lstStyle/>
           <a:p>
             <a:pPr algn="ctr"/>
+            <a:endParaRPr/>
           </a:p>
         </p:txBody>
       </p:sp>
@@ -4930,7 +4952,7 @@
           <a:noFill/>
         </p:spPr>
         <p:txBody>
-          <a:bodyPr wrap="square" lIns="0" rIns="0" tIns="0" bIns="0">
+          <a:bodyPr wrap="square" lIns="0" tIns="0" rIns="0" bIns="0">
             <a:spAutoFit/>
           </a:bodyPr>
           <a:lstStyle/>
@@ -4972,7 +4994,7 @@
 </file>
 
 <file path=ppt/slides/slide4.xml><?xml version="1.0" encoding="utf-8"?>
-<p:sld xmlns:a="http://schemas.openxmlformats.org/drawingml/2006/main" xmlns:p="http://schemas.openxmlformats.org/presentationml/2006/main" xmlns:r="http://schemas.openxmlformats.org/officeDocument/2006/relationships">
+<p:sld xmlns:a="http://schemas.openxmlformats.org/drawingml/2006/main" xmlns:r="http://schemas.openxmlformats.org/officeDocument/2006/relationships" xmlns:p="http://schemas.openxmlformats.org/presentationml/2006/main">
   <p:cSld>
     <p:spTree>
       <p:nvGrpSpPr>
@@ -4980,7 +5002,14 @@
         <p:cNvGrpSpPr/>
         <p:nvPr/>
       </p:nvGrpSpPr>
-      <p:grpSpPr/>
+      <p:grpSpPr>
+        <a:xfrm>
+          <a:off x="0" y="0"/>
+          <a:ext cx="0" cy="0"/>
+          <a:chOff x="0" y="0"/>
+          <a:chExt cx="0" cy="0"/>
+        </a:xfrm>
+      </p:grpSpPr>
       <p:sp>
         <p:nvSpPr>
           <p:cNvPr id="2" name="Rectangle 1"/>
@@ -5021,6 +5050,7 @@
           <a:lstStyle/>
           <a:p>
             <a:pPr algn="ctr"/>
+            <a:endParaRPr/>
           </a:p>
         </p:txBody>
       </p:sp>
@@ -5041,7 +5071,7 @@
           <a:noFill/>
         </p:spPr>
         <p:txBody>
-          <a:bodyPr wrap="none" lIns="0" rIns="0" tIns="0" bIns="0">
+          <a:bodyPr wrap="none" lIns="0" tIns="0" rIns="0" bIns="0">
             <a:spAutoFit/>
           </a:bodyPr>
           <a:lstStyle/>
@@ -5076,7 +5106,7 @@
           <a:noFill/>
         </p:spPr>
         <p:txBody>
-          <a:bodyPr wrap="none" lIns="0" rIns="0" tIns="0" bIns="0">
+          <a:bodyPr wrap="none" lIns="0" tIns="0" rIns="0" bIns="0">
             <a:spAutoFit/>
           </a:bodyPr>
           <a:lstStyle/>
@@ -5111,7 +5141,7 @@
           <a:noFill/>
         </p:spPr>
         <p:txBody>
-          <a:bodyPr wrap="none" lIns="0" rIns="0" tIns="0" bIns="0">
+          <a:bodyPr wrap="none" lIns="0" tIns="0" rIns="0" bIns="0">
             <a:spAutoFit/>
           </a:bodyPr>
           <a:lstStyle/>
@@ -5167,7 +5197,7 @@
           </a:fontRef>
         </p:style>
         <p:txBody>
-          <a:bodyPr rtlCol="0" anchor="ctr" wrap="square" lIns="219456" rIns="219456" tIns="182880" bIns="164592"/>
+          <a:bodyPr wrap="square" lIns="219456" tIns="182880" rIns="219456" bIns="164592" rtlCol="0" anchor="ctr"/>
           <a:lstStyle/>
           <a:p>
             <a:pPr algn="ctr">
@@ -5269,7 +5299,7 @@
           </a:fontRef>
         </p:style>
         <p:txBody>
-          <a:bodyPr rtlCol="0" anchor="ctr" wrap="square" lIns="219456" rIns="219456" tIns="182880" bIns="164592"/>
+          <a:bodyPr wrap="square" lIns="219456" tIns="182880" rIns="219456" bIns="164592" rtlCol="0" anchor="ctr"/>
           <a:lstStyle/>
           <a:p>
             <a:pPr algn="ctr">
@@ -5371,7 +5401,7 @@
           </a:fontRef>
         </p:style>
         <p:txBody>
-          <a:bodyPr rtlCol="0" anchor="ctr" wrap="square" lIns="219456" rIns="219456" tIns="182880" bIns="164592"/>
+          <a:bodyPr wrap="square" lIns="219456" tIns="182880" rIns="219456" bIns="164592" rtlCol="0" anchor="ctr"/>
           <a:lstStyle/>
           <a:p>
             <a:pPr algn="ctr">
@@ -5473,7 +5503,7 @@
           </a:fontRef>
         </p:style>
         <p:txBody>
-          <a:bodyPr rtlCol="0" anchor="ctr" wrap="square" lIns="219456" rIns="219456" tIns="182880" bIns="164592"/>
+          <a:bodyPr wrap="square" lIns="219456" tIns="182880" rIns="219456" bIns="164592" rtlCol="0" anchor="ctr"/>
           <a:lstStyle/>
           <a:p>
             <a:pPr algn="ctr">
@@ -5546,7 +5576,7 @@
 </file>
 
 <file path=ppt/slides/slide5.xml><?xml version="1.0" encoding="utf-8"?>
-<p:sld xmlns:a="http://schemas.openxmlformats.org/drawingml/2006/main" xmlns:p="http://schemas.openxmlformats.org/presentationml/2006/main" xmlns:r="http://schemas.openxmlformats.org/officeDocument/2006/relationships">
+<p:sld xmlns:a="http://schemas.openxmlformats.org/drawingml/2006/main" xmlns:r="http://schemas.openxmlformats.org/officeDocument/2006/relationships" xmlns:p="http://schemas.openxmlformats.org/presentationml/2006/main">
   <p:cSld>
     <p:spTree>
       <p:nvGrpSpPr>
@@ -5554,7 +5584,14 @@
         <p:cNvGrpSpPr/>
         <p:nvPr/>
       </p:nvGrpSpPr>
-      <p:grpSpPr/>
+      <p:grpSpPr>
+        <a:xfrm>
+          <a:off x="0" y="0"/>
+          <a:ext cx="0" cy="0"/>
+          <a:chOff x="0" y="0"/>
+          <a:chExt cx="0" cy="0"/>
+        </a:xfrm>
+      </p:grpSpPr>
       <p:sp>
         <p:nvSpPr>
           <p:cNvPr id="2" name="Rectangle 1"/>
@@ -5595,6 +5632,7 @@
           <a:lstStyle/>
           <a:p>
             <a:pPr algn="ctr"/>
+            <a:endParaRPr/>
           </a:p>
         </p:txBody>
       </p:sp>
@@ -5615,7 +5653,7 @@
           <a:noFill/>
         </p:spPr>
         <p:txBody>
-          <a:bodyPr wrap="none" lIns="0" rIns="0" tIns="0" bIns="0">
+          <a:bodyPr wrap="none" lIns="0" tIns="0" rIns="0" bIns="0">
             <a:spAutoFit/>
           </a:bodyPr>
           <a:lstStyle/>
@@ -5650,7 +5688,7 @@
           <a:noFill/>
         </p:spPr>
         <p:txBody>
-          <a:bodyPr wrap="none" lIns="0" rIns="0" tIns="0" bIns="0">
+          <a:bodyPr wrap="none" lIns="0" tIns="0" rIns="0" bIns="0">
             <a:spAutoFit/>
           </a:bodyPr>
           <a:lstStyle/>
@@ -5685,7 +5723,7 @@
           <a:noFill/>
         </p:spPr>
         <p:txBody>
-          <a:bodyPr wrap="none" lIns="0" rIns="0" tIns="0" bIns="0">
+          <a:bodyPr wrap="none" lIns="0" tIns="0" rIns="0" bIns="0">
             <a:spAutoFit/>
           </a:bodyPr>
           <a:lstStyle/>
@@ -5741,7 +5779,7 @@
           </a:fontRef>
         </p:style>
         <p:txBody>
-          <a:bodyPr rtlCol="0" anchor="ctr" wrap="square" lIns="219456" rIns="219456" tIns="182880" bIns="164592"/>
+          <a:bodyPr wrap="square" lIns="219456" tIns="182880" rIns="219456" bIns="164592" rtlCol="0" anchor="ctr"/>
           <a:lstStyle/>
           <a:p>
             <a:pPr algn="ctr">
@@ -5843,7 +5881,7 @@
           </a:fontRef>
         </p:style>
         <p:txBody>
-          <a:bodyPr rtlCol="0" anchor="ctr" wrap="square" lIns="219456" rIns="219456" tIns="182880" bIns="164592"/>
+          <a:bodyPr wrap="square" lIns="219456" tIns="182880" rIns="219456" bIns="164592" rtlCol="0" anchor="ctr"/>
           <a:lstStyle/>
           <a:p>
             <a:pPr algn="ctr">
@@ -5945,7 +5983,7 @@
           </a:fontRef>
         </p:style>
         <p:txBody>
-          <a:bodyPr rtlCol="0" anchor="ctr" wrap="square" lIns="219456" rIns="219456" tIns="182880" bIns="164592"/>
+          <a:bodyPr wrap="square" lIns="219456" tIns="182880" rIns="219456" bIns="164592" rtlCol="0" anchor="ctr"/>
           <a:lstStyle/>
           <a:p>
             <a:pPr algn="ctr">
@@ -6047,7 +6085,7 @@
           </a:fontRef>
         </p:style>
         <p:txBody>
-          <a:bodyPr rtlCol="0" anchor="ctr" lIns="320040" tIns="182880"/>
+          <a:bodyPr lIns="320040" tIns="182880" rtlCol="0" anchor="ctr"/>
           <a:lstStyle/>
           <a:p>
             <a:pPr algn="ctr">
@@ -6111,7 +6149,7 @@
 </file>
 
 <file path=ppt/slides/slide6.xml><?xml version="1.0" encoding="utf-8"?>
-<p:sld xmlns:a="http://schemas.openxmlformats.org/drawingml/2006/main" xmlns:p="http://schemas.openxmlformats.org/presentationml/2006/main" xmlns:r="http://schemas.openxmlformats.org/officeDocument/2006/relationships">
+<p:sld xmlns:a="http://schemas.openxmlformats.org/drawingml/2006/main" xmlns:r="http://schemas.openxmlformats.org/officeDocument/2006/relationships" xmlns:p="http://schemas.openxmlformats.org/presentationml/2006/main">
   <p:cSld>
     <p:spTree>
       <p:nvGrpSpPr>
@@ -6119,7 +6157,14 @@
         <p:cNvGrpSpPr/>
         <p:nvPr/>
       </p:nvGrpSpPr>
-      <p:grpSpPr/>
+      <p:grpSpPr>
+        <a:xfrm>
+          <a:off x="0" y="0"/>
+          <a:ext cx="0" cy="0"/>
+          <a:chOff x="0" y="0"/>
+          <a:chExt cx="0" cy="0"/>
+        </a:xfrm>
+      </p:grpSpPr>
       <p:sp>
         <p:nvSpPr>
           <p:cNvPr id="2" name="Rectangle 1"/>
@@ -6160,6 +6205,7 @@
           <a:lstStyle/>
           <a:p>
             <a:pPr algn="ctr"/>
+            <a:endParaRPr/>
           </a:p>
         </p:txBody>
       </p:sp>
@@ -6180,7 +6226,7 @@
           <a:noFill/>
         </p:spPr>
         <p:txBody>
-          <a:bodyPr wrap="none" lIns="0" rIns="0" tIns="0" bIns="0">
+          <a:bodyPr wrap="none" lIns="0" tIns="0" rIns="0" bIns="0">
             <a:spAutoFit/>
           </a:bodyPr>
           <a:lstStyle/>
@@ -6215,7 +6261,7 @@
           <a:noFill/>
         </p:spPr>
         <p:txBody>
-          <a:bodyPr wrap="none" lIns="0" rIns="0" tIns="0" bIns="0">
+          <a:bodyPr wrap="none" lIns="0" tIns="0" rIns="0" bIns="0">
             <a:spAutoFit/>
           </a:bodyPr>
           <a:lstStyle/>
@@ -6250,7 +6296,7 @@
           <a:noFill/>
         </p:spPr>
         <p:txBody>
-          <a:bodyPr wrap="none" lIns="0" rIns="0" tIns="0" bIns="0">
+          <a:bodyPr wrap="none" lIns="0" tIns="0" rIns="0" bIns="0">
             <a:spAutoFit/>
           </a:bodyPr>
           <a:lstStyle/>
@@ -6306,7 +6352,7 @@
           </a:fontRef>
         </p:style>
         <p:txBody>
-          <a:bodyPr rtlCol="0" anchor="ctr" lIns="182880" tIns="109728"/>
+          <a:bodyPr lIns="182880" tIns="109728" rtlCol="0" anchor="ctr"/>
           <a:lstStyle/>
           <a:p>
             <a:pPr algn="ctr">
@@ -6372,7 +6418,7 @@
           </a:fontRef>
         </p:style>
         <p:txBody>
-          <a:bodyPr rtlCol="0" anchor="ctr" lIns="182880" tIns="109728"/>
+          <a:bodyPr lIns="182880" tIns="109728" rtlCol="0" anchor="ctr"/>
           <a:lstStyle/>
           <a:p>
             <a:pPr algn="ctr">
@@ -6438,7 +6484,7 @@
           </a:fontRef>
         </p:style>
         <p:txBody>
-          <a:bodyPr rtlCol="0" anchor="ctr" lIns="182880" tIns="109728"/>
+          <a:bodyPr lIns="182880" tIns="109728" rtlCol="0" anchor="ctr"/>
           <a:lstStyle/>
           <a:p>
             <a:pPr algn="ctr">
@@ -6504,7 +6550,7 @@
           </a:fontRef>
         </p:style>
         <p:txBody>
-          <a:bodyPr rtlCol="0" anchor="ctr" lIns="182880" tIns="109728"/>
+          <a:bodyPr lIns="182880" tIns="109728" rtlCol="0" anchor="ctr"/>
           <a:lstStyle/>
           <a:p>
             <a:pPr algn="ctr">
@@ -6570,7 +6616,7 @@
           </a:fontRef>
         </p:style>
         <p:txBody>
-          <a:bodyPr rtlCol="0" anchor="ctr" lIns="182880" tIns="109728"/>
+          <a:bodyPr lIns="182880" tIns="109728" rtlCol="0" anchor="ctr"/>
           <a:lstStyle/>
           <a:p>
             <a:pPr algn="ctr">
@@ -6606,8 +6652,8 @@
         </p:nvSpPr>
         <p:spPr>
           <a:xfrm>
-            <a:off x="7315200" y="1783080"/>
-            <a:ext cx="4144975" cy="4434840"/>
+            <a:off x="7315200" y="1366684"/>
+            <a:ext cx="4144975" cy="4851236"/>
           </a:xfrm>
           <a:prstGeom prst="roundRect">
             <a:avLst/>
@@ -6640,6 +6686,7 @@
           <a:lstStyle/>
           <a:p>
             <a:pPr algn="ctr"/>
+            <a:endParaRPr/>
           </a:p>
         </p:txBody>
       </p:sp>
@@ -6684,7 +6731,7 @@
           <a:noFill/>
         </p:spPr>
         <p:txBody>
-          <a:bodyPr wrap="square" lIns="0" rIns="0" tIns="0" bIns="0">
+          <a:bodyPr wrap="square" lIns="0" tIns="0" rIns="0" bIns="0">
             <a:spAutoFit/>
           </a:bodyPr>
           <a:lstStyle/>
@@ -6726,7 +6773,7 @@
 </file>
 
 <file path=ppt/slides/slide7.xml><?xml version="1.0" encoding="utf-8"?>
-<p:sld xmlns:a="http://schemas.openxmlformats.org/drawingml/2006/main" xmlns:p="http://schemas.openxmlformats.org/presentationml/2006/main" xmlns:r="http://schemas.openxmlformats.org/officeDocument/2006/relationships">
+<p:sld xmlns:a="http://schemas.openxmlformats.org/drawingml/2006/main" xmlns:r="http://schemas.openxmlformats.org/officeDocument/2006/relationships" xmlns:p="http://schemas.openxmlformats.org/presentationml/2006/main">
   <p:cSld>
     <p:spTree>
       <p:nvGrpSpPr>
@@ -6734,7 +6781,14 @@
         <p:cNvGrpSpPr/>
         <p:nvPr/>
       </p:nvGrpSpPr>
-      <p:grpSpPr/>
+      <p:grpSpPr>
+        <a:xfrm>
+          <a:off x="0" y="0"/>
+          <a:ext cx="0" cy="0"/>
+          <a:chOff x="0" y="0"/>
+          <a:chExt cx="0" cy="0"/>
+        </a:xfrm>
+      </p:grpSpPr>
       <p:sp>
         <p:nvSpPr>
           <p:cNvPr id="2" name="Rectangle 1"/>
@@ -6775,6 +6829,7 @@
           <a:lstStyle/>
           <a:p>
             <a:pPr algn="ctr"/>
+            <a:endParaRPr/>
           </a:p>
         </p:txBody>
       </p:sp>
@@ -6795,7 +6850,7 @@
           <a:noFill/>
         </p:spPr>
         <p:txBody>
-          <a:bodyPr wrap="none" lIns="0" rIns="0" tIns="0" bIns="0">
+          <a:bodyPr wrap="none" lIns="0" tIns="0" rIns="0" bIns="0">
             <a:spAutoFit/>
           </a:bodyPr>
           <a:lstStyle/>
@@ -6830,7 +6885,7 @@
           <a:noFill/>
         </p:spPr>
         <p:txBody>
-          <a:bodyPr wrap="none" lIns="0" rIns="0" tIns="0" bIns="0">
+          <a:bodyPr wrap="none" lIns="0" tIns="0" rIns="0" bIns="0">
             <a:spAutoFit/>
           </a:bodyPr>
           <a:lstStyle/>
@@ -6865,7 +6920,7 @@
           <a:noFill/>
         </p:spPr>
         <p:txBody>
-          <a:bodyPr wrap="none" lIns="0" rIns="0" tIns="0" bIns="0">
+          <a:bodyPr wrap="none" lIns="0" tIns="0" rIns="0" bIns="0">
             <a:spAutoFit/>
           </a:bodyPr>
           <a:lstStyle/>
@@ -6891,8 +6946,8 @@
         </p:nvSpPr>
         <p:spPr>
           <a:xfrm>
-            <a:off x="731520" y="1783080"/>
-            <a:ext cx="3931920" cy="4526280"/>
+            <a:off x="550605" y="1527048"/>
+            <a:ext cx="4277033" cy="4782312"/>
           </a:xfrm>
           <a:prstGeom prst="roundRect">
             <a:avLst/>
@@ -6925,6 +6980,7 @@
           <a:lstStyle/>
           <a:p>
             <a:pPr algn="ctr"/>
+            <a:endParaRPr/>
           </a:p>
         </p:txBody>
       </p:sp>
@@ -6969,7 +7025,7 @@
           <a:noFill/>
         </p:spPr>
         <p:txBody>
-          <a:bodyPr wrap="square" lIns="0" rIns="0" tIns="0" bIns="0">
+          <a:bodyPr wrap="square" lIns="0" tIns="0" rIns="0" bIns="0">
             <a:spAutoFit/>
           </a:bodyPr>
           <a:lstStyle/>
@@ -7040,7 +7096,7 @@
           </a:fontRef>
         </p:style>
         <p:txBody>
-          <a:bodyPr rtlCol="0" anchor="ctr" wrap="square" lIns="219456" rIns="219456" tIns="182880" bIns="164592"/>
+          <a:bodyPr wrap="square" lIns="219456" tIns="182880" rIns="219456" bIns="164592" rtlCol="0" anchor="ctr"/>
           <a:lstStyle/>
           <a:p>
             <a:pPr algn="ctr">
@@ -7142,7 +7198,7 @@
           </a:fontRef>
         </p:style>
         <p:txBody>
-          <a:bodyPr rtlCol="0" anchor="ctr" wrap="square" lIns="219456" rIns="219456" tIns="182880" bIns="164592"/>
+          <a:bodyPr wrap="square" lIns="219456" tIns="182880" rIns="219456" bIns="164592" rtlCol="0" anchor="ctr"/>
           <a:lstStyle/>
           <a:p>
             <a:pPr algn="ctr">
@@ -7244,7 +7300,7 @@
           </a:fontRef>
         </p:style>
         <p:txBody>
-          <a:bodyPr rtlCol="0" anchor="ctr" wrap="square" lIns="219456" rIns="219456" tIns="182880" bIns="164592"/>
+          <a:bodyPr wrap="square" lIns="219456" tIns="182880" rIns="219456" bIns="164592" rtlCol="0" anchor="ctr"/>
           <a:lstStyle/>
           <a:p>
             <a:pPr algn="ctr">
@@ -7317,7 +7373,7 @@
 </file>
 
 <file path=ppt/slides/slide8.xml><?xml version="1.0" encoding="utf-8"?>
-<p:sld xmlns:a="http://schemas.openxmlformats.org/drawingml/2006/main" xmlns:p="http://schemas.openxmlformats.org/presentationml/2006/main" xmlns:r="http://schemas.openxmlformats.org/officeDocument/2006/relationships">
+<p:sld xmlns:a="http://schemas.openxmlformats.org/drawingml/2006/main" xmlns:r="http://schemas.openxmlformats.org/officeDocument/2006/relationships" xmlns:p="http://schemas.openxmlformats.org/presentationml/2006/main">
   <p:cSld>
     <p:spTree>
       <p:nvGrpSpPr>
@@ -7325,7 +7381,14 @@
         <p:cNvGrpSpPr/>
         <p:nvPr/>
       </p:nvGrpSpPr>
-      <p:grpSpPr/>
+      <p:grpSpPr>
+        <a:xfrm>
+          <a:off x="0" y="0"/>
+          <a:ext cx="0" cy="0"/>
+          <a:chOff x="0" y="0"/>
+          <a:chExt cx="0" cy="0"/>
+        </a:xfrm>
+      </p:grpSpPr>
       <p:sp>
         <p:nvSpPr>
           <p:cNvPr id="2" name="Rectangle 1"/>
@@ -7366,6 +7429,7 @@
           <a:lstStyle/>
           <a:p>
             <a:pPr algn="ctr"/>
+            <a:endParaRPr/>
           </a:p>
         </p:txBody>
       </p:sp>
@@ -7440,7 +7504,7 @@
           <a:noFill/>
         </p:spPr>
         <p:txBody>
-          <a:bodyPr wrap="none" lIns="0" rIns="0" tIns="0" bIns="0">
+          <a:bodyPr wrap="none" lIns="0" tIns="0" rIns="0" bIns="0">
             <a:spAutoFit/>
           </a:bodyPr>
           <a:lstStyle/>
@@ -7508,7 +7572,7 @@
           </a:fontRef>
         </p:style>
         <p:txBody>
-          <a:bodyPr rtlCol="0" anchor="ctr" lIns="274320" tIns="228600"/>
+          <a:bodyPr lIns="274320" tIns="228600" rtlCol="0" anchor="ctr"/>
           <a:lstStyle/>
           <a:p>
             <a:pPr algn="ctr">
@@ -7566,7 +7630,7 @@
           </a:fontRef>
         </p:style>
         <p:txBody>
-          <a:bodyPr rtlCol="0" anchor="ctr" lIns="256032" tIns="164592"/>
+          <a:bodyPr lIns="256032" tIns="164592" rtlCol="0" anchor="ctr"/>
           <a:lstStyle/>
           <a:p>
             <a:pPr algn="ctr">
@@ -7632,8 +7696,8 @@
         </p:nvSpPr>
         <p:spPr>
           <a:xfrm>
-            <a:off x="6583680" y="1005840"/>
-            <a:ext cx="4876495" cy="5120640"/>
+            <a:off x="6583680" y="432619"/>
+            <a:ext cx="4876495" cy="5693861"/>
           </a:xfrm>
           <a:prstGeom prst="roundRect">
             <a:avLst/>
@@ -7666,6 +7730,7 @@
           <a:lstStyle/>
           <a:p>
             <a:pPr algn="ctr"/>
+            <a:endParaRPr/>
           </a:p>
         </p:txBody>
       </p:sp>
@@ -7710,7 +7775,7 @@
           <a:noFill/>
         </p:spPr>
         <p:txBody>
-          <a:bodyPr wrap="square" lIns="0" rIns="0" tIns="0" bIns="0">
+          <a:bodyPr wrap="square" lIns="0" tIns="0" rIns="0" bIns="0">
             <a:spAutoFit/>
           </a:bodyPr>
           <a:lstStyle/>

</xml_diff>